<commit_message>
Align course prompts, memory exercises and slides for Module 2 lesson
</commit_message>
<xml_diff>
--- a/virtual_human_course/Module_2/Chapter_01/Slides/Module_2_Chapter_01_Agentic_Frameworks_and_LangGraph_Introduction.pptx
+++ b/virtual_human_course/Module_2/Chapter_01/Slides/Module_2_Chapter_01_Agentic_Frameworks_and_LangGraph_Introduction.pptx
@@ -2,32 +2,32 @@
 <file path=ppt/presentation.xml><?xml version="1.0" encoding="utf-8"?>
 <ns0:presentation xmlns:ns0="http://schemas.openxmlformats.org/presentationml/2006/main" xmlns:ns1="http://schemas.openxmlformats.org/officeDocument/2006/relationships">
   <ns0:sldMasterIdLst>
-    <ns0:sldMasterId id="2147483648" ns1:id="Re37389d152584682"/>
+    <ns0:sldMasterId id="2147483648" ns1:id="Re79887d572d84e66"/>
   </ns0:sldMasterIdLst>
   <ns0:sldIdLst>
-    <ns0:sldId id="256" ns1:id="R2e186e7aa3b744c1"/>
-    <ns0:sldId id="257" ns1:id="R9d519cf2d36b407b"/>
-    <ns0:sldId id="258" ns1:id="Rcaf46cf4818f4982"/>
-    <ns0:sldId id="259" ns1:id="Re3164cb686604831"/>
-    <ns0:sldId id="260" ns1:id="Racd3d466be4a4a8f"/>
-    <ns0:sldId id="261" ns1:id="R59af3cccaa9743c9"/>
-    <ns0:sldId id="262" ns1:id="R73d4be00f8124964"/>
-    <ns0:sldId id="263" ns1:id="Rac3d92444e004b1d"/>
-    <ns0:sldId id="264" ns1:id="R0f1bc4f994a544e6"/>
-    <ns0:sldId id="265" ns1:id="R50894c3969164361"/>
-    <ns0:sldId id="266" ns1:id="R6cb9a85c926845a5"/>
-    <ns0:sldId id="267" ns1:id="R02b9662e0a1c4f92"/>
-    <ns0:sldId id="268" ns1:id="R85dad10031ba4401"/>
-    <ns0:sldId id="269" ns1:id="R02d8199850674d58"/>
-    <ns0:sldId id="270" ns1:id="R24e685cee9434704"/>
-    <ns0:sldId id="271" ns1:id="R2276e6eefa094f20"/>
-    <ns0:sldId id="272" ns1:id="Rea2040ea4ca747e3"/>
-    <ns0:sldId id="273" ns1:id="Rbe8ab4dec0474f05"/>
-    <ns0:sldId id="274" ns1:id="R3e465975303b4d7a"/>
-    <ns0:sldId id="275" ns1:id="R2be8c98e1008441a"/>
-    <ns0:sldId id="276" ns1:id="Re4b343439408460c"/>
-    <ns0:sldId id="277" ns1:id="Reb413adbbee6469e"/>
-    <ns0:sldId id="278" ns1:id="R2a609491724642e1"/>
+    <ns0:sldId id="256" ns1:id="R911b3cfcf2ff45b3"/>
+    <ns0:sldId id="257" ns1:id="R1d8db4598fbc4473"/>
+    <ns0:sldId id="258" ns1:id="R24203d3d55b143d6"/>
+    <ns0:sldId id="259" ns1:id="R2922fd9a5fcc45e1"/>
+    <ns0:sldId id="260" ns1:id="R057848462b324365"/>
+    <ns0:sldId id="261" ns1:id="Ra04a8fb1b5094a54"/>
+    <ns0:sldId id="262" ns1:id="Rbb20455e210a461a"/>
+    <ns0:sldId id="263" ns1:id="Rcf029ede92b7441b"/>
+    <ns0:sldId id="264" ns1:id="R2367db55e2624396"/>
+    <ns0:sldId id="265" ns1:id="Reafd178f00a84aeb"/>
+    <ns0:sldId id="266" ns1:id="R4a5d7f4c21204cbd"/>
+    <ns0:sldId id="267" ns1:id="Rf6ccaf8447454eed"/>
+    <ns0:sldId id="268" ns1:id="R20a0224f73474415"/>
+    <ns0:sldId id="269" ns1:id="R83c708757ac0435a"/>
+    <ns0:sldId id="270" ns1:id="Rd4390a12ddb04d29"/>
+    <ns0:sldId id="271" ns1:id="R76d0f6f180e54705"/>
+    <ns0:sldId id="272" ns1:id="R23a2e50dd0eb44d1"/>
+    <ns0:sldId id="273" ns1:id="R5173e7948a8140f8"/>
+    <ns0:sldId id="274" ns1:id="R73bccae86f5c47a2"/>
+    <ns0:sldId id="275" ns1:id="Rb450481053c14c84"/>
+    <ns0:sldId id="276" ns1:id="R9af51ab79a994c4a"/>
+    <ns0:sldId id="277" ns1:id="R59db78627d274115"/>
+    <ns0:sldId id="278" ns1:id="R2ca98dff4db14139"/>
   </ns0:sldIdLst>
   <ns0:sldSz cx="9144000" cy="5143500"/>
   <ns0:notesSz cx="6858000" cy="9144000"/>
@@ -84,7 +84,7 @@
           <p:nvPr/>
         </p:nvPicPr>
         <p:blipFill>
-          <a:blip xmlns:r="http://schemas.openxmlformats.org/officeDocument/2006/relationships" xmlns:a="http://schemas.openxmlformats.org/drawingml/2006/main" r:embed="Reac4a647453948ac"/>
+          <a:blip xmlns:r="http://schemas.openxmlformats.org/officeDocument/2006/relationships" xmlns:a="http://schemas.openxmlformats.org/drawingml/2006/main" r:embed="Rcd1ff338fc5a4a9b"/>
           <a:srcRect xmlns:a="http://schemas.openxmlformats.org/drawingml/2006/main" l="0" t="0" r="0" b="0"/>
           <a:stretch xmlns:a="http://schemas.openxmlformats.org/drawingml/2006/main"/>
         </p:blipFill>
@@ -229,7 +229,7 @@
           <p:nvPr/>
         </p:nvPicPr>
         <p:blipFill>
-          <a:blip xmlns:r="http://schemas.openxmlformats.org/officeDocument/2006/relationships" xmlns:a="http://schemas.openxmlformats.org/drawingml/2006/main" r:embed="Rdd1c2821b1b04950"/>
+          <a:blip xmlns:r="http://schemas.openxmlformats.org/officeDocument/2006/relationships" xmlns:a="http://schemas.openxmlformats.org/drawingml/2006/main" r:embed="Rc0d5066f0ef34dce"/>
           <a:srcRect xmlns:a="http://schemas.openxmlformats.org/drawingml/2006/main" l="0" t="0" r="0" b="0"/>
           <a:stretch xmlns:a="http://schemas.openxmlformats.org/drawingml/2006/main"/>
         </p:blipFill>
@@ -1166,14 +1166,14 @@
   </p:cSld>
   <p:clrMap bg1="lt1" tx1="dk1" bg2="lt2" tx2="dk2" accent1="accent1" accent2="accent2" accent3="accent3" accent4="accent4" accent5="accent5" accent6="accent6" hlink="hlink" folHlink="folHlink"/>
   <p:sldLayoutIdLst>
-    <p:sldLayoutId xmlns:r="http://schemas.openxmlformats.org/officeDocument/2006/relationships" id="2147483649" r:id="Rd65aa42736884250"/>
-    <p:sldLayoutId xmlns:r="http://schemas.openxmlformats.org/officeDocument/2006/relationships" id="2147483650" r:id="R821a24ace92c4720"/>
-    <p:sldLayoutId xmlns:r="http://schemas.openxmlformats.org/officeDocument/2006/relationships" id="2147483651" r:id="R2aaa6c1d81704169"/>
-    <p:sldLayoutId xmlns:r="http://schemas.openxmlformats.org/officeDocument/2006/relationships" id="2147483652" r:id="R56bb49b8ff6b4b4e"/>
-    <p:sldLayoutId xmlns:r="http://schemas.openxmlformats.org/officeDocument/2006/relationships" id="2147483653" r:id="Rfdc4eacbd6b142e1"/>
-    <p:sldLayoutId xmlns:r="http://schemas.openxmlformats.org/officeDocument/2006/relationships" id="2147483654" r:id="R8f1fe7927d4243a6"/>
-    <p:sldLayoutId xmlns:r="http://schemas.openxmlformats.org/officeDocument/2006/relationships" id="2147483655" r:id="R25e97a7693064d59"/>
-    <p:sldLayoutId xmlns:r="http://schemas.openxmlformats.org/officeDocument/2006/relationships" id="2147483656" r:id="R007b33deadac4003"/>
+    <p:sldLayoutId xmlns:r="http://schemas.openxmlformats.org/officeDocument/2006/relationships" id="2147483649" r:id="R5885d5614dee4fa3"/>
+    <p:sldLayoutId xmlns:r="http://schemas.openxmlformats.org/officeDocument/2006/relationships" id="2147483650" r:id="Rf2d3458f74e44ad1"/>
+    <p:sldLayoutId xmlns:r="http://schemas.openxmlformats.org/officeDocument/2006/relationships" id="2147483651" r:id="R971dead5ca9b403d"/>
+    <p:sldLayoutId xmlns:r="http://schemas.openxmlformats.org/officeDocument/2006/relationships" id="2147483652" r:id="R2c3af0b2d002496b"/>
+    <p:sldLayoutId xmlns:r="http://schemas.openxmlformats.org/officeDocument/2006/relationships" id="2147483653" r:id="R595f59f61b394037"/>
+    <p:sldLayoutId xmlns:r="http://schemas.openxmlformats.org/officeDocument/2006/relationships" id="2147483654" r:id="Rf04c8b5c0d494995"/>
+    <p:sldLayoutId xmlns:r="http://schemas.openxmlformats.org/officeDocument/2006/relationships" id="2147483655" r:id="R72b2eca4003c458f"/>
+    <p:sldLayoutId xmlns:r="http://schemas.openxmlformats.org/officeDocument/2006/relationships" id="2147483656" r:id="Rcb4d3fe5b35e40b6"/>
   </p:sldLayoutIdLst>
   <p:hf sldNum="0" hdr="0" ftr="0" dt="0"/>
   <p:txStyles>
@@ -1839,7 +1839,7 @@
           <p:nvPr/>
         </p:nvPicPr>
         <p:blipFill>
-          <a:blip xmlns:r="http://schemas.openxmlformats.org/officeDocument/2006/relationships" xmlns:a="http://schemas.openxmlformats.org/drawingml/2006/main" r:embed="Ra56662980e7a4ccb"/>
+          <a:blip xmlns:r="http://schemas.openxmlformats.org/officeDocument/2006/relationships" xmlns:a="http://schemas.openxmlformats.org/drawingml/2006/main" r:embed="Rf401662c45bd47ff"/>
           <a:srcRect xmlns:a="http://schemas.openxmlformats.org/drawingml/2006/main" l="0" t="27" r="0" b="27"/>
           <a:stretch xmlns:a="http://schemas.openxmlformats.org/drawingml/2006/main">
             <a:fillRect l="0" t="0" r="0" b="0"/>
@@ -2638,7 +2638,7 @@
           <p:cNvPr id="53" name="c3-text-378">
             <a:extLst xmlns:a="http://schemas.openxmlformats.org/drawingml/2006/main">
               <a:ext uri="{FF2B5EF4-FFF2-40B4-BE49-F238E27FC236}">
-                <a16:creationId xmlns:a16="http://schemas.microsoft.com/office/drawing/2014/main" id="{A25F2454-673E-432A-9CA7-2B12B12DF1EA}"/>
+                <a16:creationId xmlns:a16="http://schemas.microsoft.com/office/drawing/2014/main" id="{9F36D462-7F58-4A65-BB10-9A4258F733D3}"/>
               </a:ext>
             </a:extLst>
           </p:cNvPr>
@@ -2724,7 +2724,7 @@
           <p:cNvPr id="11" name="c3-text-155">
             <a:extLst xmlns:a="http://schemas.openxmlformats.org/drawingml/2006/main">
               <a:ext uri="{FF2B5EF4-FFF2-40B4-BE49-F238E27FC236}">
-                <a16:creationId xmlns:a16="http://schemas.microsoft.com/office/drawing/2014/main" id="{FFF177C8-7CC3-46DA-B062-132CA132CE99}"/>
+                <a16:creationId xmlns:a16="http://schemas.microsoft.com/office/drawing/2014/main" id="{3F59E780-8105-441B-A32E-A6C170E0E3AD}"/>
               </a:ext>
             </a:extLst>
           </p:cNvPr>
@@ -2781,7 +2781,7 @@
           <p:cNvPr id="2" name="c3-text-156">
             <a:extLst xmlns:a="http://schemas.openxmlformats.org/drawingml/2006/main">
               <a:ext uri="{FF2B5EF4-FFF2-40B4-BE49-F238E27FC236}">
-                <a16:creationId xmlns:a16="http://schemas.microsoft.com/office/drawing/2014/main" id="{1C308577-E3EA-4D09-8CF0-3DF96AEDD223}"/>
+                <a16:creationId xmlns:a16="http://schemas.microsoft.com/office/drawing/2014/main" id="{D9D13972-E541-48C8-96C4-762ED9FAD4A4}"/>
               </a:ext>
             </a:extLst>
           </p:cNvPr>
@@ -2838,7 +2838,7 @@
           <p:cNvPr id="3" name="c3-text-157">
             <a:extLst xmlns:a="http://schemas.openxmlformats.org/drawingml/2006/main">
               <a:ext uri="{FF2B5EF4-FFF2-40B4-BE49-F238E27FC236}">
-                <a16:creationId xmlns:a16="http://schemas.microsoft.com/office/drawing/2014/main" id="{CE7D5B38-7554-46FE-9A3B-B90EB52C933D}"/>
+                <a16:creationId xmlns:a16="http://schemas.microsoft.com/office/drawing/2014/main" id="{7A44EB27-FDA0-4F59-AA7B-E2426312D9C4}"/>
               </a:ext>
             </a:extLst>
           </p:cNvPr>
@@ -2895,7 +2895,7 @@
           <p:cNvPr id="4" name="c3-shape-158">
             <a:extLst xmlns:a="http://schemas.openxmlformats.org/drawingml/2006/main">
               <a:ext uri="{FF2B5EF4-FFF2-40B4-BE49-F238E27FC236}">
-                <a16:creationId xmlns:a16="http://schemas.microsoft.com/office/drawing/2014/main" id="{722436A0-9D59-49B1-B6E6-DB4E4A1191E3}"/>
+                <a16:creationId xmlns:a16="http://schemas.microsoft.com/office/drawing/2014/main" id="{ED794952-147A-4A87-AB38-169A324146E6}"/>
               </a:ext>
             </a:extLst>
           </p:cNvPr>
@@ -2929,7 +2929,7 @@
           <p:cNvPr id="5" name="c3-text-159">
             <a:extLst xmlns:a="http://schemas.openxmlformats.org/drawingml/2006/main">
               <a:ext uri="{FF2B5EF4-FFF2-40B4-BE49-F238E27FC236}">
-                <a16:creationId xmlns:a16="http://schemas.microsoft.com/office/drawing/2014/main" id="{4B6CB78E-58B5-443A-8C07-649A95DD1445}"/>
+                <a16:creationId xmlns:a16="http://schemas.microsoft.com/office/drawing/2014/main" id="{65697CE7-AD90-4B36-AB47-445B3C66A191}"/>
               </a:ext>
             </a:extLst>
           </p:cNvPr>
@@ -3111,7 +3111,7 @@
           <p:cNvPr id="6" name="c3-text-160">
             <a:extLst xmlns:a="http://schemas.openxmlformats.org/drawingml/2006/main">
               <a:ext uri="{FF2B5EF4-FFF2-40B4-BE49-F238E27FC236}">
-                <a16:creationId xmlns:a16="http://schemas.microsoft.com/office/drawing/2014/main" id="{17B41004-D248-43B3-AA6D-4E7B31FC80F4}"/>
+                <a16:creationId xmlns:a16="http://schemas.microsoft.com/office/drawing/2014/main" id="{1D09F591-CF82-4036-B1CE-2C0A13CE709E}"/>
               </a:ext>
             </a:extLst>
           </p:cNvPr>
@@ -3191,7 +3191,7 @@
           <p:cNvPr id="7" name="c3-text-161">
             <a:extLst xmlns:a="http://schemas.openxmlformats.org/drawingml/2006/main">
               <a:ext uri="{FF2B5EF4-FFF2-40B4-BE49-F238E27FC236}">
-                <a16:creationId xmlns:a16="http://schemas.microsoft.com/office/drawing/2014/main" id="{3D4518CF-9D16-4216-853D-6BF287028C85}"/>
+                <a16:creationId xmlns:a16="http://schemas.microsoft.com/office/drawing/2014/main" id="{6F5AA76A-A015-4BAC-A5A1-998C63597685}"/>
               </a:ext>
             </a:extLst>
           </p:cNvPr>
@@ -3248,7 +3248,7 @@
           <p:cNvPr id="8" name="c3-shape-162">
             <a:extLst xmlns:a="http://schemas.openxmlformats.org/drawingml/2006/main">
               <a:ext uri="{FF2B5EF4-FFF2-40B4-BE49-F238E27FC236}">
-                <a16:creationId xmlns:a16="http://schemas.microsoft.com/office/drawing/2014/main" id="{52948A36-8D66-40C5-AA44-CD8057AE4E96}"/>
+                <a16:creationId xmlns:a16="http://schemas.microsoft.com/office/drawing/2014/main" id="{59110639-137C-450C-B4C7-61CADCF828E6}"/>
               </a:ext>
             </a:extLst>
           </p:cNvPr>
@@ -3282,7 +3282,7 @@
           <p:cNvPr id="9" name="c3-text-163">
             <a:extLst xmlns:a="http://schemas.openxmlformats.org/drawingml/2006/main">
               <a:ext uri="{FF2B5EF4-FFF2-40B4-BE49-F238E27FC236}">
-                <a16:creationId xmlns:a16="http://schemas.microsoft.com/office/drawing/2014/main" id="{DEB5CB7E-7918-49F2-B694-86D0983B844C}"/>
+                <a16:creationId xmlns:a16="http://schemas.microsoft.com/office/drawing/2014/main" id="{857DF52C-9D7E-4BC9-9CEF-0B244E957002}"/>
               </a:ext>
             </a:extLst>
           </p:cNvPr>
@@ -3339,7 +3339,7 @@
           <p:cNvPr id="10" name="c3-text-387">
             <a:extLst xmlns:a="http://schemas.openxmlformats.org/drawingml/2006/main">
               <a:ext uri="{FF2B5EF4-FFF2-40B4-BE49-F238E27FC236}">
-                <a16:creationId xmlns:a16="http://schemas.microsoft.com/office/drawing/2014/main" id="{B87DC22A-1FF9-4C59-9A09-9E654FDFEE62}"/>
+                <a16:creationId xmlns:a16="http://schemas.microsoft.com/office/drawing/2014/main" id="{227432C7-1537-4EA1-B466-954FFB84C4A4}"/>
               </a:ext>
             </a:extLst>
           </p:cNvPr>
@@ -3394,7 +3394,7 @@
     </p:spTree>
     <p:extLst>
       <p:ext uri="{BB962C8B-B14F-4D97-AF65-F5344CB8AC3E}">
-        <p14:creationId xmlns:p14="http://schemas.microsoft.com/office/powerpoint/2010/main" val="1162136997"/>
+        <p14:creationId xmlns:p14="http://schemas.microsoft.com/office/powerpoint/2010/main" val="1593866860"/>
       </p:ext>
     </p:extLst>
   </p:cSld>
@@ -3425,7 +3425,7 @@
           <p:cNvPr id="14" name="c3-text-164">
             <a:extLst xmlns:a="http://schemas.openxmlformats.org/drawingml/2006/main">
               <a:ext uri="{FF2B5EF4-FFF2-40B4-BE49-F238E27FC236}">
-                <a16:creationId xmlns:a16="http://schemas.microsoft.com/office/drawing/2014/main" id="{17E84003-A37B-4E08-9EB7-B4E4F078386A}"/>
+                <a16:creationId xmlns:a16="http://schemas.microsoft.com/office/drawing/2014/main" id="{2E83983D-2186-4B12-B2B8-4B338C169E31}"/>
               </a:ext>
             </a:extLst>
           </p:cNvPr>
@@ -3482,7 +3482,7 @@
           <p:cNvPr id="2" name="c3-text-165">
             <a:extLst xmlns:a="http://schemas.openxmlformats.org/drawingml/2006/main">
               <a:ext uri="{FF2B5EF4-FFF2-40B4-BE49-F238E27FC236}">
-                <a16:creationId xmlns:a16="http://schemas.microsoft.com/office/drawing/2014/main" id="{56435EEF-74AB-41C3-A317-0EE235B0B8C5}"/>
+                <a16:creationId xmlns:a16="http://schemas.microsoft.com/office/drawing/2014/main" id="{1EED8911-2EE7-4527-A6CA-2AFAE8AE8A84}"/>
               </a:ext>
             </a:extLst>
           </p:cNvPr>
@@ -3539,7 +3539,7 @@
           <p:cNvPr id="3" name="c3-text-166">
             <a:extLst xmlns:a="http://schemas.openxmlformats.org/drawingml/2006/main">
               <a:ext uri="{FF2B5EF4-FFF2-40B4-BE49-F238E27FC236}">
-                <a16:creationId xmlns:a16="http://schemas.microsoft.com/office/drawing/2014/main" id="{A2253111-C022-4F33-8343-EB772ECCC3B0}"/>
+                <a16:creationId xmlns:a16="http://schemas.microsoft.com/office/drawing/2014/main" id="{A4CC9C42-8B1C-40C9-A345-D8C448F9268C}"/>
               </a:ext>
             </a:extLst>
           </p:cNvPr>
@@ -3596,7 +3596,7 @@
           <p:cNvPr id="4" name="c3-shape-167">
             <a:extLst xmlns:a="http://schemas.openxmlformats.org/drawingml/2006/main">
               <a:ext uri="{FF2B5EF4-FFF2-40B4-BE49-F238E27FC236}">
-                <a16:creationId xmlns:a16="http://schemas.microsoft.com/office/drawing/2014/main" id="{4D509AA2-0F57-4352-92E9-CE26FD7F2F54}"/>
+                <a16:creationId xmlns:a16="http://schemas.microsoft.com/office/drawing/2014/main" id="{4437FE9B-E365-4141-940C-DE3B5C5E66C7}"/>
               </a:ext>
             </a:extLst>
           </p:cNvPr>
@@ -3630,7 +3630,7 @@
           <p:cNvPr id="5" name="c3-text-168">
             <a:extLst xmlns:a="http://schemas.openxmlformats.org/drawingml/2006/main">
               <a:ext uri="{FF2B5EF4-FFF2-40B4-BE49-F238E27FC236}">
-                <a16:creationId xmlns:a16="http://schemas.microsoft.com/office/drawing/2014/main" id="{571F819F-44EC-4724-9769-3825452FCFAB}"/>
+                <a16:creationId xmlns:a16="http://schemas.microsoft.com/office/drawing/2014/main" id="{0655C0C5-2B6D-4E43-9490-4BC974E901D1}"/>
               </a:ext>
             </a:extLst>
           </p:cNvPr>
@@ -3809,7 +3809,7 @@
           <p:cNvPr id="6" name="c3-shape-169">
             <a:extLst xmlns:a="http://schemas.openxmlformats.org/drawingml/2006/main">
               <a:ext uri="{FF2B5EF4-FFF2-40B4-BE49-F238E27FC236}">
-                <a16:creationId xmlns:a16="http://schemas.microsoft.com/office/drawing/2014/main" id="{FEEAA268-3300-4EB2-BFA8-81AFDEBB837F}"/>
+                <a16:creationId xmlns:a16="http://schemas.microsoft.com/office/drawing/2014/main" id="{537C6EF8-6A0D-4519-BA25-9C8697900A6A}"/>
               </a:ext>
             </a:extLst>
           </p:cNvPr>
@@ -3843,7 +3843,7 @@
           <p:cNvPr id="7" name="c3-text-170">
             <a:extLst xmlns:a="http://schemas.openxmlformats.org/drawingml/2006/main">
               <a:ext uri="{FF2B5EF4-FFF2-40B4-BE49-F238E27FC236}">
-                <a16:creationId xmlns:a16="http://schemas.microsoft.com/office/drawing/2014/main" id="{A24543F6-2BE2-4793-82FF-C2EF5BA8FA1C}"/>
+                <a16:creationId xmlns:a16="http://schemas.microsoft.com/office/drawing/2014/main" id="{EC103322-C7E6-49E2-8D24-5160FBC3F593}"/>
               </a:ext>
             </a:extLst>
           </p:cNvPr>
@@ -3900,7 +3900,7 @@
           <p:cNvPr id="8" name="c3-shape-171">
             <a:extLst xmlns:a="http://schemas.openxmlformats.org/drawingml/2006/main">
               <a:ext uri="{FF2B5EF4-FFF2-40B4-BE49-F238E27FC236}">
-                <a16:creationId xmlns:a16="http://schemas.microsoft.com/office/drawing/2014/main" id="{96F974B6-B970-4624-96F5-379BA1CEA617}"/>
+                <a16:creationId xmlns:a16="http://schemas.microsoft.com/office/drawing/2014/main" id="{DC387D3A-366D-4016-9832-AD1334D4E4FA}"/>
               </a:ext>
             </a:extLst>
           </p:cNvPr>
@@ -3932,7 +3932,7 @@
           <p:cNvPr id="9" name="c3-shape-172">
             <a:extLst xmlns:a="http://schemas.openxmlformats.org/drawingml/2006/main">
               <a:ext uri="{FF2B5EF4-FFF2-40B4-BE49-F238E27FC236}">
-                <a16:creationId xmlns:a16="http://schemas.microsoft.com/office/drawing/2014/main" id="{5154B216-E077-48B4-905D-2C2D2E8A649C}"/>
+                <a16:creationId xmlns:a16="http://schemas.microsoft.com/office/drawing/2014/main" id="{AB558727-E6AE-4641-A552-DCDC33704EA0}"/>
               </a:ext>
             </a:extLst>
           </p:cNvPr>
@@ -3966,7 +3966,7 @@
           <p:cNvPr id="10" name="c3-text-173">
             <a:extLst xmlns:a="http://schemas.openxmlformats.org/drawingml/2006/main">
               <a:ext uri="{FF2B5EF4-FFF2-40B4-BE49-F238E27FC236}">
-                <a16:creationId xmlns:a16="http://schemas.microsoft.com/office/drawing/2014/main" id="{A69B69B8-78CE-404F-A46B-8453FB27B9A1}"/>
+                <a16:creationId xmlns:a16="http://schemas.microsoft.com/office/drawing/2014/main" id="{6B1A2088-182D-4A91-94C2-D4002FAA60C2}"/>
               </a:ext>
             </a:extLst>
           </p:cNvPr>
@@ -4046,7 +4046,7 @@
           <p:cNvPr id="11" name="c3-shape-174">
             <a:extLst xmlns:a="http://schemas.openxmlformats.org/drawingml/2006/main">
               <a:ext uri="{FF2B5EF4-FFF2-40B4-BE49-F238E27FC236}">
-                <a16:creationId xmlns:a16="http://schemas.microsoft.com/office/drawing/2014/main" id="{FAAFF3A1-91EE-44D2-9C36-3949ADE932D0}"/>
+                <a16:creationId xmlns:a16="http://schemas.microsoft.com/office/drawing/2014/main" id="{7C2950D6-DC94-4ADF-A2A2-4B976233C564}"/>
               </a:ext>
             </a:extLst>
           </p:cNvPr>
@@ -4080,7 +4080,7 @@
           <p:cNvPr id="12" name="c3-text-175">
             <a:extLst xmlns:a="http://schemas.openxmlformats.org/drawingml/2006/main">
               <a:ext uri="{FF2B5EF4-FFF2-40B4-BE49-F238E27FC236}">
-                <a16:creationId xmlns:a16="http://schemas.microsoft.com/office/drawing/2014/main" id="{C23F8D5D-B4A2-40B9-88C3-EFED59A5BADB}"/>
+                <a16:creationId xmlns:a16="http://schemas.microsoft.com/office/drawing/2014/main" id="{3AECB310-0DA0-4A6F-9174-2E4EFD616961}"/>
               </a:ext>
             </a:extLst>
           </p:cNvPr>
@@ -4137,7 +4137,7 @@
           <p:cNvPr id="13" name="c3-text-388">
             <a:extLst xmlns:a="http://schemas.openxmlformats.org/drawingml/2006/main">
               <a:ext uri="{FF2B5EF4-FFF2-40B4-BE49-F238E27FC236}">
-                <a16:creationId xmlns:a16="http://schemas.microsoft.com/office/drawing/2014/main" id="{B54AA7E1-3C11-4F88-833C-F48121240FD5}"/>
+                <a16:creationId xmlns:a16="http://schemas.microsoft.com/office/drawing/2014/main" id="{01951442-862F-4A17-9A70-0EFACC767C59}"/>
               </a:ext>
             </a:extLst>
           </p:cNvPr>
@@ -4192,7 +4192,7 @@
     </p:spTree>
     <p:extLst>
       <p:ext uri="{BB962C8B-B14F-4D97-AF65-F5344CB8AC3E}">
-        <p14:creationId xmlns:p14="http://schemas.microsoft.com/office/powerpoint/2010/main" val="1690902179"/>
+        <p14:creationId xmlns:p14="http://schemas.microsoft.com/office/powerpoint/2010/main" val="130983830"/>
       </p:ext>
     </p:extLst>
   </p:cSld>
@@ -4223,7 +4223,7 @@
           <p:cNvPr id="25" name="c3-text-176">
             <a:extLst xmlns:a="http://schemas.openxmlformats.org/drawingml/2006/main">
               <a:ext uri="{FF2B5EF4-FFF2-40B4-BE49-F238E27FC236}">
-                <a16:creationId xmlns:a16="http://schemas.microsoft.com/office/drawing/2014/main" id="{F147FF8D-6F5C-4421-9F63-BAE4B9B566AA}"/>
+                <a16:creationId xmlns:a16="http://schemas.microsoft.com/office/drawing/2014/main" id="{3013257B-E273-4E2D-82FB-3D45E73DD2F7}"/>
               </a:ext>
             </a:extLst>
           </p:cNvPr>
@@ -4280,7 +4280,7 @@
           <p:cNvPr id="2" name="c3-text-177">
             <a:extLst xmlns:a="http://schemas.openxmlformats.org/drawingml/2006/main">
               <a:ext uri="{FF2B5EF4-FFF2-40B4-BE49-F238E27FC236}">
-                <a16:creationId xmlns:a16="http://schemas.microsoft.com/office/drawing/2014/main" id="{84AAA2AA-BEA2-423C-BE26-0814B6E00203}"/>
+                <a16:creationId xmlns:a16="http://schemas.microsoft.com/office/drawing/2014/main" id="{22AD947F-A618-40A1-A14D-05112116548D}"/>
               </a:ext>
             </a:extLst>
           </p:cNvPr>
@@ -4337,7 +4337,7 @@
           <p:cNvPr id="3" name="c3-text-178">
             <a:extLst xmlns:a="http://schemas.openxmlformats.org/drawingml/2006/main">
               <a:ext uri="{FF2B5EF4-FFF2-40B4-BE49-F238E27FC236}">
-                <a16:creationId xmlns:a16="http://schemas.microsoft.com/office/drawing/2014/main" id="{5EE3CE0F-8B67-48F1-AA22-8A45324F0C34}"/>
+                <a16:creationId xmlns:a16="http://schemas.microsoft.com/office/drawing/2014/main" id="{25CCF490-42C5-4B67-99E7-8512E0DAD0BB}"/>
               </a:ext>
             </a:extLst>
           </p:cNvPr>
@@ -4394,7 +4394,7 @@
           <p:cNvPr id="4" name="c3-text-179">
             <a:extLst xmlns:a="http://schemas.openxmlformats.org/drawingml/2006/main">
               <a:ext uri="{FF2B5EF4-FFF2-40B4-BE49-F238E27FC236}">
-                <a16:creationId xmlns:a16="http://schemas.microsoft.com/office/drawing/2014/main" id="{42560D90-4231-47D1-B745-B69D20A4C0CE}"/>
+                <a16:creationId xmlns:a16="http://schemas.microsoft.com/office/drawing/2014/main" id="{2C0A9956-AEC0-42A0-B29F-04FD26A4162F}"/>
               </a:ext>
             </a:extLst>
           </p:cNvPr>
@@ -4451,7 +4451,7 @@
           <p:cNvPr id="5" name="c3-shape-180">
             <a:extLst xmlns:a="http://schemas.openxmlformats.org/drawingml/2006/main">
               <a:ext uri="{FF2B5EF4-FFF2-40B4-BE49-F238E27FC236}">
-                <a16:creationId xmlns:a16="http://schemas.microsoft.com/office/drawing/2014/main" id="{91E94D20-496D-49FE-A591-5EBF1954FD9A}"/>
+                <a16:creationId xmlns:a16="http://schemas.microsoft.com/office/drawing/2014/main" id="{12EE216A-5D92-49F1-ABFC-AE34D655DA48}"/>
               </a:ext>
             </a:extLst>
           </p:cNvPr>
@@ -4485,7 +4485,7 @@
           <p:cNvPr id="6" name="c3-text-181">
             <a:extLst xmlns:a="http://schemas.openxmlformats.org/drawingml/2006/main">
               <a:ext uri="{FF2B5EF4-FFF2-40B4-BE49-F238E27FC236}">
-                <a16:creationId xmlns:a16="http://schemas.microsoft.com/office/drawing/2014/main" id="{7CFAF1D1-A25D-4B5A-BFA2-6AEC1D651B0D}"/>
+                <a16:creationId xmlns:a16="http://schemas.microsoft.com/office/drawing/2014/main" id="{AB43C915-F30D-4F97-AEFE-33726AB9A795}"/>
               </a:ext>
             </a:extLst>
           </p:cNvPr>
@@ -4542,7 +4542,7 @@
           <p:cNvPr id="7" name="c3-shape-182">
             <a:extLst xmlns:a="http://schemas.openxmlformats.org/drawingml/2006/main">
               <a:ext uri="{FF2B5EF4-FFF2-40B4-BE49-F238E27FC236}">
-                <a16:creationId xmlns:a16="http://schemas.microsoft.com/office/drawing/2014/main" id="{7310AB2A-58C2-4888-8F33-FB35C6DDE993}"/>
+                <a16:creationId xmlns:a16="http://schemas.microsoft.com/office/drawing/2014/main" id="{EBC2D40F-361F-44CA-B5BD-C562E0312992}"/>
               </a:ext>
             </a:extLst>
           </p:cNvPr>
@@ -4574,7 +4574,7 @@
           <p:cNvPr id="8" name="c3-shape-183">
             <a:extLst xmlns:a="http://schemas.openxmlformats.org/drawingml/2006/main">
               <a:ext uri="{FF2B5EF4-FFF2-40B4-BE49-F238E27FC236}">
-                <a16:creationId xmlns:a16="http://schemas.microsoft.com/office/drawing/2014/main" id="{4DED234E-1069-4934-92E8-90A3067F72B7}"/>
+                <a16:creationId xmlns:a16="http://schemas.microsoft.com/office/drawing/2014/main" id="{33C758B2-B6DE-4F97-B8A0-6C23239F3451}"/>
               </a:ext>
             </a:extLst>
           </p:cNvPr>
@@ -4608,7 +4608,7 @@
           <p:cNvPr id="9" name="c3-text-184">
             <a:extLst xmlns:a="http://schemas.openxmlformats.org/drawingml/2006/main">
               <a:ext uri="{FF2B5EF4-FFF2-40B4-BE49-F238E27FC236}">
-                <a16:creationId xmlns:a16="http://schemas.microsoft.com/office/drawing/2014/main" id="{DEA1E868-1936-4F73-B607-968292B1F4C9}"/>
+                <a16:creationId xmlns:a16="http://schemas.microsoft.com/office/drawing/2014/main" id="{F28431A6-FB1C-46E8-BF69-BDC5047ADF35}"/>
               </a:ext>
             </a:extLst>
           </p:cNvPr>
@@ -4665,7 +4665,7 @@
           <p:cNvPr id="10" name="c3-shape-185">
             <a:extLst xmlns:a="http://schemas.openxmlformats.org/drawingml/2006/main">
               <a:ext uri="{FF2B5EF4-FFF2-40B4-BE49-F238E27FC236}">
-                <a16:creationId xmlns:a16="http://schemas.microsoft.com/office/drawing/2014/main" id="{C8683C41-B7FD-43FD-B01E-5726FD2D4EF8}"/>
+                <a16:creationId xmlns:a16="http://schemas.microsoft.com/office/drawing/2014/main" id="{EE1F2969-6666-4678-A2F9-C2E9CD93564E}"/>
               </a:ext>
             </a:extLst>
           </p:cNvPr>
@@ -4697,7 +4697,7 @@
           <p:cNvPr id="11" name="c3-shape-186">
             <a:extLst xmlns:a="http://schemas.openxmlformats.org/drawingml/2006/main">
               <a:ext uri="{FF2B5EF4-FFF2-40B4-BE49-F238E27FC236}">
-                <a16:creationId xmlns:a16="http://schemas.microsoft.com/office/drawing/2014/main" id="{AF4A2B73-218C-405E-824F-173A5F4F7100}"/>
+                <a16:creationId xmlns:a16="http://schemas.microsoft.com/office/drawing/2014/main" id="{D67E8F70-ABF9-424A-86DC-995330F5372F}"/>
               </a:ext>
             </a:extLst>
           </p:cNvPr>
@@ -4731,7 +4731,7 @@
           <p:cNvPr id="12" name="c3-text-187">
             <a:extLst xmlns:a="http://schemas.openxmlformats.org/drawingml/2006/main">
               <a:ext uri="{FF2B5EF4-FFF2-40B4-BE49-F238E27FC236}">
-                <a16:creationId xmlns:a16="http://schemas.microsoft.com/office/drawing/2014/main" id="{8F3720AC-434B-4198-846B-0C60944C01D2}"/>
+                <a16:creationId xmlns:a16="http://schemas.microsoft.com/office/drawing/2014/main" id="{55E66AE1-AC7D-4C87-B15C-D048A71B534F}"/>
               </a:ext>
             </a:extLst>
           </p:cNvPr>
@@ -4788,7 +4788,7 @@
           <p:cNvPr id="13" name="c3-shape-188">
             <a:extLst xmlns:a="http://schemas.openxmlformats.org/drawingml/2006/main">
               <a:ext uri="{FF2B5EF4-FFF2-40B4-BE49-F238E27FC236}">
-                <a16:creationId xmlns:a16="http://schemas.microsoft.com/office/drawing/2014/main" id="{5B391536-3FCF-49BC-A70F-988CD339CD4E}"/>
+                <a16:creationId xmlns:a16="http://schemas.microsoft.com/office/drawing/2014/main" id="{C67F57BB-ACA3-41F8-BBAE-2E43853F1662}"/>
               </a:ext>
             </a:extLst>
           </p:cNvPr>
@@ -4820,7 +4820,7 @@
           <p:cNvPr id="14" name="c3-shape-189">
             <a:extLst xmlns:a="http://schemas.openxmlformats.org/drawingml/2006/main">
               <a:ext uri="{FF2B5EF4-FFF2-40B4-BE49-F238E27FC236}">
-                <a16:creationId xmlns:a16="http://schemas.microsoft.com/office/drawing/2014/main" id="{8703BADE-7069-4B35-A068-B336D4B2D019}"/>
+                <a16:creationId xmlns:a16="http://schemas.microsoft.com/office/drawing/2014/main" id="{ED81280C-FC3B-4968-AD0B-49E4C79119E5}"/>
               </a:ext>
             </a:extLst>
           </p:cNvPr>
@@ -4854,7 +4854,7 @@
           <p:cNvPr id="15" name="c3-text-190">
             <a:extLst xmlns:a="http://schemas.openxmlformats.org/drawingml/2006/main">
               <a:ext uri="{FF2B5EF4-FFF2-40B4-BE49-F238E27FC236}">
-                <a16:creationId xmlns:a16="http://schemas.microsoft.com/office/drawing/2014/main" id="{CD271DB7-2FFE-4CDF-9691-7D0E146E2F3D}"/>
+                <a16:creationId xmlns:a16="http://schemas.microsoft.com/office/drawing/2014/main" id="{F2253A10-1087-4A3D-B767-2A3243B72273}"/>
               </a:ext>
             </a:extLst>
           </p:cNvPr>
@@ -4911,7 +4911,7 @@
           <p:cNvPr id="16" name="c3-shape-191">
             <a:extLst xmlns:a="http://schemas.openxmlformats.org/drawingml/2006/main">
               <a:ext uri="{FF2B5EF4-FFF2-40B4-BE49-F238E27FC236}">
-                <a16:creationId xmlns:a16="http://schemas.microsoft.com/office/drawing/2014/main" id="{0495B4D1-1583-44A1-A577-C1E79C8D9D55}"/>
+                <a16:creationId xmlns:a16="http://schemas.microsoft.com/office/drawing/2014/main" id="{16EFEFD2-C7F0-4C9F-BB3B-C584656D3929}"/>
               </a:ext>
             </a:extLst>
           </p:cNvPr>
@@ -4943,7 +4943,7 @@
           <p:cNvPr id="17" name="c3-shape-192">
             <a:extLst xmlns:a="http://schemas.openxmlformats.org/drawingml/2006/main">
               <a:ext uri="{FF2B5EF4-FFF2-40B4-BE49-F238E27FC236}">
-                <a16:creationId xmlns:a16="http://schemas.microsoft.com/office/drawing/2014/main" id="{A2AF6F05-9CC6-4A3F-A378-424477F91D18}"/>
+                <a16:creationId xmlns:a16="http://schemas.microsoft.com/office/drawing/2014/main" id="{0C07D7C3-6177-4D93-BADD-D137E012E46B}"/>
               </a:ext>
             </a:extLst>
           </p:cNvPr>
@@ -4977,7 +4977,7 @@
           <p:cNvPr id="18" name="c3-text-193">
             <a:extLst xmlns:a="http://schemas.openxmlformats.org/drawingml/2006/main">
               <a:ext uri="{FF2B5EF4-FFF2-40B4-BE49-F238E27FC236}">
-                <a16:creationId xmlns:a16="http://schemas.microsoft.com/office/drawing/2014/main" id="{6A4C82EB-38B2-4998-8C61-93C211603A41}"/>
+                <a16:creationId xmlns:a16="http://schemas.microsoft.com/office/drawing/2014/main" id="{2E30F1BF-5576-486A-9765-251BEBE754D5}"/>
               </a:ext>
             </a:extLst>
           </p:cNvPr>
@@ -5034,7 +5034,7 @@
           <p:cNvPr id="19" name="c3-text-194">
             <a:extLst xmlns:a="http://schemas.openxmlformats.org/drawingml/2006/main">
               <a:ext uri="{FF2B5EF4-FFF2-40B4-BE49-F238E27FC236}">
-                <a16:creationId xmlns:a16="http://schemas.microsoft.com/office/drawing/2014/main" id="{0D00E996-874F-4C48-86DF-B9833AC82742}"/>
+                <a16:creationId xmlns:a16="http://schemas.microsoft.com/office/drawing/2014/main" id="{3C86FBC9-D3AD-4121-9754-0E7B5994ACB9}"/>
               </a:ext>
             </a:extLst>
           </p:cNvPr>
@@ -5091,7 +5091,7 @@
           <p:cNvPr id="20" name="c3-text-195">
             <a:extLst xmlns:a="http://schemas.openxmlformats.org/drawingml/2006/main">
               <a:ext uri="{FF2B5EF4-FFF2-40B4-BE49-F238E27FC236}">
-                <a16:creationId xmlns:a16="http://schemas.microsoft.com/office/drawing/2014/main" id="{9558D307-0832-4847-A05E-5F82CF8D3ADF}"/>
+                <a16:creationId xmlns:a16="http://schemas.microsoft.com/office/drawing/2014/main" id="{B6F290CA-0825-42AA-B810-804B87E4DFED}"/>
               </a:ext>
             </a:extLst>
           </p:cNvPr>
@@ -5148,7 +5148,7 @@
           <p:cNvPr id="21" name="c3-text-196">
             <a:extLst xmlns:a="http://schemas.openxmlformats.org/drawingml/2006/main">
               <a:ext uri="{FF2B5EF4-FFF2-40B4-BE49-F238E27FC236}">
-                <a16:creationId xmlns:a16="http://schemas.microsoft.com/office/drawing/2014/main" id="{0B7E5C16-2D63-411E-A2E3-5C452AACED5A}"/>
+                <a16:creationId xmlns:a16="http://schemas.microsoft.com/office/drawing/2014/main" id="{E5908CAE-2466-4162-A70D-124ADB805119}"/>
               </a:ext>
             </a:extLst>
           </p:cNvPr>
@@ -5205,7 +5205,7 @@
           <p:cNvPr id="22" name="c3-shape-197">
             <a:extLst xmlns:a="http://schemas.openxmlformats.org/drawingml/2006/main">
               <a:ext uri="{FF2B5EF4-FFF2-40B4-BE49-F238E27FC236}">
-                <a16:creationId xmlns:a16="http://schemas.microsoft.com/office/drawing/2014/main" id="{F2A7073E-490D-40EE-B65D-74D2E3C4175E}"/>
+                <a16:creationId xmlns:a16="http://schemas.microsoft.com/office/drawing/2014/main" id="{72625C3D-8A26-4C6A-8C81-E78D0ACCAA37}"/>
               </a:ext>
             </a:extLst>
           </p:cNvPr>
@@ -5239,7 +5239,7 @@
           <p:cNvPr id="23" name="c3-text-198">
             <a:extLst xmlns:a="http://schemas.openxmlformats.org/drawingml/2006/main">
               <a:ext uri="{FF2B5EF4-FFF2-40B4-BE49-F238E27FC236}">
-                <a16:creationId xmlns:a16="http://schemas.microsoft.com/office/drawing/2014/main" id="{00657F83-123C-4397-A56A-2334507ACD53}"/>
+                <a16:creationId xmlns:a16="http://schemas.microsoft.com/office/drawing/2014/main" id="{E44CDBE5-6067-4C7E-A04A-A31BA1507C79}"/>
               </a:ext>
             </a:extLst>
           </p:cNvPr>
@@ -5296,7 +5296,7 @@
           <p:cNvPr id="24" name="c3-text-389">
             <a:extLst xmlns:a="http://schemas.openxmlformats.org/drawingml/2006/main">
               <a:ext uri="{FF2B5EF4-FFF2-40B4-BE49-F238E27FC236}">
-                <a16:creationId xmlns:a16="http://schemas.microsoft.com/office/drawing/2014/main" id="{50E426AE-26D2-43AE-9594-ADD322D5C204}"/>
+                <a16:creationId xmlns:a16="http://schemas.microsoft.com/office/drawing/2014/main" id="{08856802-AD03-4532-8671-C28CD3C30325}"/>
               </a:ext>
             </a:extLst>
           </p:cNvPr>
@@ -5351,7 +5351,7 @@
     </p:spTree>
     <p:extLst>
       <p:ext uri="{BB962C8B-B14F-4D97-AF65-F5344CB8AC3E}">
-        <p14:creationId xmlns:p14="http://schemas.microsoft.com/office/powerpoint/2010/main" val="800265244"/>
+        <p14:creationId xmlns:p14="http://schemas.microsoft.com/office/powerpoint/2010/main" val="1388431891"/>
       </p:ext>
     </p:extLst>
   </p:cSld>
@@ -5382,7 +5382,7 @@
           <p:cNvPr id="7" name="c3-text-199">
             <a:extLst xmlns:a="http://schemas.openxmlformats.org/drawingml/2006/main">
               <a:ext uri="{FF2B5EF4-FFF2-40B4-BE49-F238E27FC236}">
-                <a16:creationId xmlns:a16="http://schemas.microsoft.com/office/drawing/2014/main" id="{0CE83CFE-1531-4873-BC70-EF683249CC2D}"/>
+                <a16:creationId xmlns:a16="http://schemas.microsoft.com/office/drawing/2014/main" id="{B3157D8B-4DE5-4714-B012-03C0C7B0A23E}"/>
               </a:ext>
             </a:extLst>
           </p:cNvPr>
@@ -5439,7 +5439,7 @@
           <p:cNvPr id="2" name="c3-text-200">
             <a:extLst xmlns:a="http://schemas.openxmlformats.org/drawingml/2006/main">
               <a:ext uri="{FF2B5EF4-FFF2-40B4-BE49-F238E27FC236}">
-                <a16:creationId xmlns:a16="http://schemas.microsoft.com/office/drawing/2014/main" id="{192659DF-86C5-4CA5-BD02-42FAD3DBD887}"/>
+                <a16:creationId xmlns:a16="http://schemas.microsoft.com/office/drawing/2014/main" id="{35031014-249D-4005-89D2-381ED04B1670}"/>
               </a:ext>
             </a:extLst>
           </p:cNvPr>
@@ -5496,7 +5496,7 @@
           <p:cNvPr id="3" name="c3-text-201">
             <a:extLst xmlns:a="http://schemas.openxmlformats.org/drawingml/2006/main">
               <a:ext uri="{FF2B5EF4-FFF2-40B4-BE49-F238E27FC236}">
-                <a16:creationId xmlns:a16="http://schemas.microsoft.com/office/drawing/2014/main" id="{57B18972-9EF9-425C-A577-914FEBF07CF2}"/>
+                <a16:creationId xmlns:a16="http://schemas.microsoft.com/office/drawing/2014/main" id="{B799B816-E4D7-469B-9107-8A9DE435B7C9}"/>
               </a:ext>
             </a:extLst>
           </p:cNvPr>
@@ -5553,7 +5553,7 @@
           <p:cNvPr id="4" name="c3-shape-202">
             <a:extLst xmlns:a="http://schemas.openxmlformats.org/drawingml/2006/main">
               <a:ext uri="{FF2B5EF4-FFF2-40B4-BE49-F238E27FC236}">
-                <a16:creationId xmlns:a16="http://schemas.microsoft.com/office/drawing/2014/main" id="{602DE3FA-848E-4EA0-A794-2F518D590A6E}"/>
+                <a16:creationId xmlns:a16="http://schemas.microsoft.com/office/drawing/2014/main" id="{966D696D-74B7-46FC-A0D0-BC162CD96E7E}"/>
               </a:ext>
             </a:extLst>
           </p:cNvPr>
@@ -5587,7 +5587,7 @@
           <p:cNvPr id="5" name="c3-text-203">
             <a:extLst xmlns:a="http://schemas.openxmlformats.org/drawingml/2006/main">
               <a:ext uri="{FF2B5EF4-FFF2-40B4-BE49-F238E27FC236}">
-                <a16:creationId xmlns:a16="http://schemas.microsoft.com/office/drawing/2014/main" id="{2FCB6692-B242-46AE-A305-E4EC2438AFF0}"/>
+                <a16:creationId xmlns:a16="http://schemas.microsoft.com/office/drawing/2014/main" id="{8D6CBB7D-C9A7-412E-9F1C-FC0CBB8677E2}"/>
               </a:ext>
             </a:extLst>
           </p:cNvPr>
@@ -6278,7 +6278,7 @@
           <p:cNvPr id="6" name="c3-text-390">
             <a:extLst xmlns:a="http://schemas.openxmlformats.org/drawingml/2006/main">
               <a:ext uri="{FF2B5EF4-FFF2-40B4-BE49-F238E27FC236}">
-                <a16:creationId xmlns:a16="http://schemas.microsoft.com/office/drawing/2014/main" id="{F73F9DBE-A46A-4B93-B392-B4BC14CA647A}"/>
+                <a16:creationId xmlns:a16="http://schemas.microsoft.com/office/drawing/2014/main" id="{2E4AA56C-CF06-47A2-B58C-4EC73ED05C3D}"/>
               </a:ext>
             </a:extLst>
           </p:cNvPr>
@@ -6333,7 +6333,7 @@
     </p:spTree>
     <p:extLst>
       <p:ext uri="{BB962C8B-B14F-4D97-AF65-F5344CB8AC3E}">
-        <p14:creationId xmlns:p14="http://schemas.microsoft.com/office/powerpoint/2010/main" val="405058470"/>
+        <p14:creationId xmlns:p14="http://schemas.microsoft.com/office/powerpoint/2010/main" val="487666320"/>
       </p:ext>
     </p:extLst>
   </p:cSld>
@@ -6364,7 +6364,7 @@
           <p:cNvPr id="16" name="c3-text-204">
             <a:extLst xmlns:a="http://schemas.openxmlformats.org/drawingml/2006/main">
               <a:ext uri="{FF2B5EF4-FFF2-40B4-BE49-F238E27FC236}">
-                <a16:creationId xmlns:a16="http://schemas.microsoft.com/office/drawing/2014/main" id="{70C1FDB1-E8D5-49A7-A490-6375A5619AD5}"/>
+                <a16:creationId xmlns:a16="http://schemas.microsoft.com/office/drawing/2014/main" id="{F9EFBC51-09A4-4E18-AA93-7CACF572DE16}"/>
               </a:ext>
             </a:extLst>
           </p:cNvPr>
@@ -6421,7 +6421,7 @@
           <p:cNvPr id="2" name="c3-text-205">
             <a:extLst xmlns:a="http://schemas.openxmlformats.org/drawingml/2006/main">
               <a:ext uri="{FF2B5EF4-FFF2-40B4-BE49-F238E27FC236}">
-                <a16:creationId xmlns:a16="http://schemas.microsoft.com/office/drawing/2014/main" id="{4C477720-125F-4B6A-B248-C07A0A67FEAF}"/>
+                <a16:creationId xmlns:a16="http://schemas.microsoft.com/office/drawing/2014/main" id="{1527674B-3F15-4603-9E41-A1E816842FA0}"/>
               </a:ext>
             </a:extLst>
           </p:cNvPr>
@@ -6478,7 +6478,7 @@
           <p:cNvPr id="3" name="c3-text-206">
             <a:extLst xmlns:a="http://schemas.openxmlformats.org/drawingml/2006/main">
               <a:ext uri="{FF2B5EF4-FFF2-40B4-BE49-F238E27FC236}">
-                <a16:creationId xmlns:a16="http://schemas.microsoft.com/office/drawing/2014/main" id="{33EF2CC7-78F4-4793-A272-8DC5336CE295}"/>
+                <a16:creationId xmlns:a16="http://schemas.microsoft.com/office/drawing/2014/main" id="{9DA2C784-9435-4B7F-85BE-D06998FA4B63}"/>
               </a:ext>
             </a:extLst>
           </p:cNvPr>
@@ -6535,7 +6535,7 @@
           <p:cNvPr id="4" name="c3-shape-207">
             <a:extLst xmlns:a="http://schemas.openxmlformats.org/drawingml/2006/main">
               <a:ext uri="{FF2B5EF4-FFF2-40B4-BE49-F238E27FC236}">
-                <a16:creationId xmlns:a16="http://schemas.microsoft.com/office/drawing/2014/main" id="{98C8C12B-A916-4FB0-996D-17CF31AED8B0}"/>
+                <a16:creationId xmlns:a16="http://schemas.microsoft.com/office/drawing/2014/main" id="{EC66FFE0-F559-47E7-96B7-86C6C5D765FF}"/>
               </a:ext>
             </a:extLst>
           </p:cNvPr>
@@ -6569,7 +6569,7 @@
           <p:cNvPr id="5" name="c3-text-208">
             <a:extLst xmlns:a="http://schemas.openxmlformats.org/drawingml/2006/main">
               <a:ext uri="{FF2B5EF4-FFF2-40B4-BE49-F238E27FC236}">
-                <a16:creationId xmlns:a16="http://schemas.microsoft.com/office/drawing/2014/main" id="{15164A96-BAF1-4257-A50E-1098229C2A09}"/>
+                <a16:creationId xmlns:a16="http://schemas.microsoft.com/office/drawing/2014/main" id="{D906798C-616A-4C16-A6D3-BD58B49B6125}"/>
               </a:ext>
             </a:extLst>
           </p:cNvPr>
@@ -6748,7 +6748,7 @@
           <p:cNvPr id="6" name="c3-shape-209">
             <a:extLst xmlns:a="http://schemas.openxmlformats.org/drawingml/2006/main">
               <a:ext uri="{FF2B5EF4-FFF2-40B4-BE49-F238E27FC236}">
-                <a16:creationId xmlns:a16="http://schemas.microsoft.com/office/drawing/2014/main" id="{8C7F67F0-9ADA-4A12-AFE3-37428AF09844}"/>
+                <a16:creationId xmlns:a16="http://schemas.microsoft.com/office/drawing/2014/main" id="{A402A898-E1B5-470B-ACB8-857FBF827281}"/>
               </a:ext>
             </a:extLst>
           </p:cNvPr>
@@ -6782,7 +6782,7 @@
           <p:cNvPr id="7" name="c3-shape-210">
             <a:extLst xmlns:a="http://schemas.openxmlformats.org/drawingml/2006/main">
               <a:ext uri="{FF2B5EF4-FFF2-40B4-BE49-F238E27FC236}">
-                <a16:creationId xmlns:a16="http://schemas.microsoft.com/office/drawing/2014/main" id="{19B50B70-1DAC-416F-8376-44D13D9C3828}"/>
+                <a16:creationId xmlns:a16="http://schemas.microsoft.com/office/drawing/2014/main" id="{2A0B085E-B0EA-447F-AF34-57EAA407EA7C}"/>
               </a:ext>
             </a:extLst>
           </p:cNvPr>
@@ -6814,7 +6814,7 @@
           <p:cNvPr id="8" name="c3-text-211">
             <a:extLst xmlns:a="http://schemas.openxmlformats.org/drawingml/2006/main">
               <a:ext uri="{FF2B5EF4-FFF2-40B4-BE49-F238E27FC236}">
-                <a16:creationId xmlns:a16="http://schemas.microsoft.com/office/drawing/2014/main" id="{EB61DC15-4CEC-4A79-B53F-A503B3939685}"/>
+                <a16:creationId xmlns:a16="http://schemas.microsoft.com/office/drawing/2014/main" id="{2C5D739D-081B-4746-9652-9E6BD860403F}"/>
               </a:ext>
             </a:extLst>
           </p:cNvPr>
@@ -6871,7 +6871,7 @@
           <p:cNvPr id="9" name="c3-text-212">
             <a:extLst xmlns:a="http://schemas.openxmlformats.org/drawingml/2006/main">
               <a:ext uri="{FF2B5EF4-FFF2-40B4-BE49-F238E27FC236}">
-                <a16:creationId xmlns:a16="http://schemas.microsoft.com/office/drawing/2014/main" id="{860DA162-992E-47BC-A3BA-D33407B42543}"/>
+                <a16:creationId xmlns:a16="http://schemas.microsoft.com/office/drawing/2014/main" id="{448B06B9-F27B-4387-B7DA-0B03F77EB295}"/>
               </a:ext>
             </a:extLst>
           </p:cNvPr>
@@ -6928,7 +6928,7 @@
           <p:cNvPr id="10" name="c3-shape-213">
             <a:extLst xmlns:a="http://schemas.openxmlformats.org/drawingml/2006/main">
               <a:ext uri="{FF2B5EF4-FFF2-40B4-BE49-F238E27FC236}">
-                <a16:creationId xmlns:a16="http://schemas.microsoft.com/office/drawing/2014/main" id="{A7D0BB34-6B59-4D15-B7FA-9495F2DC7E02}"/>
+                <a16:creationId xmlns:a16="http://schemas.microsoft.com/office/drawing/2014/main" id="{1EB820A9-D4AC-4A2D-9FF6-2071E31AB82F}"/>
               </a:ext>
             </a:extLst>
           </p:cNvPr>
@@ -6962,7 +6962,7 @@
           <p:cNvPr id="11" name="c3-shape-214">
             <a:extLst xmlns:a="http://schemas.openxmlformats.org/drawingml/2006/main">
               <a:ext uri="{FF2B5EF4-FFF2-40B4-BE49-F238E27FC236}">
-                <a16:creationId xmlns:a16="http://schemas.microsoft.com/office/drawing/2014/main" id="{CE7965DD-B55C-4DE3-8F53-38BAFD696126}"/>
+                <a16:creationId xmlns:a16="http://schemas.microsoft.com/office/drawing/2014/main" id="{50359D50-9D07-4231-BDA8-7E8BBCD1DA2C}"/>
               </a:ext>
             </a:extLst>
           </p:cNvPr>
@@ -6994,7 +6994,7 @@
           <p:cNvPr id="12" name="c3-text-215">
             <a:extLst xmlns:a="http://schemas.openxmlformats.org/drawingml/2006/main">
               <a:ext uri="{FF2B5EF4-FFF2-40B4-BE49-F238E27FC236}">
-                <a16:creationId xmlns:a16="http://schemas.microsoft.com/office/drawing/2014/main" id="{4C98084A-F921-44C7-B975-C35B0EFCF433}"/>
+                <a16:creationId xmlns:a16="http://schemas.microsoft.com/office/drawing/2014/main" id="{B6C4538B-E93A-4A3B-B898-D145F84CCE72}"/>
               </a:ext>
             </a:extLst>
           </p:cNvPr>
@@ -7051,7 +7051,7 @@
           <p:cNvPr id="13" name="c3-text-216">
             <a:extLst xmlns:a="http://schemas.openxmlformats.org/drawingml/2006/main">
               <a:ext uri="{FF2B5EF4-FFF2-40B4-BE49-F238E27FC236}">
-                <a16:creationId xmlns:a16="http://schemas.microsoft.com/office/drawing/2014/main" id="{7B0B0BAB-0EC9-4C50-A408-DE526C44CBA6}"/>
+                <a16:creationId xmlns:a16="http://schemas.microsoft.com/office/drawing/2014/main" id="{1FEECF20-D9CE-48F2-8D4D-1F9A4A4236A3}"/>
               </a:ext>
             </a:extLst>
           </p:cNvPr>
@@ -7106,10 +7106,10 @@
       <p:sp>
         <p:nvSpPr>
           <p:cNvPr id="14" name="c3-text-217">
-            <a:hlinkClick xmlns:r="http://schemas.openxmlformats.org/officeDocument/2006/relationships" xmlns:a="http://schemas.openxmlformats.org/drawingml/2006/main" r:id="Rbffeb11642644434"/>
-            <a:extLst xmlns:a="http://schemas.openxmlformats.org/drawingml/2006/main">
-              <a:ext uri="{FF2B5EF4-FFF2-40B4-BE49-F238E27FC236}">
-                <a16:creationId xmlns:a16="http://schemas.microsoft.com/office/drawing/2014/main" id="{41750A8B-DB19-4776-BBD5-739B61C32A61}"/>
+            <a:hlinkClick xmlns:r="http://schemas.openxmlformats.org/officeDocument/2006/relationships" xmlns:a="http://schemas.openxmlformats.org/drawingml/2006/main" r:id="Rc06b88c4888c4697"/>
+            <a:extLst xmlns:a="http://schemas.openxmlformats.org/drawingml/2006/main">
+              <a:ext uri="{FF2B5EF4-FFF2-40B4-BE49-F238E27FC236}">
+                <a16:creationId xmlns:a16="http://schemas.microsoft.com/office/drawing/2014/main" id="{43324F64-FB35-439F-A34C-24C370F5D91E}"/>
               </a:ext>
             </a:extLst>
           </p:cNvPr>
@@ -7166,7 +7166,7 @@
           <p:cNvPr id="15" name="c3-text-391">
             <a:extLst xmlns:a="http://schemas.openxmlformats.org/drawingml/2006/main">
               <a:ext uri="{FF2B5EF4-FFF2-40B4-BE49-F238E27FC236}">
-                <a16:creationId xmlns:a16="http://schemas.microsoft.com/office/drawing/2014/main" id="{0470AAA6-9D1A-4C7A-942C-B217708954C8}"/>
+                <a16:creationId xmlns:a16="http://schemas.microsoft.com/office/drawing/2014/main" id="{CDE99C61-6BDA-4B5A-BA1C-5A7406DB9F26}"/>
               </a:ext>
             </a:extLst>
           </p:cNvPr>
@@ -7221,7 +7221,7 @@
     </p:spTree>
     <p:extLst>
       <p:ext uri="{BB962C8B-B14F-4D97-AF65-F5344CB8AC3E}">
-        <p14:creationId xmlns:p14="http://schemas.microsoft.com/office/powerpoint/2010/main" val="1617321135"/>
+        <p14:creationId xmlns:p14="http://schemas.microsoft.com/office/powerpoint/2010/main" val="919727601"/>
       </p:ext>
     </p:extLst>
   </p:cSld>
@@ -7252,7 +7252,7 @@
           <p:cNvPr id="24" name="c3-text-218">
             <a:extLst xmlns:a="http://schemas.openxmlformats.org/drawingml/2006/main">
               <a:ext uri="{FF2B5EF4-FFF2-40B4-BE49-F238E27FC236}">
-                <a16:creationId xmlns:a16="http://schemas.microsoft.com/office/drawing/2014/main" id="{C527E598-E818-43C6-810A-BD3746D3B963}"/>
+                <a16:creationId xmlns:a16="http://schemas.microsoft.com/office/drawing/2014/main" id="{2EEEDA56-16E1-4015-9D11-40E3FAD64EE3}"/>
               </a:ext>
             </a:extLst>
           </p:cNvPr>
@@ -7309,7 +7309,7 @@
           <p:cNvPr id="2" name="c3-text-219">
             <a:extLst xmlns:a="http://schemas.openxmlformats.org/drawingml/2006/main">
               <a:ext uri="{FF2B5EF4-FFF2-40B4-BE49-F238E27FC236}">
-                <a16:creationId xmlns:a16="http://schemas.microsoft.com/office/drawing/2014/main" id="{280720F6-2C7F-42ED-92F5-33173AF37E12}"/>
+                <a16:creationId xmlns:a16="http://schemas.microsoft.com/office/drawing/2014/main" id="{6E42A400-1CAA-4A5D-A252-750DC5B1082A}"/>
               </a:ext>
             </a:extLst>
           </p:cNvPr>
@@ -7366,7 +7366,7 @@
           <p:cNvPr id="3" name="c3-text-220">
             <a:extLst xmlns:a="http://schemas.openxmlformats.org/drawingml/2006/main">
               <a:ext uri="{FF2B5EF4-FFF2-40B4-BE49-F238E27FC236}">
-                <a16:creationId xmlns:a16="http://schemas.microsoft.com/office/drawing/2014/main" id="{BFF88A5B-73C1-4663-841A-53A3DD92B933}"/>
+                <a16:creationId xmlns:a16="http://schemas.microsoft.com/office/drawing/2014/main" id="{1144F6A4-C069-4473-B8CF-B1C6A5161A87}"/>
               </a:ext>
             </a:extLst>
           </p:cNvPr>
@@ -7423,7 +7423,7 @@
           <p:cNvPr id="4" name="c3-text-221">
             <a:extLst xmlns:a="http://schemas.openxmlformats.org/drawingml/2006/main">
               <a:ext uri="{FF2B5EF4-FFF2-40B4-BE49-F238E27FC236}">
-                <a16:creationId xmlns:a16="http://schemas.microsoft.com/office/drawing/2014/main" id="{9FA24533-7F53-4E0D-8D6F-6E93E87E1192}"/>
+                <a16:creationId xmlns:a16="http://schemas.microsoft.com/office/drawing/2014/main" id="{341997E0-0361-4452-9677-FD4773111997}"/>
               </a:ext>
             </a:extLst>
           </p:cNvPr>
@@ -7480,7 +7480,7 @@
           <p:cNvPr id="5" name="c3-shape-222">
             <a:extLst xmlns:a="http://schemas.openxmlformats.org/drawingml/2006/main">
               <a:ext uri="{FF2B5EF4-FFF2-40B4-BE49-F238E27FC236}">
-                <a16:creationId xmlns:a16="http://schemas.microsoft.com/office/drawing/2014/main" id="{FA313E32-1727-4A3E-8FD4-47816A4650F3}"/>
+                <a16:creationId xmlns:a16="http://schemas.microsoft.com/office/drawing/2014/main" id="{36B93B17-C539-40BE-A588-8CD9C374BD7D}"/>
               </a:ext>
             </a:extLst>
           </p:cNvPr>
@@ -7514,7 +7514,7 @@
           <p:cNvPr id="6" name="c3-text-223">
             <a:extLst xmlns:a="http://schemas.openxmlformats.org/drawingml/2006/main">
               <a:ext uri="{FF2B5EF4-FFF2-40B4-BE49-F238E27FC236}">
-                <a16:creationId xmlns:a16="http://schemas.microsoft.com/office/drawing/2014/main" id="{4E84B72D-D390-49C9-B2AD-217FD5498D0B}"/>
+                <a16:creationId xmlns:a16="http://schemas.microsoft.com/office/drawing/2014/main" id="{44697ADD-AEE7-4F0B-B5B8-9C4104402F59}"/>
               </a:ext>
             </a:extLst>
           </p:cNvPr>
@@ -7571,7 +7571,7 @@
           <p:cNvPr id="7" name="c3-shape-224">
             <a:extLst xmlns:a="http://schemas.openxmlformats.org/drawingml/2006/main">
               <a:ext uri="{FF2B5EF4-FFF2-40B4-BE49-F238E27FC236}">
-                <a16:creationId xmlns:a16="http://schemas.microsoft.com/office/drawing/2014/main" id="{995825BB-385F-49D2-BFE5-0733F5A627AB}"/>
+                <a16:creationId xmlns:a16="http://schemas.microsoft.com/office/drawing/2014/main" id="{88A7BAED-C1A2-4744-86A1-D17E3F12323E}"/>
               </a:ext>
             </a:extLst>
           </p:cNvPr>
@@ -7603,7 +7603,7 @@
           <p:cNvPr id="8" name="c3-shape-225">
             <a:extLst xmlns:a="http://schemas.openxmlformats.org/drawingml/2006/main">
               <a:ext uri="{FF2B5EF4-FFF2-40B4-BE49-F238E27FC236}">
-                <a16:creationId xmlns:a16="http://schemas.microsoft.com/office/drawing/2014/main" id="{6103887D-1734-49EE-A264-A73D031813E3}"/>
+                <a16:creationId xmlns:a16="http://schemas.microsoft.com/office/drawing/2014/main" id="{C26DA6E5-00CB-489C-A45C-3AEB6AB01309}"/>
               </a:ext>
             </a:extLst>
           </p:cNvPr>
@@ -7635,7 +7635,7 @@
           <p:cNvPr id="9" name="c3-shape-226">
             <a:extLst xmlns:a="http://schemas.openxmlformats.org/drawingml/2006/main">
               <a:ext uri="{FF2B5EF4-FFF2-40B4-BE49-F238E27FC236}">
-                <a16:creationId xmlns:a16="http://schemas.microsoft.com/office/drawing/2014/main" id="{01232FF8-9BD4-492F-857B-9D8D88427898}"/>
+                <a16:creationId xmlns:a16="http://schemas.microsoft.com/office/drawing/2014/main" id="{8D9E9FE4-3C4C-4EFC-AD22-2C4AEBFA10F1}"/>
               </a:ext>
             </a:extLst>
           </p:cNvPr>
@@ -7667,7 +7667,7 @@
           <p:cNvPr id="10" name="c3-shape-227">
             <a:extLst xmlns:a="http://schemas.openxmlformats.org/drawingml/2006/main">
               <a:ext uri="{FF2B5EF4-FFF2-40B4-BE49-F238E27FC236}">
-                <a16:creationId xmlns:a16="http://schemas.microsoft.com/office/drawing/2014/main" id="{6634EDF8-74CA-4A51-9EC2-8CE522DA7AEC}"/>
+                <a16:creationId xmlns:a16="http://schemas.microsoft.com/office/drawing/2014/main" id="{79CAE32D-01CD-4BBA-8DB5-0F650728F4DE}"/>
               </a:ext>
             </a:extLst>
           </p:cNvPr>
@@ -7699,7 +7699,7 @@
           <p:cNvPr id="11" name="c3-shape-228">
             <a:extLst xmlns:a="http://schemas.openxmlformats.org/drawingml/2006/main">
               <a:ext uri="{FF2B5EF4-FFF2-40B4-BE49-F238E27FC236}">
-                <a16:creationId xmlns:a16="http://schemas.microsoft.com/office/drawing/2014/main" id="{6020DB89-C03D-4EDD-965C-20A94B87D4A8}"/>
+                <a16:creationId xmlns:a16="http://schemas.microsoft.com/office/drawing/2014/main" id="{26590AAB-9374-4AF0-89BF-76C5538463BE}"/>
               </a:ext>
             </a:extLst>
           </p:cNvPr>
@@ -7733,7 +7733,7 @@
           <p:cNvPr id="12" name="c3-text-229">
             <a:extLst xmlns:a="http://schemas.openxmlformats.org/drawingml/2006/main">
               <a:ext uri="{FF2B5EF4-FFF2-40B4-BE49-F238E27FC236}">
-                <a16:creationId xmlns:a16="http://schemas.microsoft.com/office/drawing/2014/main" id="{AE17EF47-A465-4300-8621-72742D3A406A}"/>
+                <a16:creationId xmlns:a16="http://schemas.microsoft.com/office/drawing/2014/main" id="{321E62CC-6E64-4137-8DB7-45B92B2DD071}"/>
               </a:ext>
             </a:extLst>
           </p:cNvPr>
@@ -7790,7 +7790,7 @@
           <p:cNvPr id="13" name="c3-shape-230">
             <a:extLst xmlns:a="http://schemas.openxmlformats.org/drawingml/2006/main">
               <a:ext uri="{FF2B5EF4-FFF2-40B4-BE49-F238E27FC236}">
-                <a16:creationId xmlns:a16="http://schemas.microsoft.com/office/drawing/2014/main" id="{9D560A5A-A081-4B37-840F-D2F5EB89D4C1}"/>
+                <a16:creationId xmlns:a16="http://schemas.microsoft.com/office/drawing/2014/main" id="{299DC557-538B-4663-9237-68736611565A}"/>
               </a:ext>
             </a:extLst>
           </p:cNvPr>
@@ -7824,7 +7824,7 @@
           <p:cNvPr id="14" name="c3-text-231">
             <a:extLst xmlns:a="http://schemas.openxmlformats.org/drawingml/2006/main">
               <a:ext uri="{FF2B5EF4-FFF2-40B4-BE49-F238E27FC236}">
-                <a16:creationId xmlns:a16="http://schemas.microsoft.com/office/drawing/2014/main" id="{58057895-29FD-4ADD-9218-EE28E28528B4}"/>
+                <a16:creationId xmlns:a16="http://schemas.microsoft.com/office/drawing/2014/main" id="{DE76B8A8-0981-4376-960D-4CBB46C80839}"/>
               </a:ext>
             </a:extLst>
           </p:cNvPr>
@@ -7881,7 +7881,7 @@
           <p:cNvPr id="15" name="c3-text-232">
             <a:extLst xmlns:a="http://schemas.openxmlformats.org/drawingml/2006/main">
               <a:ext uri="{FF2B5EF4-FFF2-40B4-BE49-F238E27FC236}">
-                <a16:creationId xmlns:a16="http://schemas.microsoft.com/office/drawing/2014/main" id="{A8FD1303-D9BD-4950-B289-BEFEED29D41F}"/>
+                <a16:creationId xmlns:a16="http://schemas.microsoft.com/office/drawing/2014/main" id="{F2008874-1786-466B-8564-E826D2A144E7}"/>
               </a:ext>
             </a:extLst>
           </p:cNvPr>
@@ -7938,7 +7938,7 @@
           <p:cNvPr id="16" name="c3-text-233">
             <a:extLst xmlns:a="http://schemas.openxmlformats.org/drawingml/2006/main">
               <a:ext uri="{FF2B5EF4-FFF2-40B4-BE49-F238E27FC236}">
-                <a16:creationId xmlns:a16="http://schemas.microsoft.com/office/drawing/2014/main" id="{D2F8EE11-A616-4923-9807-7C33A2191E86}"/>
+                <a16:creationId xmlns:a16="http://schemas.microsoft.com/office/drawing/2014/main" id="{44BA1820-BEB4-4687-AADD-916EE2CE5545}"/>
               </a:ext>
             </a:extLst>
           </p:cNvPr>
@@ -7995,7 +7995,7 @@
           <p:cNvPr id="17" name="c3-shape-234">
             <a:extLst xmlns:a="http://schemas.openxmlformats.org/drawingml/2006/main">
               <a:ext uri="{FF2B5EF4-FFF2-40B4-BE49-F238E27FC236}">
-                <a16:creationId xmlns:a16="http://schemas.microsoft.com/office/drawing/2014/main" id="{CEC8FEF3-8934-40CD-AA31-27CC71753585}"/>
+                <a16:creationId xmlns:a16="http://schemas.microsoft.com/office/drawing/2014/main" id="{71429697-338A-4DB5-9624-84E4E862911B}"/>
               </a:ext>
             </a:extLst>
           </p:cNvPr>
@@ -8027,7 +8027,7 @@
           <p:cNvPr id="18" name="c3-shape-235">
             <a:extLst xmlns:a="http://schemas.openxmlformats.org/drawingml/2006/main">
               <a:ext uri="{FF2B5EF4-FFF2-40B4-BE49-F238E27FC236}">
-                <a16:creationId xmlns:a16="http://schemas.microsoft.com/office/drawing/2014/main" id="{88D7BC5A-9B21-4512-A18B-EBC31237B200}"/>
+                <a16:creationId xmlns:a16="http://schemas.microsoft.com/office/drawing/2014/main" id="{2C96A374-7C70-4474-8654-2F73551F3159}"/>
               </a:ext>
             </a:extLst>
           </p:cNvPr>
@@ -8059,7 +8059,7 @@
           <p:cNvPr id="19" name="c3-shape-236">
             <a:extLst xmlns:a="http://schemas.openxmlformats.org/drawingml/2006/main">
               <a:ext uri="{FF2B5EF4-FFF2-40B4-BE49-F238E27FC236}">
-                <a16:creationId xmlns:a16="http://schemas.microsoft.com/office/drawing/2014/main" id="{A37076E5-23F7-4228-A624-33824384628D}"/>
+                <a16:creationId xmlns:a16="http://schemas.microsoft.com/office/drawing/2014/main" id="{66255BE2-8BD7-4C9B-B6F9-06C91D9AC918}"/>
               </a:ext>
             </a:extLst>
           </p:cNvPr>
@@ -8091,7 +8091,7 @@
           <p:cNvPr id="20" name="c3-shape-237">
             <a:extLst xmlns:a="http://schemas.openxmlformats.org/drawingml/2006/main">
               <a:ext uri="{FF2B5EF4-FFF2-40B4-BE49-F238E27FC236}">
-                <a16:creationId xmlns:a16="http://schemas.microsoft.com/office/drawing/2014/main" id="{57D005B0-916D-4075-BBA2-B49D5942DE4E}"/>
+                <a16:creationId xmlns:a16="http://schemas.microsoft.com/office/drawing/2014/main" id="{7FC48BCE-AD9A-4DD2-B126-4909CBE40FD0}"/>
               </a:ext>
             </a:extLst>
           </p:cNvPr>
@@ -8123,7 +8123,7 @@
           <p:cNvPr id="21" name="c3-shape-238">
             <a:extLst xmlns:a="http://schemas.openxmlformats.org/drawingml/2006/main">
               <a:ext uri="{FF2B5EF4-FFF2-40B4-BE49-F238E27FC236}">
-                <a16:creationId xmlns:a16="http://schemas.microsoft.com/office/drawing/2014/main" id="{7DAEF7ED-1919-4F99-9292-28475C5C5A6A}"/>
+                <a16:creationId xmlns:a16="http://schemas.microsoft.com/office/drawing/2014/main" id="{71CB05DB-2F9D-43F3-9C36-927FC5EB16AA}"/>
               </a:ext>
             </a:extLst>
           </p:cNvPr>
@@ -8157,7 +8157,7 @@
           <p:cNvPr id="22" name="c3-text-239">
             <a:extLst xmlns:a="http://schemas.openxmlformats.org/drawingml/2006/main">
               <a:ext uri="{FF2B5EF4-FFF2-40B4-BE49-F238E27FC236}">
-                <a16:creationId xmlns:a16="http://schemas.microsoft.com/office/drawing/2014/main" id="{F39CFAF5-3FB1-485D-BE31-75C3CD151F6C}"/>
+                <a16:creationId xmlns:a16="http://schemas.microsoft.com/office/drawing/2014/main" id="{85B52533-2CE6-4356-AE94-3E0ADFA91C3A}"/>
               </a:ext>
             </a:extLst>
           </p:cNvPr>
@@ -8214,7 +8214,7 @@
           <p:cNvPr id="23" name="c3-text-392">
             <a:extLst xmlns:a="http://schemas.openxmlformats.org/drawingml/2006/main">
               <a:ext uri="{FF2B5EF4-FFF2-40B4-BE49-F238E27FC236}">
-                <a16:creationId xmlns:a16="http://schemas.microsoft.com/office/drawing/2014/main" id="{E0CCAFD9-0927-4C3E-A514-FB1A26D5563A}"/>
+                <a16:creationId xmlns:a16="http://schemas.microsoft.com/office/drawing/2014/main" id="{9A826F86-52F7-407E-BF8F-D467EA523B4F}"/>
               </a:ext>
             </a:extLst>
           </p:cNvPr>
@@ -8269,7 +8269,7 @@
     </p:spTree>
     <p:extLst>
       <p:ext uri="{BB962C8B-B14F-4D97-AF65-F5344CB8AC3E}">
-        <p14:creationId xmlns:p14="http://schemas.microsoft.com/office/powerpoint/2010/main" val="387541214"/>
+        <p14:creationId xmlns:p14="http://schemas.microsoft.com/office/powerpoint/2010/main" val="1121948625"/>
       </p:ext>
     </p:extLst>
   </p:cSld>
@@ -8300,7 +8300,7 @@
           <p:cNvPr id="9" name="c3-text-240">
             <a:extLst xmlns:a="http://schemas.openxmlformats.org/drawingml/2006/main">
               <a:ext uri="{FF2B5EF4-FFF2-40B4-BE49-F238E27FC236}">
-                <a16:creationId xmlns:a16="http://schemas.microsoft.com/office/drawing/2014/main" id="{EA2B3100-1B97-4F62-915A-383805579D1E}"/>
+                <a16:creationId xmlns:a16="http://schemas.microsoft.com/office/drawing/2014/main" id="{1F26CC7C-8CF9-4559-80D0-E9D64ECBF508}"/>
               </a:ext>
             </a:extLst>
           </p:cNvPr>
@@ -8357,7 +8357,7 @@
           <p:cNvPr id="2" name="c3-text-241">
             <a:extLst xmlns:a="http://schemas.openxmlformats.org/drawingml/2006/main">
               <a:ext uri="{FF2B5EF4-FFF2-40B4-BE49-F238E27FC236}">
-                <a16:creationId xmlns:a16="http://schemas.microsoft.com/office/drawing/2014/main" id="{ABB0014B-FC01-4F14-83F6-3B994E2C3DF2}"/>
+                <a16:creationId xmlns:a16="http://schemas.microsoft.com/office/drawing/2014/main" id="{C8B61FFE-905D-4814-BA54-C1925BC0F0D6}"/>
               </a:ext>
             </a:extLst>
           </p:cNvPr>
@@ -8414,7 +8414,7 @@
           <p:cNvPr id="3" name="c3-text-242">
             <a:extLst xmlns:a="http://schemas.openxmlformats.org/drawingml/2006/main">
               <a:ext uri="{FF2B5EF4-FFF2-40B4-BE49-F238E27FC236}">
-                <a16:creationId xmlns:a16="http://schemas.microsoft.com/office/drawing/2014/main" id="{96BBD251-979A-4E52-9AF6-E2F68123AD67}"/>
+                <a16:creationId xmlns:a16="http://schemas.microsoft.com/office/drawing/2014/main" id="{A83DD054-FCAE-48B1-A599-64B79BB001BB}"/>
               </a:ext>
             </a:extLst>
           </p:cNvPr>
@@ -8471,7 +8471,7 @@
           <p:cNvPr id="4" name="c3-shape-243">
             <a:extLst xmlns:a="http://schemas.openxmlformats.org/drawingml/2006/main">
               <a:ext uri="{FF2B5EF4-FFF2-40B4-BE49-F238E27FC236}">
-                <a16:creationId xmlns:a16="http://schemas.microsoft.com/office/drawing/2014/main" id="{85DCEEC8-BB68-42C2-A6AE-EDC481614D92}"/>
+                <a16:creationId xmlns:a16="http://schemas.microsoft.com/office/drawing/2014/main" id="{FC01B941-609F-450A-8A4A-6EB46972D0AA}"/>
               </a:ext>
             </a:extLst>
           </p:cNvPr>
@@ -8505,7 +8505,7 @@
           <p:cNvPr id="5" name="c3-text-244">
             <a:extLst xmlns:a="http://schemas.openxmlformats.org/drawingml/2006/main">
               <a:ext uri="{FF2B5EF4-FFF2-40B4-BE49-F238E27FC236}">
-                <a16:creationId xmlns:a16="http://schemas.microsoft.com/office/drawing/2014/main" id="{CB0FAC15-AFD8-41F9-B4D9-EF53B2707348}"/>
+                <a16:creationId xmlns:a16="http://schemas.microsoft.com/office/drawing/2014/main" id="{41236042-3FF4-4EDD-A326-ADD14A91B435}"/>
               </a:ext>
             </a:extLst>
           </p:cNvPr>
@@ -8891,7 +8891,7 @@
           <p:cNvPr id="6" name="c3-text-245">
             <a:extLst xmlns:a="http://schemas.openxmlformats.org/drawingml/2006/main">
               <a:ext uri="{FF2B5EF4-FFF2-40B4-BE49-F238E27FC236}">
-                <a16:creationId xmlns:a16="http://schemas.microsoft.com/office/drawing/2014/main" id="{6E1E0DB7-0427-4939-A877-50D3ABA6CEBD}"/>
+                <a16:creationId xmlns:a16="http://schemas.microsoft.com/office/drawing/2014/main" id="{2C6C6109-E583-4FD1-9EC4-AA5A19762A7A}"/>
               </a:ext>
             </a:extLst>
           </p:cNvPr>
@@ -8946,10 +8946,10 @@
       <p:sp>
         <p:nvSpPr>
           <p:cNvPr id="7" name="c3-text-246">
-            <a:hlinkClick xmlns:r="http://schemas.openxmlformats.org/officeDocument/2006/relationships" xmlns:a="http://schemas.openxmlformats.org/drawingml/2006/main" r:id="R37b454e9b7ef447a"/>
-            <a:extLst xmlns:a="http://schemas.openxmlformats.org/drawingml/2006/main">
-              <a:ext uri="{FF2B5EF4-FFF2-40B4-BE49-F238E27FC236}">
-                <a16:creationId xmlns:a16="http://schemas.microsoft.com/office/drawing/2014/main" id="{FA5CC2A3-ED37-4321-9978-59FAF2DA9155}"/>
+            <a:hlinkClick xmlns:r="http://schemas.openxmlformats.org/officeDocument/2006/relationships" xmlns:a="http://schemas.openxmlformats.org/drawingml/2006/main" r:id="R83db730caff44a51"/>
+            <a:extLst xmlns:a="http://schemas.openxmlformats.org/drawingml/2006/main">
+              <a:ext uri="{FF2B5EF4-FFF2-40B4-BE49-F238E27FC236}">
+                <a16:creationId xmlns:a16="http://schemas.microsoft.com/office/drawing/2014/main" id="{FC700F4F-6A5F-46D3-B0EB-B9C8945EE332}"/>
               </a:ext>
             </a:extLst>
           </p:cNvPr>
@@ -9006,7 +9006,7 @@
           <p:cNvPr id="8" name="c3-text-393">
             <a:extLst xmlns:a="http://schemas.openxmlformats.org/drawingml/2006/main">
               <a:ext uri="{FF2B5EF4-FFF2-40B4-BE49-F238E27FC236}">
-                <a16:creationId xmlns:a16="http://schemas.microsoft.com/office/drawing/2014/main" id="{141598FE-25A9-4BF5-BCAA-1DA835D06F56}"/>
+                <a16:creationId xmlns:a16="http://schemas.microsoft.com/office/drawing/2014/main" id="{5021B735-FE31-4EB3-B945-F561149B3F77}"/>
               </a:ext>
             </a:extLst>
           </p:cNvPr>
@@ -9061,7 +9061,7 @@
     </p:spTree>
     <p:extLst>
       <p:ext uri="{BB962C8B-B14F-4D97-AF65-F5344CB8AC3E}">
-        <p14:creationId xmlns:p14="http://schemas.microsoft.com/office/powerpoint/2010/main" val="1720265507"/>
+        <p14:creationId xmlns:p14="http://schemas.microsoft.com/office/powerpoint/2010/main" val="1169240162"/>
       </p:ext>
     </p:extLst>
   </p:cSld>
@@ -9092,7 +9092,7 @@
           <p:cNvPr id="27" name="c3-text-247">
             <a:extLst xmlns:a="http://schemas.openxmlformats.org/drawingml/2006/main">
               <a:ext uri="{FF2B5EF4-FFF2-40B4-BE49-F238E27FC236}">
-                <a16:creationId xmlns:a16="http://schemas.microsoft.com/office/drawing/2014/main" id="{68E1B013-5362-47BB-97BD-B51BA4F9D6B6}"/>
+                <a16:creationId xmlns:a16="http://schemas.microsoft.com/office/drawing/2014/main" id="{DBA318A7-EC4C-4729-9B84-042AE694E196}"/>
               </a:ext>
             </a:extLst>
           </p:cNvPr>
@@ -9149,7 +9149,7 @@
           <p:cNvPr id="2" name="c3-text-248">
             <a:extLst xmlns:a="http://schemas.openxmlformats.org/drawingml/2006/main">
               <a:ext uri="{FF2B5EF4-FFF2-40B4-BE49-F238E27FC236}">
-                <a16:creationId xmlns:a16="http://schemas.microsoft.com/office/drawing/2014/main" id="{18EE39C0-57CE-4CCC-97AF-3EC07786D5F4}"/>
+                <a16:creationId xmlns:a16="http://schemas.microsoft.com/office/drawing/2014/main" id="{7F3B8F70-E545-4B13-BBB2-ABF4B9C3C923}"/>
               </a:ext>
             </a:extLst>
           </p:cNvPr>
@@ -9206,7 +9206,7 @@
           <p:cNvPr id="3" name="c3-text-249">
             <a:extLst xmlns:a="http://schemas.openxmlformats.org/drawingml/2006/main">
               <a:ext uri="{FF2B5EF4-FFF2-40B4-BE49-F238E27FC236}">
-                <a16:creationId xmlns:a16="http://schemas.microsoft.com/office/drawing/2014/main" id="{53061813-729F-4060-8C18-7294001DF8CD}"/>
+                <a16:creationId xmlns:a16="http://schemas.microsoft.com/office/drawing/2014/main" id="{E5ACEC8F-499F-4D88-8A92-1CF4FBE6C527}"/>
               </a:ext>
             </a:extLst>
           </p:cNvPr>
@@ -9263,7 +9263,7 @@
           <p:cNvPr id="4" name="c3-text-250">
             <a:extLst xmlns:a="http://schemas.openxmlformats.org/drawingml/2006/main">
               <a:ext uri="{FF2B5EF4-FFF2-40B4-BE49-F238E27FC236}">
-                <a16:creationId xmlns:a16="http://schemas.microsoft.com/office/drawing/2014/main" id="{E5AAEB9F-17EF-41BB-8FC7-9B201E81C006}"/>
+                <a16:creationId xmlns:a16="http://schemas.microsoft.com/office/drawing/2014/main" id="{9D1F5238-EADB-482F-9661-EDAC7F58EF2B}"/>
               </a:ext>
             </a:extLst>
           </p:cNvPr>
@@ -9320,7 +9320,7 @@
           <p:cNvPr id="5" name="c3-shape-251">
             <a:extLst xmlns:a="http://schemas.openxmlformats.org/drawingml/2006/main">
               <a:ext uri="{FF2B5EF4-FFF2-40B4-BE49-F238E27FC236}">
-                <a16:creationId xmlns:a16="http://schemas.microsoft.com/office/drawing/2014/main" id="{9AC9C33C-F5AB-4FBA-AABA-5BAE089CC4E8}"/>
+                <a16:creationId xmlns:a16="http://schemas.microsoft.com/office/drawing/2014/main" id="{885537DC-85A4-4AD5-80F9-16BDB2689574}"/>
               </a:ext>
             </a:extLst>
           </p:cNvPr>
@@ -9354,7 +9354,7 @@
           <p:cNvPr id="6" name="c3-text-252">
             <a:extLst xmlns:a="http://schemas.openxmlformats.org/drawingml/2006/main">
               <a:ext uri="{FF2B5EF4-FFF2-40B4-BE49-F238E27FC236}">
-                <a16:creationId xmlns:a16="http://schemas.microsoft.com/office/drawing/2014/main" id="{D822A771-66C0-43E2-A07D-32F76FD2E2D1}"/>
+                <a16:creationId xmlns:a16="http://schemas.microsoft.com/office/drawing/2014/main" id="{A365CF56-C2FE-4FA7-A599-BC0AEB7743DF}"/>
               </a:ext>
             </a:extLst>
           </p:cNvPr>
@@ -9411,7 +9411,7 @@
           <p:cNvPr id="7" name="c3-shape-253">
             <a:extLst xmlns:a="http://schemas.openxmlformats.org/drawingml/2006/main">
               <a:ext uri="{FF2B5EF4-FFF2-40B4-BE49-F238E27FC236}">
-                <a16:creationId xmlns:a16="http://schemas.microsoft.com/office/drawing/2014/main" id="{6425ED93-1706-45F8-8881-DFE3D3D52EAC}"/>
+                <a16:creationId xmlns:a16="http://schemas.microsoft.com/office/drawing/2014/main" id="{9B8459A9-930B-4DF2-A8EB-F7B20AE5A11D}"/>
               </a:ext>
             </a:extLst>
           </p:cNvPr>
@@ -9443,7 +9443,7 @@
           <p:cNvPr id="8" name="c3-shape-254">
             <a:extLst xmlns:a="http://schemas.openxmlformats.org/drawingml/2006/main">
               <a:ext uri="{FF2B5EF4-FFF2-40B4-BE49-F238E27FC236}">
-                <a16:creationId xmlns:a16="http://schemas.microsoft.com/office/drawing/2014/main" id="{73838B5C-F8DA-4643-9C6C-C79B65802799}"/>
+                <a16:creationId xmlns:a16="http://schemas.microsoft.com/office/drawing/2014/main" id="{00AB3C62-39CB-4EA2-84B4-655121397190}"/>
               </a:ext>
             </a:extLst>
           </p:cNvPr>
@@ -9475,7 +9475,7 @@
           <p:cNvPr id="9" name="c3-shape-255">
             <a:extLst xmlns:a="http://schemas.openxmlformats.org/drawingml/2006/main">
               <a:ext uri="{FF2B5EF4-FFF2-40B4-BE49-F238E27FC236}">
-                <a16:creationId xmlns:a16="http://schemas.microsoft.com/office/drawing/2014/main" id="{DE7B25A2-93D9-4C14-87A7-69ACA51ACDD3}"/>
+                <a16:creationId xmlns:a16="http://schemas.microsoft.com/office/drawing/2014/main" id="{65D2C5D0-B83F-419F-8351-BF6C2BD9FC87}"/>
               </a:ext>
             </a:extLst>
           </p:cNvPr>
@@ -9507,7 +9507,7 @@
           <p:cNvPr id="10" name="c3-shape-256">
             <a:extLst xmlns:a="http://schemas.openxmlformats.org/drawingml/2006/main">
               <a:ext uri="{FF2B5EF4-FFF2-40B4-BE49-F238E27FC236}">
-                <a16:creationId xmlns:a16="http://schemas.microsoft.com/office/drawing/2014/main" id="{F5798500-C723-433E-BE14-0AB3224A4601}"/>
+                <a16:creationId xmlns:a16="http://schemas.microsoft.com/office/drawing/2014/main" id="{0B601DBB-0D27-4792-B378-8EE50DCC2D58}"/>
               </a:ext>
             </a:extLst>
           </p:cNvPr>
@@ -9539,7 +9539,7 @@
           <p:cNvPr id="11" name="c3-shape-257">
             <a:extLst xmlns:a="http://schemas.openxmlformats.org/drawingml/2006/main">
               <a:ext uri="{FF2B5EF4-FFF2-40B4-BE49-F238E27FC236}">
-                <a16:creationId xmlns:a16="http://schemas.microsoft.com/office/drawing/2014/main" id="{76DAB304-9BD8-4298-A388-8508375515B1}"/>
+                <a16:creationId xmlns:a16="http://schemas.microsoft.com/office/drawing/2014/main" id="{BCC749BA-7593-46EF-8483-1330FCD9932A}"/>
               </a:ext>
             </a:extLst>
           </p:cNvPr>
@@ -9573,7 +9573,7 @@
           <p:cNvPr id="12" name="c3-text-258">
             <a:extLst xmlns:a="http://schemas.openxmlformats.org/drawingml/2006/main">
               <a:ext uri="{FF2B5EF4-FFF2-40B4-BE49-F238E27FC236}">
-                <a16:creationId xmlns:a16="http://schemas.microsoft.com/office/drawing/2014/main" id="{9396CE3F-2901-4D42-8D15-D9F7857FB91C}"/>
+                <a16:creationId xmlns:a16="http://schemas.microsoft.com/office/drawing/2014/main" id="{B4B5A110-B69F-48F9-9BED-7643FD28D203}"/>
               </a:ext>
             </a:extLst>
           </p:cNvPr>
@@ -9630,7 +9630,7 @@
           <p:cNvPr id="13" name="c3-shape-259">
             <a:extLst xmlns:a="http://schemas.openxmlformats.org/drawingml/2006/main">
               <a:ext uri="{FF2B5EF4-FFF2-40B4-BE49-F238E27FC236}">
-                <a16:creationId xmlns:a16="http://schemas.microsoft.com/office/drawing/2014/main" id="{3CD69F55-9EE0-4C04-A7D2-01679E231C32}"/>
+                <a16:creationId xmlns:a16="http://schemas.microsoft.com/office/drawing/2014/main" id="{816730EB-F3E4-426A-9445-1AA69FD9A993}"/>
               </a:ext>
             </a:extLst>
           </p:cNvPr>
@@ -9664,7 +9664,7 @@
           <p:cNvPr id="14" name="c3-text-260">
             <a:extLst xmlns:a="http://schemas.openxmlformats.org/drawingml/2006/main">
               <a:ext uri="{FF2B5EF4-FFF2-40B4-BE49-F238E27FC236}">
-                <a16:creationId xmlns:a16="http://schemas.microsoft.com/office/drawing/2014/main" id="{0B25F392-86D5-4248-8322-7F11ACCD5CE8}"/>
+                <a16:creationId xmlns:a16="http://schemas.microsoft.com/office/drawing/2014/main" id="{29983932-1BA6-4A47-B18A-D4E7D5893EE9}"/>
               </a:ext>
             </a:extLst>
           </p:cNvPr>
@@ -9721,7 +9721,7 @@
           <p:cNvPr id="15" name="c3-text-261">
             <a:extLst xmlns:a="http://schemas.openxmlformats.org/drawingml/2006/main">
               <a:ext uri="{FF2B5EF4-FFF2-40B4-BE49-F238E27FC236}">
-                <a16:creationId xmlns:a16="http://schemas.microsoft.com/office/drawing/2014/main" id="{2182C0DE-C007-46AF-8581-F708CAC2CB59}"/>
+                <a16:creationId xmlns:a16="http://schemas.microsoft.com/office/drawing/2014/main" id="{55AF6D01-37E3-4B99-BD30-25891EA5FA2E}"/>
               </a:ext>
             </a:extLst>
           </p:cNvPr>
@@ -9778,7 +9778,7 @@
           <p:cNvPr id="16" name="c3-text-262">
             <a:extLst xmlns:a="http://schemas.openxmlformats.org/drawingml/2006/main">
               <a:ext uri="{FF2B5EF4-FFF2-40B4-BE49-F238E27FC236}">
-                <a16:creationId xmlns:a16="http://schemas.microsoft.com/office/drawing/2014/main" id="{D029B2C9-20C0-4EDE-AD8B-814E9D3446C7}"/>
+                <a16:creationId xmlns:a16="http://schemas.microsoft.com/office/drawing/2014/main" id="{3CD365E3-5198-4B68-8132-2849EF45538E}"/>
               </a:ext>
             </a:extLst>
           </p:cNvPr>
@@ -9835,7 +9835,7 @@
           <p:cNvPr id="17" name="c3-shape-263">
             <a:extLst xmlns:a="http://schemas.openxmlformats.org/drawingml/2006/main">
               <a:ext uri="{FF2B5EF4-FFF2-40B4-BE49-F238E27FC236}">
-                <a16:creationId xmlns:a16="http://schemas.microsoft.com/office/drawing/2014/main" id="{0B189C7F-2E4F-4113-9975-C232D4BF0110}"/>
+                <a16:creationId xmlns:a16="http://schemas.microsoft.com/office/drawing/2014/main" id="{42D38556-291F-43FC-9BE6-5E16E5EC69F2}"/>
               </a:ext>
             </a:extLst>
           </p:cNvPr>
@@ -9867,7 +9867,7 @@
           <p:cNvPr id="18" name="c3-shape-264">
             <a:extLst xmlns:a="http://schemas.openxmlformats.org/drawingml/2006/main">
               <a:ext uri="{FF2B5EF4-FFF2-40B4-BE49-F238E27FC236}">
-                <a16:creationId xmlns:a16="http://schemas.microsoft.com/office/drawing/2014/main" id="{43C1CD9B-13CD-4371-886B-4FBD64C5A3ED}"/>
+                <a16:creationId xmlns:a16="http://schemas.microsoft.com/office/drawing/2014/main" id="{3F897CB4-A69D-434F-8C3E-1F1FF7FD2268}"/>
               </a:ext>
             </a:extLst>
           </p:cNvPr>
@@ -9899,7 +9899,7 @@
           <p:cNvPr id="19" name="c3-shape-265">
             <a:extLst xmlns:a="http://schemas.openxmlformats.org/drawingml/2006/main">
               <a:ext uri="{FF2B5EF4-FFF2-40B4-BE49-F238E27FC236}">
-                <a16:creationId xmlns:a16="http://schemas.microsoft.com/office/drawing/2014/main" id="{F9C93AB9-EA0C-4D4F-88FB-630253CEA5DA}"/>
+                <a16:creationId xmlns:a16="http://schemas.microsoft.com/office/drawing/2014/main" id="{F937B02C-B963-4196-B921-164794ADB1F4}"/>
               </a:ext>
             </a:extLst>
           </p:cNvPr>
@@ -9931,7 +9931,7 @@
           <p:cNvPr id="20" name="c3-shape-266">
             <a:extLst xmlns:a="http://schemas.openxmlformats.org/drawingml/2006/main">
               <a:ext uri="{FF2B5EF4-FFF2-40B4-BE49-F238E27FC236}">
-                <a16:creationId xmlns:a16="http://schemas.microsoft.com/office/drawing/2014/main" id="{B3695F4B-A064-490A-AF23-BCE0C69837E6}"/>
+                <a16:creationId xmlns:a16="http://schemas.microsoft.com/office/drawing/2014/main" id="{695E4C34-3171-4F62-8C91-2E7AABCF120F}"/>
               </a:ext>
             </a:extLst>
           </p:cNvPr>
@@ -9963,7 +9963,7 @@
           <p:cNvPr id="21" name="c3-shape-267">
             <a:extLst xmlns:a="http://schemas.openxmlformats.org/drawingml/2006/main">
               <a:ext uri="{FF2B5EF4-FFF2-40B4-BE49-F238E27FC236}">
-                <a16:creationId xmlns:a16="http://schemas.microsoft.com/office/drawing/2014/main" id="{6B409998-6741-478C-855C-09D0A844DE8B}"/>
+                <a16:creationId xmlns:a16="http://schemas.microsoft.com/office/drawing/2014/main" id="{1CAE16FF-3FC5-4517-BB61-CF9FFC21EA9D}"/>
               </a:ext>
             </a:extLst>
           </p:cNvPr>
@@ -9997,7 +9997,7 @@
           <p:cNvPr id="22" name="c3-text-268">
             <a:extLst xmlns:a="http://schemas.openxmlformats.org/drawingml/2006/main">
               <a:ext uri="{FF2B5EF4-FFF2-40B4-BE49-F238E27FC236}">
-                <a16:creationId xmlns:a16="http://schemas.microsoft.com/office/drawing/2014/main" id="{514FC574-269C-476C-B853-0B55D849C947}"/>
+                <a16:creationId xmlns:a16="http://schemas.microsoft.com/office/drawing/2014/main" id="{FBADA316-8BB5-4044-AD7C-6A94BA5F5CF5}"/>
               </a:ext>
             </a:extLst>
           </p:cNvPr>
@@ -10054,7 +10054,7 @@
           <p:cNvPr id="23" name="c3-shape-269">
             <a:extLst xmlns:a="http://schemas.openxmlformats.org/drawingml/2006/main">
               <a:ext uri="{FF2B5EF4-FFF2-40B4-BE49-F238E27FC236}">
-                <a16:creationId xmlns:a16="http://schemas.microsoft.com/office/drawing/2014/main" id="{79B66459-443D-45E1-9682-3F393C45CD9A}"/>
+                <a16:creationId xmlns:a16="http://schemas.microsoft.com/office/drawing/2014/main" id="{92A1B9FF-2AA7-4A93-BF27-F35C7D3882CD}"/>
               </a:ext>
             </a:extLst>
           </p:cNvPr>
@@ -10086,7 +10086,7 @@
           <p:cNvPr id="24" name="c3-shape-270">
             <a:extLst xmlns:a="http://schemas.openxmlformats.org/drawingml/2006/main">
               <a:ext uri="{FF2B5EF4-FFF2-40B4-BE49-F238E27FC236}">
-                <a16:creationId xmlns:a16="http://schemas.microsoft.com/office/drawing/2014/main" id="{CE80FC17-8F97-4834-B56E-FA4F03B7703A}"/>
+                <a16:creationId xmlns:a16="http://schemas.microsoft.com/office/drawing/2014/main" id="{36F4456D-0DAC-4610-A6FC-E86BDE1C4F0C}"/>
               </a:ext>
             </a:extLst>
           </p:cNvPr>
@@ -10120,7 +10120,7 @@
           <p:cNvPr id="25" name="c3-text-271">
             <a:extLst xmlns:a="http://schemas.openxmlformats.org/drawingml/2006/main">
               <a:ext uri="{FF2B5EF4-FFF2-40B4-BE49-F238E27FC236}">
-                <a16:creationId xmlns:a16="http://schemas.microsoft.com/office/drawing/2014/main" id="{D7BF74BC-08FB-455E-9445-DB3EF64A4B84}"/>
+                <a16:creationId xmlns:a16="http://schemas.microsoft.com/office/drawing/2014/main" id="{72D23EFA-5F73-42E3-A123-D659903F0FBA}"/>
               </a:ext>
             </a:extLst>
           </p:cNvPr>
@@ -10177,7 +10177,7 @@
           <p:cNvPr id="26" name="c3-text-394">
             <a:extLst xmlns:a="http://schemas.openxmlformats.org/drawingml/2006/main">
               <a:ext uri="{FF2B5EF4-FFF2-40B4-BE49-F238E27FC236}">
-                <a16:creationId xmlns:a16="http://schemas.microsoft.com/office/drawing/2014/main" id="{4FA26B26-EE57-4CAE-ADA1-6F16018EC83D}"/>
+                <a16:creationId xmlns:a16="http://schemas.microsoft.com/office/drawing/2014/main" id="{CE7321BF-27E3-4BB4-9220-1B68B6F0FCFD}"/>
               </a:ext>
             </a:extLst>
           </p:cNvPr>
@@ -10232,7 +10232,7 @@
     </p:spTree>
     <p:extLst>
       <p:ext uri="{BB962C8B-B14F-4D97-AF65-F5344CB8AC3E}">
-        <p14:creationId xmlns:p14="http://schemas.microsoft.com/office/powerpoint/2010/main" val="2011411054"/>
+        <p14:creationId xmlns:p14="http://schemas.microsoft.com/office/powerpoint/2010/main" val="150661063"/>
       </p:ext>
     </p:extLst>
   </p:cSld>
@@ -10263,7 +10263,7 @@
           <p:cNvPr id="10" name="c3-text-272">
             <a:extLst xmlns:a="http://schemas.openxmlformats.org/drawingml/2006/main">
               <a:ext uri="{FF2B5EF4-FFF2-40B4-BE49-F238E27FC236}">
-                <a16:creationId xmlns:a16="http://schemas.microsoft.com/office/drawing/2014/main" id="{BF265E88-5A0C-43B0-9C1B-B78F95B1EC30}"/>
+                <a16:creationId xmlns:a16="http://schemas.microsoft.com/office/drawing/2014/main" id="{6A46C231-7FFF-4885-9942-4197E0BF1C5A}"/>
               </a:ext>
             </a:extLst>
           </p:cNvPr>
@@ -10320,7 +10320,7 @@
           <p:cNvPr id="2" name="c3-text-273">
             <a:extLst xmlns:a="http://schemas.openxmlformats.org/drawingml/2006/main">
               <a:ext uri="{FF2B5EF4-FFF2-40B4-BE49-F238E27FC236}">
-                <a16:creationId xmlns:a16="http://schemas.microsoft.com/office/drawing/2014/main" id="{67D8A39A-F3B3-4E2A-B7DE-F1BC9E6BE0BA}"/>
+                <a16:creationId xmlns:a16="http://schemas.microsoft.com/office/drawing/2014/main" id="{FF32BB2C-728C-4590-8E2F-DBDB03BD552F}"/>
               </a:ext>
             </a:extLst>
           </p:cNvPr>
@@ -10377,7 +10377,7 @@
           <p:cNvPr id="3" name="c3-text-274">
             <a:extLst xmlns:a="http://schemas.openxmlformats.org/drawingml/2006/main">
               <a:ext uri="{FF2B5EF4-FFF2-40B4-BE49-F238E27FC236}">
-                <a16:creationId xmlns:a16="http://schemas.microsoft.com/office/drawing/2014/main" id="{F9F6E05D-F002-464A-951F-B4606D57B5EB}"/>
+                <a16:creationId xmlns:a16="http://schemas.microsoft.com/office/drawing/2014/main" id="{E654D038-C459-4824-A69F-1195E3EF1899}"/>
               </a:ext>
             </a:extLst>
           </p:cNvPr>
@@ -10434,7 +10434,7 @@
           <p:cNvPr id="4" name="c3-shape-275">
             <a:extLst xmlns:a="http://schemas.openxmlformats.org/drawingml/2006/main">
               <a:ext uri="{FF2B5EF4-FFF2-40B4-BE49-F238E27FC236}">
-                <a16:creationId xmlns:a16="http://schemas.microsoft.com/office/drawing/2014/main" id="{CD15C830-294E-4B9A-9CBF-D1E62EF15867}"/>
+                <a16:creationId xmlns:a16="http://schemas.microsoft.com/office/drawing/2014/main" id="{B8CF8D2B-36A7-4A83-89C7-06451185E1CD}"/>
               </a:ext>
             </a:extLst>
           </p:cNvPr>
@@ -10468,7 +10468,7 @@
           <p:cNvPr id="5" name="c3-text-276">
             <a:extLst xmlns:a="http://schemas.openxmlformats.org/drawingml/2006/main">
               <a:ext uri="{FF2B5EF4-FFF2-40B4-BE49-F238E27FC236}">
-                <a16:creationId xmlns:a16="http://schemas.microsoft.com/office/drawing/2014/main" id="{55526022-80EE-4D21-8841-9DB8CD5EBE99}"/>
+                <a16:creationId xmlns:a16="http://schemas.microsoft.com/office/drawing/2014/main" id="{2DF70C17-49C9-458C-AE6D-6DF5505604D4}"/>
               </a:ext>
             </a:extLst>
           </p:cNvPr>
@@ -10880,7 +10880,7 @@
           <p:cNvPr id="6" name="c3-text-277">
             <a:extLst xmlns:a="http://schemas.openxmlformats.org/drawingml/2006/main">
               <a:ext uri="{FF2B5EF4-FFF2-40B4-BE49-F238E27FC236}">
-                <a16:creationId xmlns:a16="http://schemas.microsoft.com/office/drawing/2014/main" id="{515DC056-0A2B-43C0-B444-BE1445F30882}"/>
+                <a16:creationId xmlns:a16="http://schemas.microsoft.com/office/drawing/2014/main" id="{14E2C84F-6D72-4EAD-8088-298B9AAB89A1}"/>
               </a:ext>
             </a:extLst>
           </p:cNvPr>
@@ -10937,7 +10937,7 @@
           <p:cNvPr id="7" name="c3-text-278">
             <a:extLst xmlns:a="http://schemas.openxmlformats.org/drawingml/2006/main">
               <a:ext uri="{FF2B5EF4-FFF2-40B4-BE49-F238E27FC236}">
-                <a16:creationId xmlns:a16="http://schemas.microsoft.com/office/drawing/2014/main" id="{0DDFF4CB-9847-4F2F-AD24-E80E648A22AD}"/>
+                <a16:creationId xmlns:a16="http://schemas.microsoft.com/office/drawing/2014/main" id="{7318CD78-1BB8-4C88-A29C-F1627EB4C6EA}"/>
               </a:ext>
             </a:extLst>
           </p:cNvPr>
@@ -10992,10 +10992,10 @@
       <p:sp>
         <p:nvSpPr>
           <p:cNvPr id="8" name="c3-text-279">
-            <a:hlinkClick xmlns:r="http://schemas.openxmlformats.org/officeDocument/2006/relationships" xmlns:a="http://schemas.openxmlformats.org/drawingml/2006/main" r:id="Rffa669cb69c34307"/>
-            <a:extLst xmlns:a="http://schemas.openxmlformats.org/drawingml/2006/main">
-              <a:ext uri="{FF2B5EF4-FFF2-40B4-BE49-F238E27FC236}">
-                <a16:creationId xmlns:a16="http://schemas.microsoft.com/office/drawing/2014/main" id="{143202CD-DC1A-496C-BE93-88AF4128552D}"/>
+            <a:hlinkClick xmlns:r="http://schemas.openxmlformats.org/officeDocument/2006/relationships" xmlns:a="http://schemas.openxmlformats.org/drawingml/2006/main" r:id="R4d21f7d86f4f42b0"/>
+            <a:extLst xmlns:a="http://schemas.openxmlformats.org/drawingml/2006/main">
+              <a:ext uri="{FF2B5EF4-FFF2-40B4-BE49-F238E27FC236}">
+                <a16:creationId xmlns:a16="http://schemas.microsoft.com/office/drawing/2014/main" id="{C99DC8DD-D43A-4A5A-BFE1-02455A90C48C}"/>
               </a:ext>
             </a:extLst>
           </p:cNvPr>
@@ -11052,7 +11052,7 @@
           <p:cNvPr id="9" name="c3-text-395">
             <a:extLst xmlns:a="http://schemas.openxmlformats.org/drawingml/2006/main">
               <a:ext uri="{FF2B5EF4-FFF2-40B4-BE49-F238E27FC236}">
-                <a16:creationId xmlns:a16="http://schemas.microsoft.com/office/drawing/2014/main" id="{474F2736-322C-48E3-ABA5-23ED6D89945D}"/>
+                <a16:creationId xmlns:a16="http://schemas.microsoft.com/office/drawing/2014/main" id="{637126D0-D140-4787-85E8-B29BF430C0C1}"/>
               </a:ext>
             </a:extLst>
           </p:cNvPr>
@@ -11107,7 +11107,7 @@
     </p:spTree>
     <p:extLst>
       <p:ext uri="{BB962C8B-B14F-4D97-AF65-F5344CB8AC3E}">
-        <p14:creationId xmlns:p14="http://schemas.microsoft.com/office/powerpoint/2010/main" val="1148192364"/>
+        <p14:creationId xmlns:p14="http://schemas.microsoft.com/office/powerpoint/2010/main" val="1479839604"/>
       </p:ext>
     </p:extLst>
   </p:cSld>
@@ -11138,7 +11138,7 @@
           <p:cNvPr id="21" name="c3-text-280">
             <a:extLst xmlns:a="http://schemas.openxmlformats.org/drawingml/2006/main">
               <a:ext uri="{FF2B5EF4-FFF2-40B4-BE49-F238E27FC236}">
-                <a16:creationId xmlns:a16="http://schemas.microsoft.com/office/drawing/2014/main" id="{77BEBAEB-38D6-4324-A0F6-887CD563CCEF}"/>
+                <a16:creationId xmlns:a16="http://schemas.microsoft.com/office/drawing/2014/main" id="{D62B8C8C-02E0-471A-82EB-64FB046486D9}"/>
               </a:ext>
             </a:extLst>
           </p:cNvPr>
@@ -11195,7 +11195,7 @@
           <p:cNvPr id="2" name="c3-text-281">
             <a:extLst xmlns:a="http://schemas.openxmlformats.org/drawingml/2006/main">
               <a:ext uri="{FF2B5EF4-FFF2-40B4-BE49-F238E27FC236}">
-                <a16:creationId xmlns:a16="http://schemas.microsoft.com/office/drawing/2014/main" id="{99D3D350-1DD0-421A-98FC-13CA33706B83}"/>
+                <a16:creationId xmlns:a16="http://schemas.microsoft.com/office/drawing/2014/main" id="{F786836D-3433-4C3D-B59E-751CE99AB44C}"/>
               </a:ext>
             </a:extLst>
           </p:cNvPr>
@@ -11252,7 +11252,7 @@
           <p:cNvPr id="3" name="c3-text-282">
             <a:extLst xmlns:a="http://schemas.openxmlformats.org/drawingml/2006/main">
               <a:ext uri="{FF2B5EF4-FFF2-40B4-BE49-F238E27FC236}">
-                <a16:creationId xmlns:a16="http://schemas.microsoft.com/office/drawing/2014/main" id="{382588D4-EB4C-47B7-91C1-CC1D54803974}"/>
+                <a16:creationId xmlns:a16="http://schemas.microsoft.com/office/drawing/2014/main" id="{A65B9C73-A60D-4F5E-95FD-A389E859BC05}"/>
               </a:ext>
             </a:extLst>
           </p:cNvPr>
@@ -11309,7 +11309,7 @@
           <p:cNvPr id="4" name="c3-shape-283">
             <a:extLst xmlns:a="http://schemas.openxmlformats.org/drawingml/2006/main">
               <a:ext uri="{FF2B5EF4-FFF2-40B4-BE49-F238E27FC236}">
-                <a16:creationId xmlns:a16="http://schemas.microsoft.com/office/drawing/2014/main" id="{5658EA5B-4087-4A6B-A707-EAF7BC463990}"/>
+                <a16:creationId xmlns:a16="http://schemas.microsoft.com/office/drawing/2014/main" id="{DF7CF019-07B3-4C77-86AC-28E7E048F19E}"/>
               </a:ext>
             </a:extLst>
           </p:cNvPr>
@@ -11343,7 +11343,7 @@
           <p:cNvPr id="5" name="c3-text-284">
             <a:extLst xmlns:a="http://schemas.openxmlformats.org/drawingml/2006/main">
               <a:ext uri="{FF2B5EF4-FFF2-40B4-BE49-F238E27FC236}">
-                <a16:creationId xmlns:a16="http://schemas.microsoft.com/office/drawing/2014/main" id="{F96A8DBD-049D-4635-974C-DE03D0D88F14}"/>
+                <a16:creationId xmlns:a16="http://schemas.microsoft.com/office/drawing/2014/main" id="{7C7AD55C-DABB-4AF9-9C25-C4D5B688FF63}"/>
               </a:ext>
             </a:extLst>
           </p:cNvPr>
@@ -11423,7 +11423,7 @@
           <p:cNvPr id="6" name="c3-shape-285">
             <a:extLst xmlns:a="http://schemas.openxmlformats.org/drawingml/2006/main">
               <a:ext uri="{FF2B5EF4-FFF2-40B4-BE49-F238E27FC236}">
-                <a16:creationId xmlns:a16="http://schemas.microsoft.com/office/drawing/2014/main" id="{75EF1E5A-E57E-41D6-8383-E9B800CD8D57}"/>
+                <a16:creationId xmlns:a16="http://schemas.microsoft.com/office/drawing/2014/main" id="{C695AFB8-7FC3-4677-99B2-05FA6374A975}"/>
               </a:ext>
             </a:extLst>
           </p:cNvPr>
@@ -11455,7 +11455,7 @@
           <p:cNvPr id="7" name="c3-shape-286">
             <a:extLst xmlns:a="http://schemas.openxmlformats.org/drawingml/2006/main">
               <a:ext uri="{FF2B5EF4-FFF2-40B4-BE49-F238E27FC236}">
-                <a16:creationId xmlns:a16="http://schemas.microsoft.com/office/drawing/2014/main" id="{C75FC6D4-F41C-4088-90C5-FF66A7A7CDC9}"/>
+                <a16:creationId xmlns:a16="http://schemas.microsoft.com/office/drawing/2014/main" id="{CEAFA4C4-182E-491E-BCB3-5FDDD0B011DC}"/>
               </a:ext>
             </a:extLst>
           </p:cNvPr>
@@ -11489,7 +11489,7 @@
           <p:cNvPr id="8" name="c3-text-287">
             <a:extLst xmlns:a="http://schemas.openxmlformats.org/drawingml/2006/main">
               <a:ext uri="{FF2B5EF4-FFF2-40B4-BE49-F238E27FC236}">
-                <a16:creationId xmlns:a16="http://schemas.microsoft.com/office/drawing/2014/main" id="{AE4DBBEB-687B-4986-B012-FBAE01E63734}"/>
+                <a16:creationId xmlns:a16="http://schemas.microsoft.com/office/drawing/2014/main" id="{10651A1B-DD6A-480A-8F38-E8709BB86A75}"/>
               </a:ext>
             </a:extLst>
           </p:cNvPr>
@@ -11546,7 +11546,7 @@
           <p:cNvPr id="9" name="c3-shape-288">
             <a:extLst xmlns:a="http://schemas.openxmlformats.org/drawingml/2006/main">
               <a:ext uri="{FF2B5EF4-FFF2-40B4-BE49-F238E27FC236}">
-                <a16:creationId xmlns:a16="http://schemas.microsoft.com/office/drawing/2014/main" id="{F3034FF9-9D86-4D54-BC0D-DE62173C3F55}"/>
+                <a16:creationId xmlns:a16="http://schemas.microsoft.com/office/drawing/2014/main" id="{00680754-02A2-4696-BC2C-2BF35D28239A}"/>
               </a:ext>
             </a:extLst>
           </p:cNvPr>
@@ -11578,7 +11578,7 @@
           <p:cNvPr id="10" name="c3-shape-289">
             <a:extLst xmlns:a="http://schemas.openxmlformats.org/drawingml/2006/main">
               <a:ext uri="{FF2B5EF4-FFF2-40B4-BE49-F238E27FC236}">
-                <a16:creationId xmlns:a16="http://schemas.microsoft.com/office/drawing/2014/main" id="{CF47281B-5DBD-4F2E-83E1-638FCE05D74D}"/>
+                <a16:creationId xmlns:a16="http://schemas.microsoft.com/office/drawing/2014/main" id="{D63085B3-C272-45F8-8449-6590C71E4E67}"/>
               </a:ext>
             </a:extLst>
           </p:cNvPr>
@@ -11612,7 +11612,7 @@
           <p:cNvPr id="11" name="c3-text-290">
             <a:extLst xmlns:a="http://schemas.openxmlformats.org/drawingml/2006/main">
               <a:ext uri="{FF2B5EF4-FFF2-40B4-BE49-F238E27FC236}">
-                <a16:creationId xmlns:a16="http://schemas.microsoft.com/office/drawing/2014/main" id="{43D8D94D-2305-4EDF-AAAB-300716B5CD2D}"/>
+                <a16:creationId xmlns:a16="http://schemas.microsoft.com/office/drawing/2014/main" id="{1B48D21A-E8DA-40AB-B673-9533F043A4B4}"/>
               </a:ext>
             </a:extLst>
           </p:cNvPr>
@@ -11669,7 +11669,7 @@
           <p:cNvPr id="12" name="c3-shape-291">
             <a:extLst xmlns:a="http://schemas.openxmlformats.org/drawingml/2006/main">
               <a:ext uri="{FF2B5EF4-FFF2-40B4-BE49-F238E27FC236}">
-                <a16:creationId xmlns:a16="http://schemas.microsoft.com/office/drawing/2014/main" id="{1DAA1002-6286-4F07-8342-0A387DF23EFA}"/>
+                <a16:creationId xmlns:a16="http://schemas.microsoft.com/office/drawing/2014/main" id="{AF3E2A0E-7967-4067-A6B4-6365558DA60D}"/>
               </a:ext>
             </a:extLst>
           </p:cNvPr>
@@ -11701,7 +11701,7 @@
           <p:cNvPr id="13" name="c3-shape-292">
             <a:extLst xmlns:a="http://schemas.openxmlformats.org/drawingml/2006/main">
               <a:ext uri="{FF2B5EF4-FFF2-40B4-BE49-F238E27FC236}">
-                <a16:creationId xmlns:a16="http://schemas.microsoft.com/office/drawing/2014/main" id="{D3960E26-3F9D-400A-9737-04719D3D2D17}"/>
+                <a16:creationId xmlns:a16="http://schemas.microsoft.com/office/drawing/2014/main" id="{EFCB62B5-51B1-4080-B011-80866600A95F}"/>
               </a:ext>
             </a:extLst>
           </p:cNvPr>
@@ -11735,7 +11735,7 @@
           <p:cNvPr id="14" name="c3-text-293">
             <a:extLst xmlns:a="http://schemas.openxmlformats.org/drawingml/2006/main">
               <a:ext uri="{FF2B5EF4-FFF2-40B4-BE49-F238E27FC236}">
-                <a16:creationId xmlns:a16="http://schemas.microsoft.com/office/drawing/2014/main" id="{C24DD92E-30F6-4DE9-83C6-8604F52AD4A1}"/>
+                <a16:creationId xmlns:a16="http://schemas.microsoft.com/office/drawing/2014/main" id="{DA15EF74-2AC4-4164-9783-CE78B2CF4377}"/>
               </a:ext>
             </a:extLst>
           </p:cNvPr>
@@ -11792,7 +11792,7 @@
           <p:cNvPr id="15" name="c3-text-294">
             <a:extLst xmlns:a="http://schemas.openxmlformats.org/drawingml/2006/main">
               <a:ext uri="{FF2B5EF4-FFF2-40B4-BE49-F238E27FC236}">
-                <a16:creationId xmlns:a16="http://schemas.microsoft.com/office/drawing/2014/main" id="{654B2EFF-AB2B-4DEB-A403-5B439C629738}"/>
+                <a16:creationId xmlns:a16="http://schemas.microsoft.com/office/drawing/2014/main" id="{7558ACED-4D0B-4F7D-B76A-D58568B828CF}"/>
               </a:ext>
             </a:extLst>
           </p:cNvPr>
@@ -11849,7 +11849,7 @@
           <p:cNvPr id="16" name="c3-text-295">
             <a:extLst xmlns:a="http://schemas.openxmlformats.org/drawingml/2006/main">
               <a:ext uri="{FF2B5EF4-FFF2-40B4-BE49-F238E27FC236}">
-                <a16:creationId xmlns:a16="http://schemas.microsoft.com/office/drawing/2014/main" id="{46408337-EF66-4E40-B345-8B4932633AE5}"/>
+                <a16:creationId xmlns:a16="http://schemas.microsoft.com/office/drawing/2014/main" id="{4722CBC3-5516-4950-876E-B5105CF04551}"/>
               </a:ext>
             </a:extLst>
           </p:cNvPr>
@@ -11896,7 +11896,7 @@
                 <a:ea typeface="Calibri"/>
                 <a:cs typeface="Calibri"/>
               </a:rPr>
-              <a:t>llm.invoke([system] + context)</a:t>
+              <a:t>prompt + context, then llm.invoke</a:t>
             </a:r>
           </a:p>
         </p:txBody>
@@ -11906,7 +11906,7 @@
           <p:cNvPr id="17" name="c3-text-296">
             <a:extLst xmlns:a="http://schemas.openxmlformats.org/drawingml/2006/main">
               <a:ext uri="{FF2B5EF4-FFF2-40B4-BE49-F238E27FC236}">
-                <a16:creationId xmlns:a16="http://schemas.microsoft.com/office/drawing/2014/main" id="{9838F1FD-12C0-4DA2-B02D-C7E2A072327A}"/>
+                <a16:creationId xmlns:a16="http://schemas.microsoft.com/office/drawing/2014/main" id="{7E44FDE1-CCEF-4E64-8393-F4E245DCD5B4}"/>
               </a:ext>
             </a:extLst>
           </p:cNvPr>
@@ -11963,7 +11963,7 @@
           <p:cNvPr id="18" name="c3-text-297">
             <a:extLst xmlns:a="http://schemas.openxmlformats.org/drawingml/2006/main">
               <a:ext uri="{FF2B5EF4-FFF2-40B4-BE49-F238E27FC236}">
-                <a16:creationId xmlns:a16="http://schemas.microsoft.com/office/drawing/2014/main" id="{8801AC8C-B063-444D-B98A-42E68207167A}"/>
+                <a16:creationId xmlns:a16="http://schemas.microsoft.com/office/drawing/2014/main" id="{4075F2F8-FA17-4F47-A687-ADB8B172C0FF}"/>
               </a:ext>
             </a:extLst>
           </p:cNvPr>
@@ -12018,10 +12018,10 @@
       <p:sp>
         <p:nvSpPr>
           <p:cNvPr id="19" name="c3-text-298">
-            <a:hlinkClick xmlns:r="http://schemas.openxmlformats.org/officeDocument/2006/relationships" xmlns:a="http://schemas.openxmlformats.org/drawingml/2006/main" r:id="Reb2793b2c0bf4b61"/>
-            <a:extLst xmlns:a="http://schemas.openxmlformats.org/drawingml/2006/main">
-              <a:ext uri="{FF2B5EF4-FFF2-40B4-BE49-F238E27FC236}">
-                <a16:creationId xmlns:a16="http://schemas.microsoft.com/office/drawing/2014/main" id="{985E01CB-B4DF-45C5-AC55-6AEC2D932896}"/>
+            <a:hlinkClick xmlns:r="http://schemas.openxmlformats.org/officeDocument/2006/relationships" xmlns:a="http://schemas.openxmlformats.org/drawingml/2006/main" r:id="R2f019b7f3bef4a7f"/>
+            <a:extLst xmlns:a="http://schemas.openxmlformats.org/drawingml/2006/main">
+              <a:ext uri="{FF2B5EF4-FFF2-40B4-BE49-F238E27FC236}">
+                <a16:creationId xmlns:a16="http://schemas.microsoft.com/office/drawing/2014/main" id="{724FE3A5-919A-456B-B891-7B7FE8CF26E6}"/>
               </a:ext>
             </a:extLst>
           </p:cNvPr>
@@ -12078,7 +12078,7 @@
           <p:cNvPr id="20" name="c3-text-396">
             <a:extLst xmlns:a="http://schemas.openxmlformats.org/drawingml/2006/main">
               <a:ext uri="{FF2B5EF4-FFF2-40B4-BE49-F238E27FC236}">
-                <a16:creationId xmlns:a16="http://schemas.microsoft.com/office/drawing/2014/main" id="{1CEF9594-A179-4B8B-BB68-9B7EF1D58552}"/>
+                <a16:creationId xmlns:a16="http://schemas.microsoft.com/office/drawing/2014/main" id="{2D8158E3-F217-4050-999E-8A80F6EBC669}"/>
               </a:ext>
             </a:extLst>
           </p:cNvPr>
@@ -12133,7 +12133,7 @@
     </p:spTree>
     <p:extLst>
       <p:ext uri="{BB962C8B-B14F-4D97-AF65-F5344CB8AC3E}">
-        <p14:creationId xmlns:p14="http://schemas.microsoft.com/office/powerpoint/2010/main" val="548729894"/>
+        <p14:creationId xmlns:p14="http://schemas.microsoft.com/office/powerpoint/2010/main" val="1440473865"/>
       </p:ext>
     </p:extLst>
   </p:cSld>
@@ -12164,7 +12164,7 @@
           <p:cNvPr id="19" name="c3-text-1">
             <a:extLst xmlns:a="http://schemas.openxmlformats.org/drawingml/2006/main">
               <a:ext uri="{FF2B5EF4-FFF2-40B4-BE49-F238E27FC236}">
-                <a16:creationId xmlns:a16="http://schemas.microsoft.com/office/drawing/2014/main" id="{C964DBBB-C21A-4FAE-8FB5-ED0EC96B607B}"/>
+                <a16:creationId xmlns:a16="http://schemas.microsoft.com/office/drawing/2014/main" id="{44104240-7374-4817-A87D-91A43F522575}"/>
               </a:ext>
             </a:extLst>
           </p:cNvPr>
@@ -12221,7 +12221,7 @@
           <p:cNvPr id="2" name="c3-text-2">
             <a:extLst xmlns:a="http://schemas.openxmlformats.org/drawingml/2006/main">
               <a:ext uri="{FF2B5EF4-FFF2-40B4-BE49-F238E27FC236}">
-                <a16:creationId xmlns:a16="http://schemas.microsoft.com/office/drawing/2014/main" id="{03605206-4912-4FE2-994A-F52505E8B1BF}"/>
+                <a16:creationId xmlns:a16="http://schemas.microsoft.com/office/drawing/2014/main" id="{83B79D81-71F9-4886-8B29-33ADFDA40145}"/>
               </a:ext>
             </a:extLst>
           </p:cNvPr>
@@ -12278,7 +12278,7 @@
           <p:cNvPr id="3" name="c3-text-3">
             <a:extLst xmlns:a="http://schemas.openxmlformats.org/drawingml/2006/main">
               <a:ext uri="{FF2B5EF4-FFF2-40B4-BE49-F238E27FC236}">
-                <a16:creationId xmlns:a16="http://schemas.microsoft.com/office/drawing/2014/main" id="{E145C7CF-7BC5-4C16-B430-D11ED850AF1E}"/>
+                <a16:creationId xmlns:a16="http://schemas.microsoft.com/office/drawing/2014/main" id="{202E701C-BD40-45D0-8C54-0288C6E790AC}"/>
               </a:ext>
             </a:extLst>
           </p:cNvPr>
@@ -12335,7 +12335,7 @@
           <p:cNvPr id="4" name="c3-shape-4">
             <a:extLst xmlns:a="http://schemas.openxmlformats.org/drawingml/2006/main">
               <a:ext uri="{FF2B5EF4-FFF2-40B4-BE49-F238E27FC236}">
-                <a16:creationId xmlns:a16="http://schemas.microsoft.com/office/drawing/2014/main" id="{B77985E7-122C-4D2A-B4BD-4BDE28074757}"/>
+                <a16:creationId xmlns:a16="http://schemas.microsoft.com/office/drawing/2014/main" id="{DBA3D037-E5E5-4FB2-BEA8-43E34E176DA1}"/>
               </a:ext>
             </a:extLst>
           </p:cNvPr>
@@ -12369,7 +12369,7 @@
           <p:cNvPr id="5" name="c3-shape-5">
             <a:extLst xmlns:a="http://schemas.openxmlformats.org/drawingml/2006/main">
               <a:ext uri="{FF2B5EF4-FFF2-40B4-BE49-F238E27FC236}">
-                <a16:creationId xmlns:a16="http://schemas.microsoft.com/office/drawing/2014/main" id="{1AC37F9D-A7F7-4ED5-86D1-44274F5C3B43}"/>
+                <a16:creationId xmlns:a16="http://schemas.microsoft.com/office/drawing/2014/main" id="{8A1D0112-DCFE-42B2-9F2B-8CBA7CDF7D4B}"/>
               </a:ext>
             </a:extLst>
           </p:cNvPr>
@@ -12401,7 +12401,7 @@
           <p:cNvPr id="6" name="c3-text-6">
             <a:extLst xmlns:a="http://schemas.openxmlformats.org/drawingml/2006/main">
               <a:ext uri="{FF2B5EF4-FFF2-40B4-BE49-F238E27FC236}">
-                <a16:creationId xmlns:a16="http://schemas.microsoft.com/office/drawing/2014/main" id="{37AE9DE3-1DF0-45AD-846E-1234D1F172EC}"/>
+                <a16:creationId xmlns:a16="http://schemas.microsoft.com/office/drawing/2014/main" id="{81412C67-A9D6-4547-A88F-295E7B974635}"/>
               </a:ext>
             </a:extLst>
           </p:cNvPr>
@@ -12458,7 +12458,7 @@
           <p:cNvPr id="7" name="c3-text-7">
             <a:extLst xmlns:a="http://schemas.openxmlformats.org/drawingml/2006/main">
               <a:ext uri="{FF2B5EF4-FFF2-40B4-BE49-F238E27FC236}">
-                <a16:creationId xmlns:a16="http://schemas.microsoft.com/office/drawing/2014/main" id="{D3A8C0B5-16FD-4F6F-9665-9B7BEAFD92BA}"/>
+                <a16:creationId xmlns:a16="http://schemas.microsoft.com/office/drawing/2014/main" id="{39261D0A-60F6-4C92-B13E-E126188BD337}"/>
               </a:ext>
             </a:extLst>
           </p:cNvPr>
@@ -12538,7 +12538,7 @@
           <p:cNvPr id="8" name="c3-shape-8">
             <a:extLst xmlns:a="http://schemas.openxmlformats.org/drawingml/2006/main">
               <a:ext uri="{FF2B5EF4-FFF2-40B4-BE49-F238E27FC236}">
-                <a16:creationId xmlns:a16="http://schemas.microsoft.com/office/drawing/2014/main" id="{EF13D13A-15B3-4D06-A802-7E4895453DA2}"/>
+                <a16:creationId xmlns:a16="http://schemas.microsoft.com/office/drawing/2014/main" id="{7CD80BD1-5676-47F5-86B7-5195CCE43F9A}"/>
               </a:ext>
             </a:extLst>
           </p:cNvPr>
@@ -12572,7 +12572,7 @@
           <p:cNvPr id="9" name="c3-shape-9">
             <a:extLst xmlns:a="http://schemas.openxmlformats.org/drawingml/2006/main">
               <a:ext uri="{FF2B5EF4-FFF2-40B4-BE49-F238E27FC236}">
-                <a16:creationId xmlns:a16="http://schemas.microsoft.com/office/drawing/2014/main" id="{A3E02240-99E2-4BB4-946B-91676BA6F0CA}"/>
+                <a16:creationId xmlns:a16="http://schemas.microsoft.com/office/drawing/2014/main" id="{DDF39FA9-3397-40EE-BB9D-C995E9D52C7E}"/>
               </a:ext>
             </a:extLst>
           </p:cNvPr>
@@ -12604,7 +12604,7 @@
           <p:cNvPr id="10" name="c3-text-10">
             <a:extLst xmlns:a="http://schemas.openxmlformats.org/drawingml/2006/main">
               <a:ext uri="{FF2B5EF4-FFF2-40B4-BE49-F238E27FC236}">
-                <a16:creationId xmlns:a16="http://schemas.microsoft.com/office/drawing/2014/main" id="{8F349414-2FCB-4186-B2AC-36D384F11CA1}"/>
+                <a16:creationId xmlns:a16="http://schemas.microsoft.com/office/drawing/2014/main" id="{64D9BCF5-9ED8-4B85-9640-B758ED65D30A}"/>
               </a:ext>
             </a:extLst>
           </p:cNvPr>
@@ -12661,7 +12661,7 @@
           <p:cNvPr id="11" name="c3-text-11">
             <a:extLst xmlns:a="http://schemas.openxmlformats.org/drawingml/2006/main">
               <a:ext uri="{FF2B5EF4-FFF2-40B4-BE49-F238E27FC236}">
-                <a16:creationId xmlns:a16="http://schemas.microsoft.com/office/drawing/2014/main" id="{60DA6A3E-24E4-4417-81F9-7BF6F48BBBBA}"/>
+                <a16:creationId xmlns:a16="http://schemas.microsoft.com/office/drawing/2014/main" id="{BC00DBB7-C8AA-48B4-A612-5F88CB9B072D}"/>
               </a:ext>
             </a:extLst>
           </p:cNvPr>
@@ -12718,7 +12718,7 @@
           <p:cNvPr id="12" name="c3-shape-12">
             <a:extLst xmlns:a="http://schemas.openxmlformats.org/drawingml/2006/main">
               <a:ext uri="{FF2B5EF4-FFF2-40B4-BE49-F238E27FC236}">
-                <a16:creationId xmlns:a16="http://schemas.microsoft.com/office/drawing/2014/main" id="{CCFD53FF-EE62-4A46-8DE1-8372FAB1F86D}"/>
+                <a16:creationId xmlns:a16="http://schemas.microsoft.com/office/drawing/2014/main" id="{EEC26C9C-5CFF-4B40-8D4C-29BF7E477136}"/>
               </a:ext>
             </a:extLst>
           </p:cNvPr>
@@ -12752,7 +12752,7 @@
           <p:cNvPr id="13" name="c3-shape-13">
             <a:extLst xmlns:a="http://schemas.openxmlformats.org/drawingml/2006/main">
               <a:ext uri="{FF2B5EF4-FFF2-40B4-BE49-F238E27FC236}">
-                <a16:creationId xmlns:a16="http://schemas.microsoft.com/office/drawing/2014/main" id="{6A67788D-6E61-4F10-8CF2-9C542214D162}"/>
+                <a16:creationId xmlns:a16="http://schemas.microsoft.com/office/drawing/2014/main" id="{156139D6-EF3E-466F-B27D-391E28A11583}"/>
               </a:ext>
             </a:extLst>
           </p:cNvPr>
@@ -12784,7 +12784,7 @@
           <p:cNvPr id="14" name="c3-text-14">
             <a:extLst xmlns:a="http://schemas.openxmlformats.org/drawingml/2006/main">
               <a:ext uri="{FF2B5EF4-FFF2-40B4-BE49-F238E27FC236}">
-                <a16:creationId xmlns:a16="http://schemas.microsoft.com/office/drawing/2014/main" id="{78E98176-214C-48B6-A826-CDE2C7F4D4D9}"/>
+                <a16:creationId xmlns:a16="http://schemas.microsoft.com/office/drawing/2014/main" id="{A2AA37E9-7E6F-4840-B52D-E30DA5543CE5}"/>
               </a:ext>
             </a:extLst>
           </p:cNvPr>
@@ -12841,7 +12841,7 @@
           <p:cNvPr id="15" name="c3-text-15">
             <a:extLst xmlns:a="http://schemas.openxmlformats.org/drawingml/2006/main">
               <a:ext uri="{FF2B5EF4-FFF2-40B4-BE49-F238E27FC236}">
-                <a16:creationId xmlns:a16="http://schemas.microsoft.com/office/drawing/2014/main" id="{39BBC1B7-349F-4800-96F4-059AD0465E14}"/>
+                <a16:creationId xmlns:a16="http://schemas.microsoft.com/office/drawing/2014/main" id="{EB5B2435-AB8D-4275-A427-1EA02C21E68B}"/>
               </a:ext>
             </a:extLst>
           </p:cNvPr>
@@ -12898,7 +12898,7 @@
           <p:cNvPr id="16" name="c3-shape-16">
             <a:extLst xmlns:a="http://schemas.openxmlformats.org/drawingml/2006/main">
               <a:ext uri="{FF2B5EF4-FFF2-40B4-BE49-F238E27FC236}">
-                <a16:creationId xmlns:a16="http://schemas.microsoft.com/office/drawing/2014/main" id="{89D4A7E2-DD9A-4428-BC03-7FFF4F051665}"/>
+                <a16:creationId xmlns:a16="http://schemas.microsoft.com/office/drawing/2014/main" id="{5830D326-A9AD-4B06-A19B-1AB7B51989E4}"/>
               </a:ext>
             </a:extLst>
           </p:cNvPr>
@@ -12932,7 +12932,7 @@
           <p:cNvPr id="17" name="c3-text-17">
             <a:extLst xmlns:a="http://schemas.openxmlformats.org/drawingml/2006/main">
               <a:ext uri="{FF2B5EF4-FFF2-40B4-BE49-F238E27FC236}">
-                <a16:creationId xmlns:a16="http://schemas.microsoft.com/office/drawing/2014/main" id="{30D90293-EDEA-48B1-A693-61A1BF870190}"/>
+                <a16:creationId xmlns:a16="http://schemas.microsoft.com/office/drawing/2014/main" id="{477B126D-6D82-4D22-B373-CF63A6E5986C}"/>
               </a:ext>
             </a:extLst>
           </p:cNvPr>
@@ -12989,7 +12989,7 @@
           <p:cNvPr id="18" name="c3-text-379">
             <a:extLst xmlns:a="http://schemas.openxmlformats.org/drawingml/2006/main">
               <a:ext uri="{FF2B5EF4-FFF2-40B4-BE49-F238E27FC236}">
-                <a16:creationId xmlns:a16="http://schemas.microsoft.com/office/drawing/2014/main" id="{5181321B-D285-4AB9-AD0C-2B566C9AF3E5}"/>
+                <a16:creationId xmlns:a16="http://schemas.microsoft.com/office/drawing/2014/main" id="{89A6740B-74AE-4D09-B793-F683EFD57CED}"/>
               </a:ext>
             </a:extLst>
           </p:cNvPr>
@@ -13044,7 +13044,7 @@
     </p:spTree>
     <p:extLst>
       <p:ext uri="{BB962C8B-B14F-4D97-AF65-F5344CB8AC3E}">
-        <p14:creationId xmlns:p14="http://schemas.microsoft.com/office/powerpoint/2010/main" val="1987584658"/>
+        <p14:creationId xmlns:p14="http://schemas.microsoft.com/office/powerpoint/2010/main" val="1280439708"/>
       </p:ext>
     </p:extLst>
   </p:cSld>
@@ -13075,7 +13075,7 @@
           <p:cNvPr id="31" name="c3-text-299">
             <a:extLst xmlns:a="http://schemas.openxmlformats.org/drawingml/2006/main">
               <a:ext uri="{FF2B5EF4-FFF2-40B4-BE49-F238E27FC236}">
-                <a16:creationId xmlns:a16="http://schemas.microsoft.com/office/drawing/2014/main" id="{71D44FE0-4170-4724-AFEB-1717D3229D3D}"/>
+                <a16:creationId xmlns:a16="http://schemas.microsoft.com/office/drawing/2014/main" id="{D88B13DF-CC14-4CE8-9BF1-7948E476AF5B}"/>
               </a:ext>
             </a:extLst>
           </p:cNvPr>
@@ -13132,7 +13132,7 @@
           <p:cNvPr id="2" name="c3-text-300">
             <a:extLst xmlns:a="http://schemas.openxmlformats.org/drawingml/2006/main">
               <a:ext uri="{FF2B5EF4-FFF2-40B4-BE49-F238E27FC236}">
-                <a16:creationId xmlns:a16="http://schemas.microsoft.com/office/drawing/2014/main" id="{6716659A-4489-4E4F-9AA8-21ABE9805EA9}"/>
+                <a16:creationId xmlns:a16="http://schemas.microsoft.com/office/drawing/2014/main" id="{99B2977F-A240-4928-B9E9-BA6C6AD80330}"/>
               </a:ext>
             </a:extLst>
           </p:cNvPr>
@@ -13189,7 +13189,7 @@
           <p:cNvPr id="3" name="c3-text-301">
             <a:extLst xmlns:a="http://schemas.openxmlformats.org/drawingml/2006/main">
               <a:ext uri="{FF2B5EF4-FFF2-40B4-BE49-F238E27FC236}">
-                <a16:creationId xmlns:a16="http://schemas.microsoft.com/office/drawing/2014/main" id="{3FDABA5A-A0FB-4710-AB60-61B77616835F}"/>
+                <a16:creationId xmlns:a16="http://schemas.microsoft.com/office/drawing/2014/main" id="{ACEAF643-4996-4ED5-AE9B-1D022C1FCFD4}"/>
               </a:ext>
             </a:extLst>
           </p:cNvPr>
@@ -13246,7 +13246,7 @@
           <p:cNvPr id="4" name="c3-shape-302">
             <a:extLst xmlns:a="http://schemas.openxmlformats.org/drawingml/2006/main">
               <a:ext uri="{FF2B5EF4-FFF2-40B4-BE49-F238E27FC236}">
-                <a16:creationId xmlns:a16="http://schemas.microsoft.com/office/drawing/2014/main" id="{72C5CFF3-5947-46D5-876B-C839EDD6B7C3}"/>
+                <a16:creationId xmlns:a16="http://schemas.microsoft.com/office/drawing/2014/main" id="{45C86384-1D04-4BAC-A9B7-E9B2C1A6FE31}"/>
               </a:ext>
             </a:extLst>
           </p:cNvPr>
@@ -13280,7 +13280,7 @@
           <p:cNvPr id="5" name="c3-text-303">
             <a:extLst xmlns:a="http://schemas.openxmlformats.org/drawingml/2006/main">
               <a:ext uri="{FF2B5EF4-FFF2-40B4-BE49-F238E27FC236}">
-                <a16:creationId xmlns:a16="http://schemas.microsoft.com/office/drawing/2014/main" id="{D7222E3B-1F3E-4FD0-BA7A-56B054FC33DC}"/>
+                <a16:creationId xmlns:a16="http://schemas.microsoft.com/office/drawing/2014/main" id="{748A10FB-F1CC-4378-ACD5-A8C6F64756EA}"/>
               </a:ext>
             </a:extLst>
           </p:cNvPr>
@@ -13337,7 +13337,7 @@
           <p:cNvPr id="6" name="c3-shape-304">
             <a:extLst xmlns:a="http://schemas.openxmlformats.org/drawingml/2006/main">
               <a:ext uri="{FF2B5EF4-FFF2-40B4-BE49-F238E27FC236}">
-                <a16:creationId xmlns:a16="http://schemas.microsoft.com/office/drawing/2014/main" id="{642FD87F-0990-492D-AA01-636B4A2C627B}"/>
+                <a16:creationId xmlns:a16="http://schemas.microsoft.com/office/drawing/2014/main" id="{545E6EF8-1021-4E74-AC88-9EE95A9E940B}"/>
               </a:ext>
             </a:extLst>
           </p:cNvPr>
@@ -13369,7 +13369,7 @@
           <p:cNvPr id="7" name="c3-shape-305">
             <a:extLst xmlns:a="http://schemas.openxmlformats.org/drawingml/2006/main">
               <a:ext uri="{FF2B5EF4-FFF2-40B4-BE49-F238E27FC236}">
-                <a16:creationId xmlns:a16="http://schemas.microsoft.com/office/drawing/2014/main" id="{FFF5B061-D87A-4557-B167-8A7FC216799C}"/>
+                <a16:creationId xmlns:a16="http://schemas.microsoft.com/office/drawing/2014/main" id="{1E81E3EE-3CD2-4FCF-832C-5431C60158FE}"/>
               </a:ext>
             </a:extLst>
           </p:cNvPr>
@@ -13403,7 +13403,7 @@
           <p:cNvPr id="8" name="c3-text-306">
             <a:extLst xmlns:a="http://schemas.openxmlformats.org/drawingml/2006/main">
               <a:ext uri="{FF2B5EF4-FFF2-40B4-BE49-F238E27FC236}">
-                <a16:creationId xmlns:a16="http://schemas.microsoft.com/office/drawing/2014/main" id="{B51AD970-60F5-4524-BD6C-F9CF52662909}"/>
+                <a16:creationId xmlns:a16="http://schemas.microsoft.com/office/drawing/2014/main" id="{36B85E9E-2BC8-49EF-A6DA-406542A57C98}"/>
               </a:ext>
             </a:extLst>
           </p:cNvPr>
@@ -13460,7 +13460,7 @@
           <p:cNvPr id="9" name="c3-shape-307">
             <a:extLst xmlns:a="http://schemas.openxmlformats.org/drawingml/2006/main">
               <a:ext uri="{FF2B5EF4-FFF2-40B4-BE49-F238E27FC236}">
-                <a16:creationId xmlns:a16="http://schemas.microsoft.com/office/drawing/2014/main" id="{6ED296A1-377E-4095-8555-941197B83C60}"/>
+                <a16:creationId xmlns:a16="http://schemas.microsoft.com/office/drawing/2014/main" id="{E716A095-29A6-436E-B0A8-D0D27FB84BF9}"/>
               </a:ext>
             </a:extLst>
           </p:cNvPr>
@@ -13492,7 +13492,7 @@
           <p:cNvPr id="10" name="c3-shape-308">
             <a:extLst xmlns:a="http://schemas.openxmlformats.org/drawingml/2006/main">
               <a:ext uri="{FF2B5EF4-FFF2-40B4-BE49-F238E27FC236}">
-                <a16:creationId xmlns:a16="http://schemas.microsoft.com/office/drawing/2014/main" id="{C5A7A9D8-F7CA-42CE-A202-54A34027B66E}"/>
+                <a16:creationId xmlns:a16="http://schemas.microsoft.com/office/drawing/2014/main" id="{8115F2E7-4675-41A7-A6B9-A3C465EA7174}"/>
               </a:ext>
             </a:extLst>
           </p:cNvPr>
@@ -13526,7 +13526,7 @@
           <p:cNvPr id="11" name="c3-text-309">
             <a:extLst xmlns:a="http://schemas.openxmlformats.org/drawingml/2006/main">
               <a:ext uri="{FF2B5EF4-FFF2-40B4-BE49-F238E27FC236}">
-                <a16:creationId xmlns:a16="http://schemas.microsoft.com/office/drawing/2014/main" id="{477FF94C-F5EA-4421-96F4-3999B60F6723}"/>
+                <a16:creationId xmlns:a16="http://schemas.microsoft.com/office/drawing/2014/main" id="{43485948-773B-4E13-8C7E-F453590962F9}"/>
               </a:ext>
             </a:extLst>
           </p:cNvPr>
@@ -13583,7 +13583,7 @@
           <p:cNvPr id="12" name="c3-shape-310">
             <a:extLst xmlns:a="http://schemas.openxmlformats.org/drawingml/2006/main">
               <a:ext uri="{FF2B5EF4-FFF2-40B4-BE49-F238E27FC236}">
-                <a16:creationId xmlns:a16="http://schemas.microsoft.com/office/drawing/2014/main" id="{DF32D7AD-0FAC-4100-9E0D-D4A226760CB1}"/>
+                <a16:creationId xmlns:a16="http://schemas.microsoft.com/office/drawing/2014/main" id="{8EF70A54-EFD6-4F0C-8052-3FD73655FB8E}"/>
               </a:ext>
             </a:extLst>
           </p:cNvPr>
@@ -13615,7 +13615,7 @@
           <p:cNvPr id="13" name="c3-shape-311">
             <a:extLst xmlns:a="http://schemas.openxmlformats.org/drawingml/2006/main">
               <a:ext uri="{FF2B5EF4-FFF2-40B4-BE49-F238E27FC236}">
-                <a16:creationId xmlns:a16="http://schemas.microsoft.com/office/drawing/2014/main" id="{F57262D6-04A5-48FC-B45F-B0F8199F2BB2}"/>
+                <a16:creationId xmlns:a16="http://schemas.microsoft.com/office/drawing/2014/main" id="{892D4EA3-7333-46FB-9338-59C81224B369}"/>
               </a:ext>
             </a:extLst>
           </p:cNvPr>
@@ -13649,7 +13649,7 @@
           <p:cNvPr id="14" name="c3-text-312">
             <a:extLst xmlns:a="http://schemas.openxmlformats.org/drawingml/2006/main">
               <a:ext uri="{FF2B5EF4-FFF2-40B4-BE49-F238E27FC236}">
-                <a16:creationId xmlns:a16="http://schemas.microsoft.com/office/drawing/2014/main" id="{205A3093-AAB5-4206-95C4-0BDC4C31C563}"/>
+                <a16:creationId xmlns:a16="http://schemas.microsoft.com/office/drawing/2014/main" id="{23B1C724-3B7F-4444-80BA-A01B69F71E2B}"/>
               </a:ext>
             </a:extLst>
           </p:cNvPr>
@@ -13706,7 +13706,7 @@
           <p:cNvPr id="15" name="c3-shape-313">
             <a:extLst xmlns:a="http://schemas.openxmlformats.org/drawingml/2006/main">
               <a:ext uri="{FF2B5EF4-FFF2-40B4-BE49-F238E27FC236}">
-                <a16:creationId xmlns:a16="http://schemas.microsoft.com/office/drawing/2014/main" id="{222D291E-D310-46D3-94A7-1F432F8F52E9}"/>
+                <a16:creationId xmlns:a16="http://schemas.microsoft.com/office/drawing/2014/main" id="{3410EC82-03CC-44D8-BA1A-4F97CBC65778}"/>
               </a:ext>
             </a:extLst>
           </p:cNvPr>
@@ -13740,7 +13740,7 @@
           <p:cNvPr id="16" name="c3-text-314">
             <a:extLst xmlns:a="http://schemas.openxmlformats.org/drawingml/2006/main">
               <a:ext uri="{FF2B5EF4-FFF2-40B4-BE49-F238E27FC236}">
-                <a16:creationId xmlns:a16="http://schemas.microsoft.com/office/drawing/2014/main" id="{6AA3D28D-B4A8-4B48-A6D9-7160FA800940}"/>
+                <a16:creationId xmlns:a16="http://schemas.microsoft.com/office/drawing/2014/main" id="{22738484-C29E-4ACF-BFA7-BA21FA980A07}"/>
               </a:ext>
             </a:extLst>
           </p:cNvPr>
@@ -13797,7 +13797,7 @@
           <p:cNvPr id="17" name="c3-shape-315">
             <a:extLst xmlns:a="http://schemas.openxmlformats.org/drawingml/2006/main">
               <a:ext uri="{FF2B5EF4-FFF2-40B4-BE49-F238E27FC236}">
-                <a16:creationId xmlns:a16="http://schemas.microsoft.com/office/drawing/2014/main" id="{746599EB-C73D-4E37-B7BC-F827E9F75BDE}"/>
+                <a16:creationId xmlns:a16="http://schemas.microsoft.com/office/drawing/2014/main" id="{DCF3395B-0C24-4E9C-8EE5-B239481E3BD1}"/>
               </a:ext>
             </a:extLst>
           </p:cNvPr>
@@ -13829,7 +13829,7 @@
           <p:cNvPr id="18" name="c3-text-316">
             <a:extLst xmlns:a="http://schemas.openxmlformats.org/drawingml/2006/main">
               <a:ext uri="{FF2B5EF4-FFF2-40B4-BE49-F238E27FC236}">
-                <a16:creationId xmlns:a16="http://schemas.microsoft.com/office/drawing/2014/main" id="{A8850F83-9639-4B24-AFD9-71569047476D}"/>
+                <a16:creationId xmlns:a16="http://schemas.microsoft.com/office/drawing/2014/main" id="{E831124A-4BAD-4691-BDB1-9C9B28AFF653}"/>
               </a:ext>
             </a:extLst>
           </p:cNvPr>
@@ -13886,7 +13886,7 @@
           <p:cNvPr id="19" name="c3-text-317">
             <a:extLst xmlns:a="http://schemas.openxmlformats.org/drawingml/2006/main">
               <a:ext uri="{FF2B5EF4-FFF2-40B4-BE49-F238E27FC236}">
-                <a16:creationId xmlns:a16="http://schemas.microsoft.com/office/drawing/2014/main" id="{72081F6C-BE87-480A-ADDD-E6D6D560385F}"/>
+                <a16:creationId xmlns:a16="http://schemas.microsoft.com/office/drawing/2014/main" id="{1483E4D5-1E60-4BDD-A276-E323B5A0557C}"/>
               </a:ext>
             </a:extLst>
           </p:cNvPr>
@@ -13943,7 +13943,7 @@
           <p:cNvPr id="20" name="c3-text-318">
             <a:extLst xmlns:a="http://schemas.openxmlformats.org/drawingml/2006/main">
               <a:ext uri="{FF2B5EF4-FFF2-40B4-BE49-F238E27FC236}">
-                <a16:creationId xmlns:a16="http://schemas.microsoft.com/office/drawing/2014/main" id="{BE8B3259-2F33-4D97-93EE-AE0DCA96FD02}"/>
+                <a16:creationId xmlns:a16="http://schemas.microsoft.com/office/drawing/2014/main" id="{C52CAF84-1EEF-4DD9-9C99-BDA1DF29FB68}"/>
               </a:ext>
             </a:extLst>
           </p:cNvPr>
@@ -14000,7 +14000,7 @@
           <p:cNvPr id="21" name="c3-shape-319">
             <a:extLst xmlns:a="http://schemas.openxmlformats.org/drawingml/2006/main">
               <a:ext uri="{FF2B5EF4-FFF2-40B4-BE49-F238E27FC236}">
-                <a16:creationId xmlns:a16="http://schemas.microsoft.com/office/drawing/2014/main" id="{71F3041E-9349-4F4C-9AB7-750DF9EC8FA3}"/>
+                <a16:creationId xmlns:a16="http://schemas.microsoft.com/office/drawing/2014/main" id="{28CF81A9-3BD8-4D1C-8E5B-E4EB4605658A}"/>
               </a:ext>
             </a:extLst>
           </p:cNvPr>
@@ -14034,7 +14034,7 @@
           <p:cNvPr id="22" name="c3-shape-320">
             <a:extLst xmlns:a="http://schemas.openxmlformats.org/drawingml/2006/main">
               <a:ext uri="{FF2B5EF4-FFF2-40B4-BE49-F238E27FC236}">
-                <a16:creationId xmlns:a16="http://schemas.microsoft.com/office/drawing/2014/main" id="{292746EB-F8D0-4BA9-BBE2-147B0B38C073}"/>
+                <a16:creationId xmlns:a16="http://schemas.microsoft.com/office/drawing/2014/main" id="{F4829A34-60B3-4872-B9D7-B3BCC228E8FC}"/>
               </a:ext>
             </a:extLst>
           </p:cNvPr>
@@ -14066,7 +14066,7 @@
           <p:cNvPr id="23" name="c3-text-321">
             <a:extLst xmlns:a="http://schemas.openxmlformats.org/drawingml/2006/main">
               <a:ext uri="{FF2B5EF4-FFF2-40B4-BE49-F238E27FC236}">
-                <a16:creationId xmlns:a16="http://schemas.microsoft.com/office/drawing/2014/main" id="{6C4AF0EF-5B6B-4CE5-8E56-1873811AC1B9}"/>
+                <a16:creationId xmlns:a16="http://schemas.microsoft.com/office/drawing/2014/main" id="{1CA2180A-9783-488C-869E-FAA6343655EB}"/>
               </a:ext>
             </a:extLst>
           </p:cNvPr>
@@ -14123,7 +14123,7 @@
           <p:cNvPr id="24" name="c3-text-322">
             <a:extLst xmlns:a="http://schemas.openxmlformats.org/drawingml/2006/main">
               <a:ext uri="{FF2B5EF4-FFF2-40B4-BE49-F238E27FC236}">
-                <a16:creationId xmlns:a16="http://schemas.microsoft.com/office/drawing/2014/main" id="{2324C627-8DC4-4FE9-AE1C-86717EA7F5C8}"/>
+                <a16:creationId xmlns:a16="http://schemas.microsoft.com/office/drawing/2014/main" id="{E4007D94-120E-4A39-8AEF-7A5C8D70FBC7}"/>
               </a:ext>
             </a:extLst>
           </p:cNvPr>
@@ -14180,7 +14180,7 @@
           <p:cNvPr id="25" name="c3-shape-323">
             <a:extLst xmlns:a="http://schemas.openxmlformats.org/drawingml/2006/main">
               <a:ext uri="{FF2B5EF4-FFF2-40B4-BE49-F238E27FC236}">
-                <a16:creationId xmlns:a16="http://schemas.microsoft.com/office/drawing/2014/main" id="{67217CE2-F58D-4AEE-8C7C-DD8B2571A505}"/>
+                <a16:creationId xmlns:a16="http://schemas.microsoft.com/office/drawing/2014/main" id="{BC419611-5379-408D-B489-362ACA83CE2C}"/>
               </a:ext>
             </a:extLst>
           </p:cNvPr>
@@ -14214,7 +14214,7 @@
           <p:cNvPr id="26" name="c3-shape-324">
             <a:extLst xmlns:a="http://schemas.openxmlformats.org/drawingml/2006/main">
               <a:ext uri="{FF2B5EF4-FFF2-40B4-BE49-F238E27FC236}">
-                <a16:creationId xmlns:a16="http://schemas.microsoft.com/office/drawing/2014/main" id="{5927C205-A6AD-4924-AC50-512C8B245D7C}"/>
+                <a16:creationId xmlns:a16="http://schemas.microsoft.com/office/drawing/2014/main" id="{D2C28924-A5A1-41A6-ADD6-163D17D5ADDB}"/>
               </a:ext>
             </a:extLst>
           </p:cNvPr>
@@ -14246,7 +14246,7 @@
           <p:cNvPr id="27" name="c3-text-325">
             <a:extLst xmlns:a="http://schemas.openxmlformats.org/drawingml/2006/main">
               <a:ext uri="{FF2B5EF4-FFF2-40B4-BE49-F238E27FC236}">
-                <a16:creationId xmlns:a16="http://schemas.microsoft.com/office/drawing/2014/main" id="{F30270CE-D923-4B71-A12F-AC4832731375}"/>
+                <a16:creationId xmlns:a16="http://schemas.microsoft.com/office/drawing/2014/main" id="{A2CC44B5-FA34-454A-9D7B-D45FF5D342AE}"/>
               </a:ext>
             </a:extLst>
           </p:cNvPr>
@@ -14303,7 +14303,7 @@
           <p:cNvPr id="28" name="c3-text-326">
             <a:extLst xmlns:a="http://schemas.openxmlformats.org/drawingml/2006/main">
               <a:ext uri="{FF2B5EF4-FFF2-40B4-BE49-F238E27FC236}">
-                <a16:creationId xmlns:a16="http://schemas.microsoft.com/office/drawing/2014/main" id="{B74A1526-E018-460D-A477-55B80381C94E}"/>
+                <a16:creationId xmlns:a16="http://schemas.microsoft.com/office/drawing/2014/main" id="{495E5BB7-8BF0-4412-9595-F1F7B841D58A}"/>
               </a:ext>
             </a:extLst>
           </p:cNvPr>
@@ -14358,10 +14358,10 @@
       <p:sp>
         <p:nvSpPr>
           <p:cNvPr id="29" name="c3-text-327">
-            <a:hlinkClick xmlns:r="http://schemas.openxmlformats.org/officeDocument/2006/relationships" xmlns:a="http://schemas.openxmlformats.org/drawingml/2006/main" r:id="R34bec3723dc4467f"/>
-            <a:extLst xmlns:a="http://schemas.openxmlformats.org/drawingml/2006/main">
-              <a:ext uri="{FF2B5EF4-FFF2-40B4-BE49-F238E27FC236}">
-                <a16:creationId xmlns:a16="http://schemas.microsoft.com/office/drawing/2014/main" id="{929993CA-777B-4C13-A16D-1C951F44B35B}"/>
+            <a:hlinkClick xmlns:r="http://schemas.openxmlformats.org/officeDocument/2006/relationships" xmlns:a="http://schemas.openxmlformats.org/drawingml/2006/main" r:id="R3f9e9ed6517f4439"/>
+            <a:extLst xmlns:a="http://schemas.openxmlformats.org/drawingml/2006/main">
+              <a:ext uri="{FF2B5EF4-FFF2-40B4-BE49-F238E27FC236}">
+                <a16:creationId xmlns:a16="http://schemas.microsoft.com/office/drawing/2014/main" id="{72FF8A8F-3C89-479D-9052-AE36038B793A}"/>
               </a:ext>
             </a:extLst>
           </p:cNvPr>
@@ -14418,7 +14418,7 @@
           <p:cNvPr id="30" name="c3-text-397">
             <a:extLst xmlns:a="http://schemas.openxmlformats.org/drawingml/2006/main">
               <a:ext uri="{FF2B5EF4-FFF2-40B4-BE49-F238E27FC236}">
-                <a16:creationId xmlns:a16="http://schemas.microsoft.com/office/drawing/2014/main" id="{29D6E05B-D24C-4025-BB61-FA1A49745C14}"/>
+                <a16:creationId xmlns:a16="http://schemas.microsoft.com/office/drawing/2014/main" id="{D16B13B0-FE92-4536-8C35-7E62615FC7A8}"/>
               </a:ext>
             </a:extLst>
           </p:cNvPr>
@@ -14473,7 +14473,7 @@
     </p:spTree>
     <p:extLst>
       <p:ext uri="{BB962C8B-B14F-4D97-AF65-F5344CB8AC3E}">
-        <p14:creationId xmlns:p14="http://schemas.microsoft.com/office/powerpoint/2010/main" val="2016809016"/>
+        <p14:creationId xmlns:p14="http://schemas.microsoft.com/office/powerpoint/2010/main" val="586853981"/>
       </p:ext>
     </p:extLst>
   </p:cSld>
@@ -14504,7 +14504,7 @@
           <p:cNvPr id="15" name="c3-text-328">
             <a:extLst xmlns:a="http://schemas.openxmlformats.org/drawingml/2006/main">
               <a:ext uri="{FF2B5EF4-FFF2-40B4-BE49-F238E27FC236}">
-                <a16:creationId xmlns:a16="http://schemas.microsoft.com/office/drawing/2014/main" id="{483E134B-AF2B-48A5-97A8-F052B2E1CA84}"/>
+                <a16:creationId xmlns:a16="http://schemas.microsoft.com/office/drawing/2014/main" id="{15BEF1D2-BE11-4B78-8D94-AD3D53352ABF}"/>
               </a:ext>
             </a:extLst>
           </p:cNvPr>
@@ -14561,7 +14561,7 @@
           <p:cNvPr id="2" name="c3-text-329">
             <a:extLst xmlns:a="http://schemas.openxmlformats.org/drawingml/2006/main">
               <a:ext uri="{FF2B5EF4-FFF2-40B4-BE49-F238E27FC236}">
-                <a16:creationId xmlns:a16="http://schemas.microsoft.com/office/drawing/2014/main" id="{38615EF4-6F78-4607-82FE-D08F163F3DD1}"/>
+                <a16:creationId xmlns:a16="http://schemas.microsoft.com/office/drawing/2014/main" id="{19CCF2EE-A46D-4BC8-AA39-D5B8B8C42A4C}"/>
               </a:ext>
             </a:extLst>
           </p:cNvPr>
@@ -14618,7 +14618,7 @@
           <p:cNvPr id="3" name="c3-text-330">
             <a:extLst xmlns:a="http://schemas.openxmlformats.org/drawingml/2006/main">
               <a:ext uri="{FF2B5EF4-FFF2-40B4-BE49-F238E27FC236}">
-                <a16:creationId xmlns:a16="http://schemas.microsoft.com/office/drawing/2014/main" id="{B4C757BB-C488-44F2-AEF1-3A239762030B}"/>
+                <a16:creationId xmlns:a16="http://schemas.microsoft.com/office/drawing/2014/main" id="{ADDF4256-BB60-442B-BCF0-62E112EB9119}"/>
               </a:ext>
             </a:extLst>
           </p:cNvPr>
@@ -14675,7 +14675,7 @@
           <p:cNvPr id="4" name="c3-shape-331">
             <a:extLst xmlns:a="http://schemas.openxmlformats.org/drawingml/2006/main">
               <a:ext uri="{FF2B5EF4-FFF2-40B4-BE49-F238E27FC236}">
-                <a16:creationId xmlns:a16="http://schemas.microsoft.com/office/drawing/2014/main" id="{8ECE1C9D-CE7E-4263-86B8-B72CC31BB393}"/>
+                <a16:creationId xmlns:a16="http://schemas.microsoft.com/office/drawing/2014/main" id="{62BB283A-C6E1-4F5F-B28E-8B9DD9717812}"/>
               </a:ext>
             </a:extLst>
           </p:cNvPr>
@@ -14709,7 +14709,7 @@
           <p:cNvPr id="5" name="c3-shape-332">
             <a:extLst xmlns:a="http://schemas.openxmlformats.org/drawingml/2006/main">
               <a:ext uri="{FF2B5EF4-FFF2-40B4-BE49-F238E27FC236}">
-                <a16:creationId xmlns:a16="http://schemas.microsoft.com/office/drawing/2014/main" id="{503F4497-53A7-4EA3-A41D-01A69A8DC228}"/>
+                <a16:creationId xmlns:a16="http://schemas.microsoft.com/office/drawing/2014/main" id="{675BA125-184D-45E1-82DF-C334A5CA3E6B}"/>
               </a:ext>
             </a:extLst>
           </p:cNvPr>
@@ -14741,7 +14741,7 @@
           <p:cNvPr id="6" name="c3-text-333">
             <a:extLst xmlns:a="http://schemas.openxmlformats.org/drawingml/2006/main">
               <a:ext uri="{FF2B5EF4-FFF2-40B4-BE49-F238E27FC236}">
-                <a16:creationId xmlns:a16="http://schemas.microsoft.com/office/drawing/2014/main" id="{D75D7BD0-84BA-43C5-9E8B-969D7F742833}"/>
+                <a16:creationId xmlns:a16="http://schemas.microsoft.com/office/drawing/2014/main" id="{2C687C4A-C112-4565-9A11-FF6C1308BF3B}"/>
               </a:ext>
             </a:extLst>
           </p:cNvPr>
@@ -14798,7 +14798,7 @@
           <p:cNvPr id="7" name="c3-text-334">
             <a:extLst xmlns:a="http://schemas.openxmlformats.org/drawingml/2006/main">
               <a:ext uri="{FF2B5EF4-FFF2-40B4-BE49-F238E27FC236}">
-                <a16:creationId xmlns:a16="http://schemas.microsoft.com/office/drawing/2014/main" id="{2B713AB9-33D2-410E-A82B-45F080777D15}"/>
+                <a16:creationId xmlns:a16="http://schemas.microsoft.com/office/drawing/2014/main" id="{7D70B595-18FB-4A47-B640-F52A069483A2}"/>
               </a:ext>
             </a:extLst>
           </p:cNvPr>
@@ -14878,7 +14878,7 @@
           <p:cNvPr id="8" name="c3-shape-335">
             <a:extLst xmlns:a="http://schemas.openxmlformats.org/drawingml/2006/main">
               <a:ext uri="{FF2B5EF4-FFF2-40B4-BE49-F238E27FC236}">
-                <a16:creationId xmlns:a16="http://schemas.microsoft.com/office/drawing/2014/main" id="{248A9DCA-F074-4006-9A08-8B19E7C3661D}"/>
+                <a16:creationId xmlns:a16="http://schemas.microsoft.com/office/drawing/2014/main" id="{2E406382-6EE1-451B-9783-BABC185355B4}"/>
               </a:ext>
             </a:extLst>
           </p:cNvPr>
@@ -14912,7 +14912,7 @@
           <p:cNvPr id="9" name="c3-shape-336">
             <a:extLst xmlns:a="http://schemas.openxmlformats.org/drawingml/2006/main">
               <a:ext uri="{FF2B5EF4-FFF2-40B4-BE49-F238E27FC236}">
-                <a16:creationId xmlns:a16="http://schemas.microsoft.com/office/drawing/2014/main" id="{CE00B1E7-76E7-410F-84C6-3D5D739401F6}"/>
+                <a16:creationId xmlns:a16="http://schemas.microsoft.com/office/drawing/2014/main" id="{A39C3176-5CC6-41CE-9C65-81C9476F0A2B}"/>
               </a:ext>
             </a:extLst>
           </p:cNvPr>
@@ -14944,7 +14944,7 @@
           <p:cNvPr id="10" name="c3-text-337">
             <a:extLst xmlns:a="http://schemas.openxmlformats.org/drawingml/2006/main">
               <a:ext uri="{FF2B5EF4-FFF2-40B4-BE49-F238E27FC236}">
-                <a16:creationId xmlns:a16="http://schemas.microsoft.com/office/drawing/2014/main" id="{6DF1DE0C-05D7-4DB8-B458-8303A640B250}"/>
+                <a16:creationId xmlns:a16="http://schemas.microsoft.com/office/drawing/2014/main" id="{E96F0968-6537-49E9-B617-B3902F3BD1CB}"/>
               </a:ext>
             </a:extLst>
           </p:cNvPr>
@@ -15001,7 +15001,7 @@
           <p:cNvPr id="11" name="c3-text-338">
             <a:extLst xmlns:a="http://schemas.openxmlformats.org/drawingml/2006/main">
               <a:ext uri="{FF2B5EF4-FFF2-40B4-BE49-F238E27FC236}">
-                <a16:creationId xmlns:a16="http://schemas.microsoft.com/office/drawing/2014/main" id="{8F8F14DE-4B60-4A79-8382-7E8CE015812F}"/>
+                <a16:creationId xmlns:a16="http://schemas.microsoft.com/office/drawing/2014/main" id="{FD0896A7-370A-417E-B499-4C79780F635D}"/>
               </a:ext>
             </a:extLst>
           </p:cNvPr>
@@ -15104,7 +15104,7 @@
           <p:cNvPr id="12" name="c3-shape-339">
             <a:extLst xmlns:a="http://schemas.openxmlformats.org/drawingml/2006/main">
               <a:ext uri="{FF2B5EF4-FFF2-40B4-BE49-F238E27FC236}">
-                <a16:creationId xmlns:a16="http://schemas.microsoft.com/office/drawing/2014/main" id="{F1CF640F-82C9-4054-A104-A42727948AB7}"/>
+                <a16:creationId xmlns:a16="http://schemas.microsoft.com/office/drawing/2014/main" id="{E4FDDAB8-6B6D-4EB3-8A2B-A96E496AEE0F}"/>
               </a:ext>
             </a:extLst>
           </p:cNvPr>
@@ -15138,7 +15138,7 @@
           <p:cNvPr id="13" name="c3-text-340">
             <a:extLst xmlns:a="http://schemas.openxmlformats.org/drawingml/2006/main">
               <a:ext uri="{FF2B5EF4-FFF2-40B4-BE49-F238E27FC236}">
-                <a16:creationId xmlns:a16="http://schemas.microsoft.com/office/drawing/2014/main" id="{3DCF99D8-4BBB-4B50-B6C6-CA9842F7B691}"/>
+                <a16:creationId xmlns:a16="http://schemas.microsoft.com/office/drawing/2014/main" id="{93E70CD2-AA34-4255-A6D3-509AC1A11063}"/>
               </a:ext>
             </a:extLst>
           </p:cNvPr>
@@ -15195,7 +15195,7 @@
           <p:cNvPr id="14" name="c3-text-398">
             <a:extLst xmlns:a="http://schemas.openxmlformats.org/drawingml/2006/main">
               <a:ext uri="{FF2B5EF4-FFF2-40B4-BE49-F238E27FC236}">
-                <a16:creationId xmlns:a16="http://schemas.microsoft.com/office/drawing/2014/main" id="{B3FB752A-E1A3-4063-B270-DD818241DBFD}"/>
+                <a16:creationId xmlns:a16="http://schemas.microsoft.com/office/drawing/2014/main" id="{EF52C6B9-31E3-419E-9921-551A802E8399}"/>
               </a:ext>
             </a:extLst>
           </p:cNvPr>
@@ -15250,7 +15250,7 @@
     </p:spTree>
     <p:extLst>
       <p:ext uri="{BB962C8B-B14F-4D97-AF65-F5344CB8AC3E}">
-        <p14:creationId xmlns:p14="http://schemas.microsoft.com/office/powerpoint/2010/main" val="289616787"/>
+        <p14:creationId xmlns:p14="http://schemas.microsoft.com/office/powerpoint/2010/main" val="1903441675"/>
       </p:ext>
     </p:extLst>
   </p:cSld>
@@ -15281,7 +15281,7 @@
           <p:cNvPr id="27" name="c3-text-341">
             <a:extLst xmlns:a="http://schemas.openxmlformats.org/drawingml/2006/main">
               <a:ext uri="{FF2B5EF4-FFF2-40B4-BE49-F238E27FC236}">
-                <a16:creationId xmlns:a16="http://schemas.microsoft.com/office/drawing/2014/main" id="{9503A365-41C6-43DE-8078-D2B5838C59C7}"/>
+                <a16:creationId xmlns:a16="http://schemas.microsoft.com/office/drawing/2014/main" id="{75E26519-B2DB-4C50-88AC-B6D6E05FD429}"/>
               </a:ext>
             </a:extLst>
           </p:cNvPr>
@@ -15338,7 +15338,7 @@
           <p:cNvPr id="2" name="c3-text-342">
             <a:extLst xmlns:a="http://schemas.openxmlformats.org/drawingml/2006/main">
               <a:ext uri="{FF2B5EF4-FFF2-40B4-BE49-F238E27FC236}">
-                <a16:creationId xmlns:a16="http://schemas.microsoft.com/office/drawing/2014/main" id="{CC22EB1E-2E44-4A1F-8C3B-4AA941D4621F}"/>
+                <a16:creationId xmlns:a16="http://schemas.microsoft.com/office/drawing/2014/main" id="{AE801358-6D1E-4BFF-83B7-970FD2D92C0F}"/>
               </a:ext>
             </a:extLst>
           </p:cNvPr>
@@ -15395,7 +15395,7 @@
           <p:cNvPr id="3" name="c3-text-343">
             <a:extLst xmlns:a="http://schemas.openxmlformats.org/drawingml/2006/main">
               <a:ext uri="{FF2B5EF4-FFF2-40B4-BE49-F238E27FC236}">
-                <a16:creationId xmlns:a16="http://schemas.microsoft.com/office/drawing/2014/main" id="{F044CC8B-B6C4-4BC1-A43C-3A952F226864}"/>
+                <a16:creationId xmlns:a16="http://schemas.microsoft.com/office/drawing/2014/main" id="{F36FF003-F549-4346-8968-06EB71D54E2E}"/>
               </a:ext>
             </a:extLst>
           </p:cNvPr>
@@ -15450,10 +15450,10 @@
       <p:sp>
         <p:nvSpPr>
           <p:cNvPr id="4" name="c3-text-344">
-            <a:hlinkClick xmlns:r="http://schemas.openxmlformats.org/officeDocument/2006/relationships" xmlns:a="http://schemas.openxmlformats.org/drawingml/2006/main" r:id="R7c57d309f3d44961"/>
-            <a:extLst xmlns:a="http://schemas.openxmlformats.org/drawingml/2006/main">
-              <a:ext uri="{FF2B5EF4-FFF2-40B4-BE49-F238E27FC236}">
-                <a16:creationId xmlns:a16="http://schemas.microsoft.com/office/drawing/2014/main" id="{C165F428-84DA-4F6C-9F0F-20439845A321}"/>
+            <a:hlinkClick xmlns:r="http://schemas.openxmlformats.org/officeDocument/2006/relationships" xmlns:a="http://schemas.openxmlformats.org/drawingml/2006/main" r:id="R548b9d8032eb4d66"/>
+            <a:extLst xmlns:a="http://schemas.openxmlformats.org/drawingml/2006/main">
+              <a:ext uri="{FF2B5EF4-FFF2-40B4-BE49-F238E27FC236}">
+                <a16:creationId xmlns:a16="http://schemas.microsoft.com/office/drawing/2014/main" id="{62395427-C93F-466D-A7E7-BACDB347CEAD}"/>
               </a:ext>
             </a:extLst>
           </p:cNvPr>
@@ -15508,10 +15508,10 @@
       <p:sp>
         <p:nvSpPr>
           <p:cNvPr id="5" name="c3-text-345">
-            <a:hlinkClick xmlns:r="http://schemas.openxmlformats.org/officeDocument/2006/relationships" xmlns:a="http://schemas.openxmlformats.org/drawingml/2006/main" r:id="R401d9af45e2d492a"/>
-            <a:extLst xmlns:a="http://schemas.openxmlformats.org/drawingml/2006/main">
-              <a:ext uri="{FF2B5EF4-FFF2-40B4-BE49-F238E27FC236}">
-                <a16:creationId xmlns:a16="http://schemas.microsoft.com/office/drawing/2014/main" id="{6602C214-D424-4629-98F2-F45E71162CC9}"/>
+            <a:hlinkClick xmlns:r="http://schemas.openxmlformats.org/officeDocument/2006/relationships" xmlns:a="http://schemas.openxmlformats.org/drawingml/2006/main" r:id="Rdddaafd0e7174cdc"/>
+            <a:extLst xmlns:a="http://schemas.openxmlformats.org/drawingml/2006/main">
+              <a:ext uri="{FF2B5EF4-FFF2-40B4-BE49-F238E27FC236}">
+                <a16:creationId xmlns:a16="http://schemas.microsoft.com/office/drawing/2014/main" id="{D8424792-1D5E-4ECD-80C4-5032060EEF18}"/>
               </a:ext>
             </a:extLst>
           </p:cNvPr>
@@ -15568,7 +15568,7 @@
           <p:cNvPr id="6" name="c3-shape-346">
             <a:extLst xmlns:a="http://schemas.openxmlformats.org/drawingml/2006/main">
               <a:ext uri="{FF2B5EF4-FFF2-40B4-BE49-F238E27FC236}">
-                <a16:creationId xmlns:a16="http://schemas.microsoft.com/office/drawing/2014/main" id="{F836AAF0-4958-478C-89C8-9A84CE41E08E}"/>
+                <a16:creationId xmlns:a16="http://schemas.microsoft.com/office/drawing/2014/main" id="{9D4458E0-5609-49C4-921E-DFA38CE6E467}"/>
               </a:ext>
             </a:extLst>
           </p:cNvPr>
@@ -15598,10 +15598,10 @@
       <p:sp>
         <p:nvSpPr>
           <p:cNvPr id="7" name="c3-text-347">
-            <a:hlinkClick xmlns:r="http://schemas.openxmlformats.org/officeDocument/2006/relationships" xmlns:a="http://schemas.openxmlformats.org/drawingml/2006/main" r:id="Rdf01bbf3e9d546de"/>
-            <a:extLst xmlns:a="http://schemas.openxmlformats.org/drawingml/2006/main">
-              <a:ext uri="{FF2B5EF4-FFF2-40B4-BE49-F238E27FC236}">
-                <a16:creationId xmlns:a16="http://schemas.microsoft.com/office/drawing/2014/main" id="{BAB5FDCD-5C3D-460C-833F-EC2AD20A4458}"/>
+            <a:hlinkClick xmlns:r="http://schemas.openxmlformats.org/officeDocument/2006/relationships" xmlns:a="http://schemas.openxmlformats.org/drawingml/2006/main" r:id="R76eb2cde5e384c1a"/>
+            <a:extLst xmlns:a="http://schemas.openxmlformats.org/drawingml/2006/main">
+              <a:ext uri="{FF2B5EF4-FFF2-40B4-BE49-F238E27FC236}">
+                <a16:creationId xmlns:a16="http://schemas.microsoft.com/office/drawing/2014/main" id="{6AB394DE-BFAF-4963-AC41-E4F58F4B5AA9}"/>
               </a:ext>
             </a:extLst>
           </p:cNvPr>
@@ -15656,10 +15656,10 @@
       <p:sp>
         <p:nvSpPr>
           <p:cNvPr id="8" name="c3-text-348">
-            <a:hlinkClick xmlns:r="http://schemas.openxmlformats.org/officeDocument/2006/relationships" xmlns:a="http://schemas.openxmlformats.org/drawingml/2006/main" r:id="Re6e10cfdae9c4502"/>
-            <a:extLst xmlns:a="http://schemas.openxmlformats.org/drawingml/2006/main">
-              <a:ext uri="{FF2B5EF4-FFF2-40B4-BE49-F238E27FC236}">
-                <a16:creationId xmlns:a16="http://schemas.microsoft.com/office/drawing/2014/main" id="{C30396BE-8204-48D2-962E-438D2F6898B9}"/>
+            <a:hlinkClick xmlns:r="http://schemas.openxmlformats.org/officeDocument/2006/relationships" xmlns:a="http://schemas.openxmlformats.org/drawingml/2006/main" r:id="Rf536709f1df34645"/>
+            <a:extLst xmlns:a="http://schemas.openxmlformats.org/drawingml/2006/main">
+              <a:ext uri="{FF2B5EF4-FFF2-40B4-BE49-F238E27FC236}">
+                <a16:creationId xmlns:a16="http://schemas.microsoft.com/office/drawing/2014/main" id="{FBA8DF1C-AE83-468F-805A-40DB2C2371AB}"/>
               </a:ext>
             </a:extLst>
           </p:cNvPr>
@@ -15716,7 +15716,7 @@
           <p:cNvPr id="9" name="c3-shape-349">
             <a:extLst xmlns:a="http://schemas.openxmlformats.org/drawingml/2006/main">
               <a:ext uri="{FF2B5EF4-FFF2-40B4-BE49-F238E27FC236}">
-                <a16:creationId xmlns:a16="http://schemas.microsoft.com/office/drawing/2014/main" id="{38446CCC-FD17-4BDD-83A7-D47D9F63E611}"/>
+                <a16:creationId xmlns:a16="http://schemas.microsoft.com/office/drawing/2014/main" id="{C62A923D-7807-4D30-A8B0-058C1B76E024}"/>
               </a:ext>
             </a:extLst>
           </p:cNvPr>
@@ -15746,10 +15746,10 @@
       <p:sp>
         <p:nvSpPr>
           <p:cNvPr id="10" name="c3-text-350">
-            <a:hlinkClick xmlns:r="http://schemas.openxmlformats.org/officeDocument/2006/relationships" xmlns:a="http://schemas.openxmlformats.org/drawingml/2006/main" r:id="Rc1746e421e2d4ed2"/>
-            <a:extLst xmlns:a="http://schemas.openxmlformats.org/drawingml/2006/main">
-              <a:ext uri="{FF2B5EF4-FFF2-40B4-BE49-F238E27FC236}">
-                <a16:creationId xmlns:a16="http://schemas.microsoft.com/office/drawing/2014/main" id="{5CBF5DBA-4B1B-4FF2-88D6-0D343B18440F}"/>
+            <a:hlinkClick xmlns:r="http://schemas.openxmlformats.org/officeDocument/2006/relationships" xmlns:a="http://schemas.openxmlformats.org/drawingml/2006/main" r:id="R4ce2a95861994a97"/>
+            <a:extLst xmlns:a="http://schemas.openxmlformats.org/drawingml/2006/main">
+              <a:ext uri="{FF2B5EF4-FFF2-40B4-BE49-F238E27FC236}">
+                <a16:creationId xmlns:a16="http://schemas.microsoft.com/office/drawing/2014/main" id="{B75BAE8A-A722-4D4A-8614-726A7380284B}"/>
               </a:ext>
             </a:extLst>
           </p:cNvPr>
@@ -15804,10 +15804,10 @@
       <p:sp>
         <p:nvSpPr>
           <p:cNvPr id="11" name="c3-text-351">
-            <a:hlinkClick xmlns:r="http://schemas.openxmlformats.org/officeDocument/2006/relationships" xmlns:a="http://schemas.openxmlformats.org/drawingml/2006/main" r:id="R0d1c837f5f09478d"/>
-            <a:extLst xmlns:a="http://schemas.openxmlformats.org/drawingml/2006/main">
-              <a:ext uri="{FF2B5EF4-FFF2-40B4-BE49-F238E27FC236}">
-                <a16:creationId xmlns:a16="http://schemas.microsoft.com/office/drawing/2014/main" id="{38996597-C163-4C69-BB87-32C6704C6197}"/>
+            <a:hlinkClick xmlns:r="http://schemas.openxmlformats.org/officeDocument/2006/relationships" xmlns:a="http://schemas.openxmlformats.org/drawingml/2006/main" r:id="R039332f551134de2"/>
+            <a:extLst xmlns:a="http://schemas.openxmlformats.org/drawingml/2006/main">
+              <a:ext uri="{FF2B5EF4-FFF2-40B4-BE49-F238E27FC236}">
+                <a16:creationId xmlns:a16="http://schemas.microsoft.com/office/drawing/2014/main" id="{73A27EE4-2517-4601-8372-9B3FDC5ECA87}"/>
               </a:ext>
             </a:extLst>
           </p:cNvPr>
@@ -15864,7 +15864,7 @@
           <p:cNvPr id="12" name="c3-shape-352">
             <a:extLst xmlns:a="http://schemas.openxmlformats.org/drawingml/2006/main">
               <a:ext uri="{FF2B5EF4-FFF2-40B4-BE49-F238E27FC236}">
-                <a16:creationId xmlns:a16="http://schemas.microsoft.com/office/drawing/2014/main" id="{590521EE-766B-4B0C-B8C3-2B02ED8C8FD7}"/>
+                <a16:creationId xmlns:a16="http://schemas.microsoft.com/office/drawing/2014/main" id="{4AA0676B-F3A6-46D1-AAFD-3B24AC34EDCE}"/>
               </a:ext>
             </a:extLst>
           </p:cNvPr>
@@ -15894,10 +15894,10 @@
       <p:sp>
         <p:nvSpPr>
           <p:cNvPr id="13" name="c3-text-353">
-            <a:hlinkClick xmlns:r="http://schemas.openxmlformats.org/officeDocument/2006/relationships" xmlns:a="http://schemas.openxmlformats.org/drawingml/2006/main" r:id="R436ee2c295e04fcb"/>
-            <a:extLst xmlns:a="http://schemas.openxmlformats.org/drawingml/2006/main">
-              <a:ext uri="{FF2B5EF4-FFF2-40B4-BE49-F238E27FC236}">
-                <a16:creationId xmlns:a16="http://schemas.microsoft.com/office/drawing/2014/main" id="{5E837DE7-FFAD-44D9-B792-A92874A30D7D}"/>
+            <a:hlinkClick xmlns:r="http://schemas.openxmlformats.org/officeDocument/2006/relationships" xmlns:a="http://schemas.openxmlformats.org/drawingml/2006/main" r:id="Rb5241ac4bdaf4d30"/>
+            <a:extLst xmlns:a="http://schemas.openxmlformats.org/drawingml/2006/main">
+              <a:ext uri="{FF2B5EF4-FFF2-40B4-BE49-F238E27FC236}">
+                <a16:creationId xmlns:a16="http://schemas.microsoft.com/office/drawing/2014/main" id="{E0C0822F-5B9C-4876-9362-E9672CDF00EB}"/>
               </a:ext>
             </a:extLst>
           </p:cNvPr>
@@ -15952,10 +15952,10 @@
       <p:sp>
         <p:nvSpPr>
           <p:cNvPr id="14" name="c3-text-354">
-            <a:hlinkClick xmlns:r="http://schemas.openxmlformats.org/officeDocument/2006/relationships" xmlns:a="http://schemas.openxmlformats.org/drawingml/2006/main" r:id="Rb5287a906cc24d1d"/>
-            <a:extLst xmlns:a="http://schemas.openxmlformats.org/drawingml/2006/main">
-              <a:ext uri="{FF2B5EF4-FFF2-40B4-BE49-F238E27FC236}">
-                <a16:creationId xmlns:a16="http://schemas.microsoft.com/office/drawing/2014/main" id="{54A30BF6-7414-436B-BC19-FA8D7481C56A}"/>
+            <a:hlinkClick xmlns:r="http://schemas.openxmlformats.org/officeDocument/2006/relationships" xmlns:a="http://schemas.openxmlformats.org/drawingml/2006/main" r:id="R701fc648bebd46cb"/>
+            <a:extLst xmlns:a="http://schemas.openxmlformats.org/drawingml/2006/main">
+              <a:ext uri="{FF2B5EF4-FFF2-40B4-BE49-F238E27FC236}">
+                <a16:creationId xmlns:a16="http://schemas.microsoft.com/office/drawing/2014/main" id="{5E401252-23BE-4D17-A77B-26906BFD4000}"/>
               </a:ext>
             </a:extLst>
           </p:cNvPr>
@@ -16010,10 +16010,10 @@
       <p:sp>
         <p:nvSpPr>
           <p:cNvPr id="15" name="c3-text-355">
-            <a:hlinkClick xmlns:r="http://schemas.openxmlformats.org/officeDocument/2006/relationships" xmlns:a="http://schemas.openxmlformats.org/drawingml/2006/main" r:id="R1418d4cd6db7431b"/>
-            <a:extLst xmlns:a="http://schemas.openxmlformats.org/drawingml/2006/main">
-              <a:ext uri="{FF2B5EF4-FFF2-40B4-BE49-F238E27FC236}">
-                <a16:creationId xmlns:a16="http://schemas.microsoft.com/office/drawing/2014/main" id="{D3A2AA8B-9B14-4987-A11A-1AB891834AF8}"/>
+            <a:hlinkClick xmlns:r="http://schemas.openxmlformats.org/officeDocument/2006/relationships" xmlns:a="http://schemas.openxmlformats.org/drawingml/2006/main" r:id="Rc5057b76f9324a80"/>
+            <a:extLst xmlns:a="http://schemas.openxmlformats.org/drawingml/2006/main">
+              <a:ext uri="{FF2B5EF4-FFF2-40B4-BE49-F238E27FC236}">
+                <a16:creationId xmlns:a16="http://schemas.microsoft.com/office/drawing/2014/main" id="{6DD5FC25-3148-41B3-BB3A-818D7D0851E7}"/>
               </a:ext>
             </a:extLst>
           </p:cNvPr>
@@ -16068,10 +16068,10 @@
       <p:sp>
         <p:nvSpPr>
           <p:cNvPr id="16" name="c3-text-356">
-            <a:hlinkClick xmlns:r="http://schemas.openxmlformats.org/officeDocument/2006/relationships" xmlns:a="http://schemas.openxmlformats.org/drawingml/2006/main" r:id="Re3477e9f6abe4dfb"/>
-            <a:extLst xmlns:a="http://schemas.openxmlformats.org/drawingml/2006/main">
-              <a:ext uri="{FF2B5EF4-FFF2-40B4-BE49-F238E27FC236}">
-                <a16:creationId xmlns:a16="http://schemas.microsoft.com/office/drawing/2014/main" id="{2F3CA7B8-879E-4787-BA3D-8AFC9408EBD3}"/>
+            <a:hlinkClick xmlns:r="http://schemas.openxmlformats.org/officeDocument/2006/relationships" xmlns:a="http://schemas.openxmlformats.org/drawingml/2006/main" r:id="R32dcdc88971b4f7b"/>
+            <a:extLst xmlns:a="http://schemas.openxmlformats.org/drawingml/2006/main">
+              <a:ext uri="{FF2B5EF4-FFF2-40B4-BE49-F238E27FC236}">
+                <a16:creationId xmlns:a16="http://schemas.microsoft.com/office/drawing/2014/main" id="{F55F87EA-A159-4C89-A762-5BD896DF3362}"/>
               </a:ext>
             </a:extLst>
           </p:cNvPr>
@@ -16128,7 +16128,7 @@
           <p:cNvPr id="17" name="c3-shape-357">
             <a:extLst xmlns:a="http://schemas.openxmlformats.org/drawingml/2006/main">
               <a:ext uri="{FF2B5EF4-FFF2-40B4-BE49-F238E27FC236}">
-                <a16:creationId xmlns:a16="http://schemas.microsoft.com/office/drawing/2014/main" id="{8A4BE130-F758-4597-90AB-6E838C067D44}"/>
+                <a16:creationId xmlns:a16="http://schemas.microsoft.com/office/drawing/2014/main" id="{FEE673FE-0D16-4289-AA64-BE4606CC8A3D}"/>
               </a:ext>
             </a:extLst>
           </p:cNvPr>
@@ -16158,10 +16158,10 @@
       <p:sp>
         <p:nvSpPr>
           <p:cNvPr id="18" name="c3-text-358">
-            <a:hlinkClick xmlns:r="http://schemas.openxmlformats.org/officeDocument/2006/relationships" xmlns:a="http://schemas.openxmlformats.org/drawingml/2006/main" r:id="R03523fd7caff4d58"/>
-            <a:extLst xmlns:a="http://schemas.openxmlformats.org/drawingml/2006/main">
-              <a:ext uri="{FF2B5EF4-FFF2-40B4-BE49-F238E27FC236}">
-                <a16:creationId xmlns:a16="http://schemas.microsoft.com/office/drawing/2014/main" id="{4A0A9811-F928-47AB-920F-4A52D0E3D351}"/>
+            <a:hlinkClick xmlns:r="http://schemas.openxmlformats.org/officeDocument/2006/relationships" xmlns:a="http://schemas.openxmlformats.org/drawingml/2006/main" r:id="R77a6d459adbe4838"/>
+            <a:extLst xmlns:a="http://schemas.openxmlformats.org/drawingml/2006/main">
+              <a:ext uri="{FF2B5EF4-FFF2-40B4-BE49-F238E27FC236}">
+                <a16:creationId xmlns:a16="http://schemas.microsoft.com/office/drawing/2014/main" id="{6252439A-4C04-41B5-BE81-AE0DB8DF1818}"/>
               </a:ext>
             </a:extLst>
           </p:cNvPr>
@@ -16216,10 +16216,10 @@
       <p:sp>
         <p:nvSpPr>
           <p:cNvPr id="19" name="c3-text-359">
-            <a:hlinkClick xmlns:r="http://schemas.openxmlformats.org/officeDocument/2006/relationships" xmlns:a="http://schemas.openxmlformats.org/drawingml/2006/main" r:id="Rcdf1d8ea43784849"/>
-            <a:extLst xmlns:a="http://schemas.openxmlformats.org/drawingml/2006/main">
-              <a:ext uri="{FF2B5EF4-FFF2-40B4-BE49-F238E27FC236}">
-                <a16:creationId xmlns:a16="http://schemas.microsoft.com/office/drawing/2014/main" id="{4D7DCB9D-82E2-4878-A59A-FDE7AFD261DB}"/>
+            <a:hlinkClick xmlns:r="http://schemas.openxmlformats.org/officeDocument/2006/relationships" xmlns:a="http://schemas.openxmlformats.org/drawingml/2006/main" r:id="Rc61a1550ce72455d"/>
+            <a:extLst xmlns:a="http://schemas.openxmlformats.org/drawingml/2006/main">
+              <a:ext uri="{FF2B5EF4-FFF2-40B4-BE49-F238E27FC236}">
+                <a16:creationId xmlns:a16="http://schemas.microsoft.com/office/drawing/2014/main" id="{B9712043-8C85-4FDA-B9A9-004C83AD7C83}"/>
               </a:ext>
             </a:extLst>
           </p:cNvPr>
@@ -16276,7 +16276,7 @@
           <p:cNvPr id="20" name="c3-shape-360">
             <a:extLst xmlns:a="http://schemas.openxmlformats.org/drawingml/2006/main">
               <a:ext uri="{FF2B5EF4-FFF2-40B4-BE49-F238E27FC236}">
-                <a16:creationId xmlns:a16="http://schemas.microsoft.com/office/drawing/2014/main" id="{FDEF3FBD-D912-4012-B193-5246A8369CA3}"/>
+                <a16:creationId xmlns:a16="http://schemas.microsoft.com/office/drawing/2014/main" id="{404A1E44-02C0-412B-B828-20351A5BDC0B}"/>
               </a:ext>
             </a:extLst>
           </p:cNvPr>
@@ -16306,10 +16306,10 @@
       <p:sp>
         <p:nvSpPr>
           <p:cNvPr id="21" name="c3-text-361">
-            <a:hlinkClick xmlns:r="http://schemas.openxmlformats.org/officeDocument/2006/relationships" xmlns:a="http://schemas.openxmlformats.org/drawingml/2006/main" r:id="R84c2c2fc283e408a"/>
-            <a:extLst xmlns:a="http://schemas.openxmlformats.org/drawingml/2006/main">
-              <a:ext uri="{FF2B5EF4-FFF2-40B4-BE49-F238E27FC236}">
-                <a16:creationId xmlns:a16="http://schemas.microsoft.com/office/drawing/2014/main" id="{FA769C84-BDBA-40AC-8ECC-A8D51D63EAAE}"/>
+            <a:hlinkClick xmlns:r="http://schemas.openxmlformats.org/officeDocument/2006/relationships" xmlns:a="http://schemas.openxmlformats.org/drawingml/2006/main" r:id="Rd7e38570eb8a4268"/>
+            <a:extLst xmlns:a="http://schemas.openxmlformats.org/drawingml/2006/main">
+              <a:ext uri="{FF2B5EF4-FFF2-40B4-BE49-F238E27FC236}">
+                <a16:creationId xmlns:a16="http://schemas.microsoft.com/office/drawing/2014/main" id="{BEB7BE24-DA6D-4995-A7D8-E3EB8F2552F1}"/>
               </a:ext>
             </a:extLst>
           </p:cNvPr>
@@ -16364,10 +16364,10 @@
       <p:sp>
         <p:nvSpPr>
           <p:cNvPr id="22" name="c3-text-362">
-            <a:hlinkClick xmlns:r="http://schemas.openxmlformats.org/officeDocument/2006/relationships" xmlns:a="http://schemas.openxmlformats.org/drawingml/2006/main" r:id="Rfcd0aa012fe14b01"/>
-            <a:extLst xmlns:a="http://schemas.openxmlformats.org/drawingml/2006/main">
-              <a:ext uri="{FF2B5EF4-FFF2-40B4-BE49-F238E27FC236}">
-                <a16:creationId xmlns:a16="http://schemas.microsoft.com/office/drawing/2014/main" id="{488C7314-3EA4-496D-AAB9-F74B9DAFC567}"/>
+            <a:hlinkClick xmlns:r="http://schemas.openxmlformats.org/officeDocument/2006/relationships" xmlns:a="http://schemas.openxmlformats.org/drawingml/2006/main" r:id="R66b86d228a0c49b6"/>
+            <a:extLst xmlns:a="http://schemas.openxmlformats.org/drawingml/2006/main">
+              <a:ext uri="{FF2B5EF4-FFF2-40B4-BE49-F238E27FC236}">
+                <a16:creationId xmlns:a16="http://schemas.microsoft.com/office/drawing/2014/main" id="{94E34CE4-C46C-4E72-96A4-37CE5A2C1599}"/>
               </a:ext>
             </a:extLst>
           </p:cNvPr>
@@ -16424,7 +16424,7 @@
           <p:cNvPr id="23" name="c3-shape-363">
             <a:extLst xmlns:a="http://schemas.openxmlformats.org/drawingml/2006/main">
               <a:ext uri="{FF2B5EF4-FFF2-40B4-BE49-F238E27FC236}">
-                <a16:creationId xmlns:a16="http://schemas.microsoft.com/office/drawing/2014/main" id="{D34DD081-E360-44D4-B292-91075CA48298}"/>
+                <a16:creationId xmlns:a16="http://schemas.microsoft.com/office/drawing/2014/main" id="{3B5E2003-C204-421E-8CFE-27432152FE85}"/>
               </a:ext>
             </a:extLst>
           </p:cNvPr>
@@ -16454,10 +16454,10 @@
       <p:sp>
         <p:nvSpPr>
           <p:cNvPr id="24" name="c3-text-364">
-            <a:hlinkClick xmlns:r="http://schemas.openxmlformats.org/officeDocument/2006/relationships" xmlns:a="http://schemas.openxmlformats.org/drawingml/2006/main" r:id="R7e1ecca56e2449a5"/>
-            <a:extLst xmlns:a="http://schemas.openxmlformats.org/drawingml/2006/main">
-              <a:ext uri="{FF2B5EF4-FFF2-40B4-BE49-F238E27FC236}">
-                <a16:creationId xmlns:a16="http://schemas.microsoft.com/office/drawing/2014/main" id="{5A858F07-4D39-483A-80F5-B4E04EACAB3D}"/>
+            <a:hlinkClick xmlns:r="http://schemas.openxmlformats.org/officeDocument/2006/relationships" xmlns:a="http://schemas.openxmlformats.org/drawingml/2006/main" r:id="R9830f8bf24ad4ceb"/>
+            <a:extLst xmlns:a="http://schemas.openxmlformats.org/drawingml/2006/main">
+              <a:ext uri="{FF2B5EF4-FFF2-40B4-BE49-F238E27FC236}">
+                <a16:creationId xmlns:a16="http://schemas.microsoft.com/office/drawing/2014/main" id="{6361449F-D9B7-4BBA-B090-8B61AE50FEC3}"/>
               </a:ext>
             </a:extLst>
           </p:cNvPr>
@@ -16512,10 +16512,10 @@
       <p:sp>
         <p:nvSpPr>
           <p:cNvPr id="25" name="c3-text-365">
-            <a:hlinkClick xmlns:r="http://schemas.openxmlformats.org/officeDocument/2006/relationships" xmlns:a="http://schemas.openxmlformats.org/drawingml/2006/main" r:id="R9ec306671746482c"/>
-            <a:extLst xmlns:a="http://schemas.openxmlformats.org/drawingml/2006/main">
-              <a:ext uri="{FF2B5EF4-FFF2-40B4-BE49-F238E27FC236}">
-                <a16:creationId xmlns:a16="http://schemas.microsoft.com/office/drawing/2014/main" id="{51C78ADC-6E91-4CC9-B76C-42510127430B}"/>
+            <a:hlinkClick xmlns:r="http://schemas.openxmlformats.org/officeDocument/2006/relationships" xmlns:a="http://schemas.openxmlformats.org/drawingml/2006/main" r:id="R260a15d7bf634df7"/>
+            <a:extLst xmlns:a="http://schemas.openxmlformats.org/drawingml/2006/main">
+              <a:ext uri="{FF2B5EF4-FFF2-40B4-BE49-F238E27FC236}">
+                <a16:creationId xmlns:a16="http://schemas.microsoft.com/office/drawing/2014/main" id="{FE2667F3-68F7-481B-B2CC-00AD2323A3E8}"/>
               </a:ext>
             </a:extLst>
           </p:cNvPr>
@@ -16572,7 +16572,7 @@
           <p:cNvPr id="26" name="c3-text-399">
             <a:extLst xmlns:a="http://schemas.openxmlformats.org/drawingml/2006/main">
               <a:ext uri="{FF2B5EF4-FFF2-40B4-BE49-F238E27FC236}">
-                <a16:creationId xmlns:a16="http://schemas.microsoft.com/office/drawing/2014/main" id="{F80D1377-5CEC-4438-9672-90E15BA11B09}"/>
+                <a16:creationId xmlns:a16="http://schemas.microsoft.com/office/drawing/2014/main" id="{A83EA66C-A7F7-49B4-93F4-FDC073BA21C8}"/>
               </a:ext>
             </a:extLst>
           </p:cNvPr>
@@ -16627,7 +16627,7 @@
     </p:spTree>
     <p:extLst>
       <p:ext uri="{BB962C8B-B14F-4D97-AF65-F5344CB8AC3E}">
-        <p14:creationId xmlns:p14="http://schemas.microsoft.com/office/powerpoint/2010/main" val="675667842"/>
+        <p14:creationId xmlns:p14="http://schemas.microsoft.com/office/powerpoint/2010/main" val="1451741449"/>
       </p:ext>
     </p:extLst>
   </p:cSld>
@@ -16658,7 +16658,7 @@
           <p:cNvPr id="14" name="c3-text-366">
             <a:extLst xmlns:a="http://schemas.openxmlformats.org/drawingml/2006/main">
               <a:ext uri="{FF2B5EF4-FFF2-40B4-BE49-F238E27FC236}">
-                <a16:creationId xmlns:a16="http://schemas.microsoft.com/office/drawing/2014/main" id="{61A59A04-41A8-432B-8AB2-756F160724FD}"/>
+                <a16:creationId xmlns:a16="http://schemas.microsoft.com/office/drawing/2014/main" id="{80F2A88A-37F4-4144-8BA4-9330D4F827C0}"/>
               </a:ext>
             </a:extLst>
           </p:cNvPr>
@@ -16715,7 +16715,7 @@
           <p:cNvPr id="2" name="c3-text-367">
             <a:extLst xmlns:a="http://schemas.openxmlformats.org/drawingml/2006/main">
               <a:ext uri="{FF2B5EF4-FFF2-40B4-BE49-F238E27FC236}">
-                <a16:creationId xmlns:a16="http://schemas.microsoft.com/office/drawing/2014/main" id="{71E74002-728A-4F26-9A30-AE5A69D54108}"/>
+                <a16:creationId xmlns:a16="http://schemas.microsoft.com/office/drawing/2014/main" id="{93F28960-7B38-48FA-AE59-8FCC73AE89EF}"/>
               </a:ext>
             </a:extLst>
           </p:cNvPr>
@@ -16772,7 +16772,7 @@
           <p:cNvPr id="3" name="c3-text-368">
             <a:extLst xmlns:a="http://schemas.openxmlformats.org/drawingml/2006/main">
               <a:ext uri="{FF2B5EF4-FFF2-40B4-BE49-F238E27FC236}">
-                <a16:creationId xmlns:a16="http://schemas.microsoft.com/office/drawing/2014/main" id="{BAB6179D-9D00-434C-AF50-C2F12445F9B9}"/>
+                <a16:creationId xmlns:a16="http://schemas.microsoft.com/office/drawing/2014/main" id="{819EED3C-18B0-47AB-8C25-F5617D69E0BF}"/>
               </a:ext>
             </a:extLst>
           </p:cNvPr>
@@ -16827,10 +16827,10 @@
       <p:sp>
         <p:nvSpPr>
           <p:cNvPr id="4" name="c3-text-369">
-            <a:hlinkClick xmlns:r="http://schemas.openxmlformats.org/officeDocument/2006/relationships" xmlns:a="http://schemas.openxmlformats.org/drawingml/2006/main" r:id="Rf0e86e40ff1e419a"/>
-            <a:extLst xmlns:a="http://schemas.openxmlformats.org/drawingml/2006/main">
-              <a:ext uri="{FF2B5EF4-FFF2-40B4-BE49-F238E27FC236}">
-                <a16:creationId xmlns:a16="http://schemas.microsoft.com/office/drawing/2014/main" id="{1120C06A-4727-4D1F-B070-1281A48E5940}"/>
+            <a:hlinkClick xmlns:r="http://schemas.openxmlformats.org/officeDocument/2006/relationships" xmlns:a="http://schemas.openxmlformats.org/drawingml/2006/main" r:id="R941cc81b167646eb"/>
+            <a:extLst xmlns:a="http://schemas.openxmlformats.org/drawingml/2006/main">
+              <a:ext uri="{FF2B5EF4-FFF2-40B4-BE49-F238E27FC236}">
+                <a16:creationId xmlns:a16="http://schemas.microsoft.com/office/drawing/2014/main" id="{6DD03FAE-DD10-4652-9152-9F123350E66A}"/>
               </a:ext>
             </a:extLst>
           </p:cNvPr>
@@ -16885,10 +16885,10 @@
       <p:sp>
         <p:nvSpPr>
           <p:cNvPr id="5" name="c3-text-370">
-            <a:hlinkClick xmlns:r="http://schemas.openxmlformats.org/officeDocument/2006/relationships" xmlns:a="http://schemas.openxmlformats.org/drawingml/2006/main" r:id="R3040a19069274f95"/>
-            <a:extLst xmlns:a="http://schemas.openxmlformats.org/drawingml/2006/main">
-              <a:ext uri="{FF2B5EF4-FFF2-40B4-BE49-F238E27FC236}">
-                <a16:creationId xmlns:a16="http://schemas.microsoft.com/office/drawing/2014/main" id="{149F0E76-CDFB-4B55-BE09-3BFC07D7D23F}"/>
+            <a:hlinkClick xmlns:r="http://schemas.openxmlformats.org/officeDocument/2006/relationships" xmlns:a="http://schemas.openxmlformats.org/drawingml/2006/main" r:id="Rfec3bb7d184d4eae"/>
+            <a:extLst xmlns:a="http://schemas.openxmlformats.org/drawingml/2006/main">
+              <a:ext uri="{FF2B5EF4-FFF2-40B4-BE49-F238E27FC236}">
+                <a16:creationId xmlns:a16="http://schemas.microsoft.com/office/drawing/2014/main" id="{FDFF9BA9-83C3-4024-98E5-B7E11D8AA041}"/>
               </a:ext>
             </a:extLst>
           </p:cNvPr>
@@ -16945,7 +16945,7 @@
           <p:cNvPr id="6" name="c3-shape-371">
             <a:extLst xmlns:a="http://schemas.openxmlformats.org/drawingml/2006/main">
               <a:ext uri="{FF2B5EF4-FFF2-40B4-BE49-F238E27FC236}">
-                <a16:creationId xmlns:a16="http://schemas.microsoft.com/office/drawing/2014/main" id="{BD1EA269-C2FD-42E6-B5A4-7230A67B1461}"/>
+                <a16:creationId xmlns:a16="http://schemas.microsoft.com/office/drawing/2014/main" id="{3982B538-ED36-42E7-B912-F9A1654A6D42}"/>
               </a:ext>
             </a:extLst>
           </p:cNvPr>
@@ -16975,10 +16975,10 @@
       <p:sp>
         <p:nvSpPr>
           <p:cNvPr id="7" name="c3-text-372">
-            <a:hlinkClick xmlns:r="http://schemas.openxmlformats.org/officeDocument/2006/relationships" xmlns:a="http://schemas.openxmlformats.org/drawingml/2006/main" r:id="R1220c2a9aee049d5"/>
-            <a:extLst xmlns:a="http://schemas.openxmlformats.org/drawingml/2006/main">
-              <a:ext uri="{FF2B5EF4-FFF2-40B4-BE49-F238E27FC236}">
-                <a16:creationId xmlns:a16="http://schemas.microsoft.com/office/drawing/2014/main" id="{3C43C641-FCC8-4D9C-A46B-2E6F8ECBD5EE}"/>
+            <a:hlinkClick xmlns:r="http://schemas.openxmlformats.org/officeDocument/2006/relationships" xmlns:a="http://schemas.openxmlformats.org/drawingml/2006/main" r:id="Rd26c75cf86554786"/>
+            <a:extLst xmlns:a="http://schemas.openxmlformats.org/drawingml/2006/main">
+              <a:ext uri="{FF2B5EF4-FFF2-40B4-BE49-F238E27FC236}">
+                <a16:creationId xmlns:a16="http://schemas.microsoft.com/office/drawing/2014/main" id="{BF12FC0E-26BB-4463-8D2C-F3BA7D975B22}"/>
               </a:ext>
             </a:extLst>
           </p:cNvPr>
@@ -17033,10 +17033,10 @@
       <p:sp>
         <p:nvSpPr>
           <p:cNvPr id="8" name="c3-text-373">
-            <a:hlinkClick xmlns:r="http://schemas.openxmlformats.org/officeDocument/2006/relationships" xmlns:a="http://schemas.openxmlformats.org/drawingml/2006/main" r:id="Red7c231846764ebd"/>
-            <a:extLst xmlns:a="http://schemas.openxmlformats.org/drawingml/2006/main">
-              <a:ext uri="{FF2B5EF4-FFF2-40B4-BE49-F238E27FC236}">
-                <a16:creationId xmlns:a16="http://schemas.microsoft.com/office/drawing/2014/main" id="{76CC5EC1-EB05-4C90-AD4F-79449D00547B}"/>
+            <a:hlinkClick xmlns:r="http://schemas.openxmlformats.org/officeDocument/2006/relationships" xmlns:a="http://schemas.openxmlformats.org/drawingml/2006/main" r:id="Rd2e878b4e36b487c"/>
+            <a:extLst xmlns:a="http://schemas.openxmlformats.org/drawingml/2006/main">
+              <a:ext uri="{FF2B5EF4-FFF2-40B4-BE49-F238E27FC236}">
+                <a16:creationId xmlns:a16="http://schemas.microsoft.com/office/drawing/2014/main" id="{91A521F8-524F-4941-A0C3-CB3BE109CFB6}"/>
               </a:ext>
             </a:extLst>
           </p:cNvPr>
@@ -17093,7 +17093,7 @@
           <p:cNvPr id="9" name="c3-shape-374">
             <a:extLst xmlns:a="http://schemas.openxmlformats.org/drawingml/2006/main">
               <a:ext uri="{FF2B5EF4-FFF2-40B4-BE49-F238E27FC236}">
-                <a16:creationId xmlns:a16="http://schemas.microsoft.com/office/drawing/2014/main" id="{7DBDBFFC-3B46-4056-9ABE-85733B78BA7A}"/>
+                <a16:creationId xmlns:a16="http://schemas.microsoft.com/office/drawing/2014/main" id="{6BCA5B06-9962-46BF-926F-45B5AAE6C846}"/>
               </a:ext>
             </a:extLst>
           </p:cNvPr>
@@ -17123,10 +17123,10 @@
       <p:sp>
         <p:nvSpPr>
           <p:cNvPr id="10" name="c3-text-375">
-            <a:hlinkClick xmlns:r="http://schemas.openxmlformats.org/officeDocument/2006/relationships" xmlns:a="http://schemas.openxmlformats.org/drawingml/2006/main" r:id="R3441153cdab94cc1"/>
-            <a:extLst xmlns:a="http://schemas.openxmlformats.org/drawingml/2006/main">
-              <a:ext uri="{FF2B5EF4-FFF2-40B4-BE49-F238E27FC236}">
-                <a16:creationId xmlns:a16="http://schemas.microsoft.com/office/drawing/2014/main" id="{0866503A-0E55-4415-BD95-2074AD898AA1}"/>
+            <a:hlinkClick xmlns:r="http://schemas.openxmlformats.org/officeDocument/2006/relationships" xmlns:a="http://schemas.openxmlformats.org/drawingml/2006/main" r:id="R068b0a89b6e342fd"/>
+            <a:extLst xmlns:a="http://schemas.openxmlformats.org/drawingml/2006/main">
+              <a:ext uri="{FF2B5EF4-FFF2-40B4-BE49-F238E27FC236}">
+                <a16:creationId xmlns:a16="http://schemas.microsoft.com/office/drawing/2014/main" id="{03A7418E-6D59-4025-9A11-7DF917926149}"/>
               </a:ext>
             </a:extLst>
           </p:cNvPr>
@@ -17181,10 +17181,10 @@
       <p:sp>
         <p:nvSpPr>
           <p:cNvPr id="11" name="c3-text-376">
-            <a:hlinkClick xmlns:r="http://schemas.openxmlformats.org/officeDocument/2006/relationships" xmlns:a="http://schemas.openxmlformats.org/drawingml/2006/main" r:id="R723366127e624388"/>
-            <a:extLst xmlns:a="http://schemas.openxmlformats.org/drawingml/2006/main">
-              <a:ext uri="{FF2B5EF4-FFF2-40B4-BE49-F238E27FC236}">
-                <a16:creationId xmlns:a16="http://schemas.microsoft.com/office/drawing/2014/main" id="{8E49C9C0-27ED-4A86-A599-B4A9F46FBC98}"/>
+            <a:hlinkClick xmlns:r="http://schemas.openxmlformats.org/officeDocument/2006/relationships" xmlns:a="http://schemas.openxmlformats.org/drawingml/2006/main" r:id="R752dbcde39464763"/>
+            <a:extLst xmlns:a="http://schemas.openxmlformats.org/drawingml/2006/main">
+              <a:ext uri="{FF2B5EF4-FFF2-40B4-BE49-F238E27FC236}">
+                <a16:creationId xmlns:a16="http://schemas.microsoft.com/office/drawing/2014/main" id="{F7C2E95D-BF37-497E-8882-4B8CFE58CBF5}"/>
               </a:ext>
             </a:extLst>
           </p:cNvPr>
@@ -17241,7 +17241,7 @@
           <p:cNvPr id="12" name="c3-shape-377">
             <a:extLst xmlns:a="http://schemas.openxmlformats.org/drawingml/2006/main">
               <a:ext uri="{FF2B5EF4-FFF2-40B4-BE49-F238E27FC236}">
-                <a16:creationId xmlns:a16="http://schemas.microsoft.com/office/drawing/2014/main" id="{6AAC31D2-9C2F-43D7-B4C6-80ED2039AB26}"/>
+                <a16:creationId xmlns:a16="http://schemas.microsoft.com/office/drawing/2014/main" id="{ABD76E6E-B018-43A7-AFE0-59EC178E9D34}"/>
               </a:ext>
             </a:extLst>
           </p:cNvPr>
@@ -17273,7 +17273,7 @@
           <p:cNvPr id="13" name="c3-text-400">
             <a:extLst xmlns:a="http://schemas.openxmlformats.org/drawingml/2006/main">
               <a:ext uri="{FF2B5EF4-FFF2-40B4-BE49-F238E27FC236}">
-                <a16:creationId xmlns:a16="http://schemas.microsoft.com/office/drawing/2014/main" id="{8A2704DD-119B-4A6D-996D-B481D3B3211A}"/>
+                <a16:creationId xmlns:a16="http://schemas.microsoft.com/office/drawing/2014/main" id="{7FC988F3-3D23-49EE-B5CC-D5DFC9ACAE0C}"/>
               </a:ext>
             </a:extLst>
           </p:cNvPr>
@@ -17328,7 +17328,7 @@
     </p:spTree>
     <p:extLst>
       <p:ext uri="{BB962C8B-B14F-4D97-AF65-F5344CB8AC3E}">
-        <p14:creationId xmlns:p14="http://schemas.microsoft.com/office/powerpoint/2010/main" val="1052777999"/>
+        <p14:creationId xmlns:p14="http://schemas.microsoft.com/office/powerpoint/2010/main" val="1071109423"/>
       </p:ext>
     </p:extLst>
   </p:cSld>
@@ -17359,7 +17359,7 @@
           <p:cNvPr id="27" name="c3-text-18">
             <a:extLst xmlns:a="http://schemas.openxmlformats.org/drawingml/2006/main">
               <a:ext uri="{FF2B5EF4-FFF2-40B4-BE49-F238E27FC236}">
-                <a16:creationId xmlns:a16="http://schemas.microsoft.com/office/drawing/2014/main" id="{0F589622-A59B-4DDF-88C0-FF2F93CF6BE3}"/>
+                <a16:creationId xmlns:a16="http://schemas.microsoft.com/office/drawing/2014/main" id="{A0784229-1898-4627-8B41-51D90B396D75}"/>
               </a:ext>
             </a:extLst>
           </p:cNvPr>
@@ -17416,7 +17416,7 @@
           <p:cNvPr id="2" name="c3-text-19">
             <a:extLst xmlns:a="http://schemas.openxmlformats.org/drawingml/2006/main">
               <a:ext uri="{FF2B5EF4-FFF2-40B4-BE49-F238E27FC236}">
-                <a16:creationId xmlns:a16="http://schemas.microsoft.com/office/drawing/2014/main" id="{7486B991-5B9A-4471-9595-0606BBEE4200}"/>
+                <a16:creationId xmlns:a16="http://schemas.microsoft.com/office/drawing/2014/main" id="{CE90308C-0504-4817-891A-1A9856B97769}"/>
               </a:ext>
             </a:extLst>
           </p:cNvPr>
@@ -17473,7 +17473,7 @@
           <p:cNvPr id="3" name="c3-text-20">
             <a:extLst xmlns:a="http://schemas.openxmlformats.org/drawingml/2006/main">
               <a:ext uri="{FF2B5EF4-FFF2-40B4-BE49-F238E27FC236}">
-                <a16:creationId xmlns:a16="http://schemas.microsoft.com/office/drawing/2014/main" id="{6B7C28AA-F208-4C64-B611-C936DE04A443}"/>
+                <a16:creationId xmlns:a16="http://schemas.microsoft.com/office/drawing/2014/main" id="{02BB7646-8859-45C0-857A-157ADA546B62}"/>
               </a:ext>
             </a:extLst>
           </p:cNvPr>
@@ -17530,7 +17530,7 @@
           <p:cNvPr id="4" name="c3-shape-21">
             <a:extLst xmlns:a="http://schemas.openxmlformats.org/drawingml/2006/main">
               <a:ext uri="{FF2B5EF4-FFF2-40B4-BE49-F238E27FC236}">
-                <a16:creationId xmlns:a16="http://schemas.microsoft.com/office/drawing/2014/main" id="{3A8D811A-6A4A-47A7-8414-B54BF072443A}"/>
+                <a16:creationId xmlns:a16="http://schemas.microsoft.com/office/drawing/2014/main" id="{1BFFE7EC-54E5-4533-9BA5-78D5DC69E287}"/>
               </a:ext>
             </a:extLst>
           </p:cNvPr>
@@ -17568,7 +17568,7 @@
           <p:nvPr/>
         </p:nvPicPr>
         <p:blipFill>
-          <a:blip xmlns:r="http://schemas.openxmlformats.org/officeDocument/2006/relationships" xmlns:a="http://schemas.openxmlformats.org/drawingml/2006/main" r:embed="Ra8f532fe9ffe4216"/>
+          <a:blip xmlns:r="http://schemas.openxmlformats.org/officeDocument/2006/relationships" xmlns:a="http://schemas.openxmlformats.org/drawingml/2006/main" r:embed="R6b70da77fabe4027"/>
           <a:stretch xmlns:a="http://schemas.openxmlformats.org/drawingml/2006/main"/>
         </p:blipFill>
         <p:spPr>
@@ -17584,10 +17584,10 @@
       <p:sp>
         <p:nvSpPr>
           <p:cNvPr id="6" name="c3-text-22">
-            <a:hlinkClick xmlns:r="http://schemas.openxmlformats.org/officeDocument/2006/relationships" xmlns:a="http://schemas.openxmlformats.org/drawingml/2006/main" r:id="R69a5f09c58174d5d"/>
-            <a:extLst xmlns:a="http://schemas.openxmlformats.org/drawingml/2006/main">
-              <a:ext uri="{FF2B5EF4-FFF2-40B4-BE49-F238E27FC236}">
-                <a16:creationId xmlns:a16="http://schemas.microsoft.com/office/drawing/2014/main" id="{FA01A304-7543-4C9C-9B4D-82BCD546958B}"/>
+            <a:hlinkClick xmlns:r="http://schemas.openxmlformats.org/officeDocument/2006/relationships" xmlns:a="http://schemas.openxmlformats.org/drawingml/2006/main" r:id="Rdd56d5044b9f47d9"/>
+            <a:extLst xmlns:a="http://schemas.openxmlformats.org/drawingml/2006/main">
+              <a:ext uri="{FF2B5EF4-FFF2-40B4-BE49-F238E27FC236}">
+                <a16:creationId xmlns:a16="http://schemas.microsoft.com/office/drawing/2014/main" id="{A0103470-E0D3-47F3-921E-BC346D115EEE}"/>
               </a:ext>
             </a:extLst>
           </p:cNvPr>
@@ -17644,7 +17644,7 @@
           <p:cNvPr id="7" name="c3-text-23">
             <a:extLst xmlns:a="http://schemas.openxmlformats.org/drawingml/2006/main">
               <a:ext uri="{FF2B5EF4-FFF2-40B4-BE49-F238E27FC236}">
-                <a16:creationId xmlns:a16="http://schemas.microsoft.com/office/drawing/2014/main" id="{A43FFB46-9FC4-4310-B0F7-34CDC98B5D18}"/>
+                <a16:creationId xmlns:a16="http://schemas.microsoft.com/office/drawing/2014/main" id="{1F379366-A4AA-4ABD-A384-8DAC86709DA5}"/>
               </a:ext>
             </a:extLst>
           </p:cNvPr>
@@ -17701,7 +17701,7 @@
           <p:cNvPr id="8" name="c3-text-24">
             <a:extLst xmlns:a="http://schemas.openxmlformats.org/drawingml/2006/main">
               <a:ext uri="{FF2B5EF4-FFF2-40B4-BE49-F238E27FC236}">
-                <a16:creationId xmlns:a16="http://schemas.microsoft.com/office/drawing/2014/main" id="{4D285DD1-0A38-4429-8837-30258E927551}"/>
+                <a16:creationId xmlns:a16="http://schemas.microsoft.com/office/drawing/2014/main" id="{93AF0C8A-1DF7-43E9-B717-1EB0F0E932C6}"/>
               </a:ext>
             </a:extLst>
           </p:cNvPr>
@@ -17758,7 +17758,7 @@
           <p:cNvPr id="9" name="c3-shape-25">
             <a:extLst xmlns:a="http://schemas.openxmlformats.org/drawingml/2006/main">
               <a:ext uri="{FF2B5EF4-FFF2-40B4-BE49-F238E27FC236}">
-                <a16:creationId xmlns:a16="http://schemas.microsoft.com/office/drawing/2014/main" id="{005D59CC-25E6-435F-8F68-747792C948B1}"/>
+                <a16:creationId xmlns:a16="http://schemas.microsoft.com/office/drawing/2014/main" id="{0DC88332-DE8B-4ACA-B585-9A37FF607F9E}"/>
               </a:ext>
             </a:extLst>
           </p:cNvPr>
@@ -17796,7 +17796,7 @@
           <p:nvPr/>
         </p:nvPicPr>
         <p:blipFill>
-          <a:blip xmlns:r="http://schemas.openxmlformats.org/officeDocument/2006/relationships" xmlns:a="http://schemas.openxmlformats.org/drawingml/2006/main" r:embed="Rfdbc87af057a4a48"/>
+          <a:blip xmlns:r="http://schemas.openxmlformats.org/officeDocument/2006/relationships" xmlns:a="http://schemas.openxmlformats.org/drawingml/2006/main" r:embed="Rb40f5b506a55462b"/>
           <a:stretch xmlns:a="http://schemas.openxmlformats.org/drawingml/2006/main"/>
         </p:blipFill>
         <p:spPr>
@@ -17812,10 +17812,10 @@
       <p:sp>
         <p:nvSpPr>
           <p:cNvPr id="11" name="c3-text-26">
-            <a:hlinkClick xmlns:r="http://schemas.openxmlformats.org/officeDocument/2006/relationships" xmlns:a="http://schemas.openxmlformats.org/drawingml/2006/main" r:id="Rc5b13f942429438b"/>
-            <a:extLst xmlns:a="http://schemas.openxmlformats.org/drawingml/2006/main">
-              <a:ext uri="{FF2B5EF4-FFF2-40B4-BE49-F238E27FC236}">
-                <a16:creationId xmlns:a16="http://schemas.microsoft.com/office/drawing/2014/main" id="{F5CB3BE8-4DFC-46FA-9220-633C981E0592}"/>
+            <a:hlinkClick xmlns:r="http://schemas.openxmlformats.org/officeDocument/2006/relationships" xmlns:a="http://schemas.openxmlformats.org/drawingml/2006/main" r:id="Rb477aee55f2d43bc"/>
+            <a:extLst xmlns:a="http://schemas.openxmlformats.org/drawingml/2006/main">
+              <a:ext uri="{FF2B5EF4-FFF2-40B4-BE49-F238E27FC236}">
+                <a16:creationId xmlns:a16="http://schemas.microsoft.com/office/drawing/2014/main" id="{FEDCCC73-A981-49E7-B649-1F0C80BAA14B}"/>
               </a:ext>
             </a:extLst>
           </p:cNvPr>
@@ -17872,7 +17872,7 @@
           <p:cNvPr id="12" name="c3-text-27">
             <a:extLst xmlns:a="http://schemas.openxmlformats.org/drawingml/2006/main">
               <a:ext uri="{FF2B5EF4-FFF2-40B4-BE49-F238E27FC236}">
-                <a16:creationId xmlns:a16="http://schemas.microsoft.com/office/drawing/2014/main" id="{45F00D91-2F4E-462F-939B-20891D10E986}"/>
+                <a16:creationId xmlns:a16="http://schemas.microsoft.com/office/drawing/2014/main" id="{C84F0DF8-468A-4AE2-BC1B-180F8409EDDF}"/>
               </a:ext>
             </a:extLst>
           </p:cNvPr>
@@ -17929,7 +17929,7 @@
           <p:cNvPr id="13" name="c3-text-28">
             <a:extLst xmlns:a="http://schemas.openxmlformats.org/drawingml/2006/main">
               <a:ext uri="{FF2B5EF4-FFF2-40B4-BE49-F238E27FC236}">
-                <a16:creationId xmlns:a16="http://schemas.microsoft.com/office/drawing/2014/main" id="{84E31871-880C-4D66-97C8-8C704F261B0C}"/>
+                <a16:creationId xmlns:a16="http://schemas.microsoft.com/office/drawing/2014/main" id="{DE96152D-A890-40FA-A323-6CFDE000985C}"/>
               </a:ext>
             </a:extLst>
           </p:cNvPr>
@@ -17986,7 +17986,7 @@
           <p:cNvPr id="14" name="c3-shape-29">
             <a:extLst xmlns:a="http://schemas.openxmlformats.org/drawingml/2006/main">
               <a:ext uri="{FF2B5EF4-FFF2-40B4-BE49-F238E27FC236}">
-                <a16:creationId xmlns:a16="http://schemas.microsoft.com/office/drawing/2014/main" id="{76277547-9E13-45AC-8276-6D263D88F1F9}"/>
+                <a16:creationId xmlns:a16="http://schemas.microsoft.com/office/drawing/2014/main" id="{F790D51A-603C-4FDA-83FB-00ADC1DEF95D}"/>
               </a:ext>
             </a:extLst>
           </p:cNvPr>
@@ -18024,7 +18024,7 @@
           <p:nvPr/>
         </p:nvPicPr>
         <p:blipFill>
-          <a:blip xmlns:r="http://schemas.openxmlformats.org/officeDocument/2006/relationships" xmlns:a="http://schemas.openxmlformats.org/drawingml/2006/main" r:embed="Re4e4bafd5c534916"/>
+          <a:blip xmlns:r="http://schemas.openxmlformats.org/officeDocument/2006/relationships" xmlns:a="http://schemas.openxmlformats.org/drawingml/2006/main" r:embed="R793ef76b95cf4ccf"/>
           <a:stretch xmlns:a="http://schemas.openxmlformats.org/drawingml/2006/main"/>
         </p:blipFill>
         <p:spPr>
@@ -18040,10 +18040,10 @@
       <p:sp>
         <p:nvSpPr>
           <p:cNvPr id="16" name="c3-text-30">
-            <a:hlinkClick xmlns:r="http://schemas.openxmlformats.org/officeDocument/2006/relationships" xmlns:a="http://schemas.openxmlformats.org/drawingml/2006/main" r:id="Ra49c74bd2de94c31"/>
-            <a:extLst xmlns:a="http://schemas.openxmlformats.org/drawingml/2006/main">
-              <a:ext uri="{FF2B5EF4-FFF2-40B4-BE49-F238E27FC236}">
-                <a16:creationId xmlns:a16="http://schemas.microsoft.com/office/drawing/2014/main" id="{7A14A409-456C-449B-8B5A-7249EE97F5B6}"/>
+            <a:hlinkClick xmlns:r="http://schemas.openxmlformats.org/officeDocument/2006/relationships" xmlns:a="http://schemas.openxmlformats.org/drawingml/2006/main" r:id="Rd965344d6f0a4f37"/>
+            <a:extLst xmlns:a="http://schemas.openxmlformats.org/drawingml/2006/main">
+              <a:ext uri="{FF2B5EF4-FFF2-40B4-BE49-F238E27FC236}">
+                <a16:creationId xmlns:a16="http://schemas.microsoft.com/office/drawing/2014/main" id="{03582433-10CD-4999-AFAB-194FD058E0D4}"/>
               </a:ext>
             </a:extLst>
           </p:cNvPr>
@@ -18100,7 +18100,7 @@
           <p:cNvPr id="17" name="c3-text-31">
             <a:extLst xmlns:a="http://schemas.openxmlformats.org/drawingml/2006/main">
               <a:ext uri="{FF2B5EF4-FFF2-40B4-BE49-F238E27FC236}">
-                <a16:creationId xmlns:a16="http://schemas.microsoft.com/office/drawing/2014/main" id="{C76E9BAE-FD9D-4F8F-8915-6A0443901327}"/>
+                <a16:creationId xmlns:a16="http://schemas.microsoft.com/office/drawing/2014/main" id="{E4456C77-2556-4841-99D4-413DE65D08F8}"/>
               </a:ext>
             </a:extLst>
           </p:cNvPr>
@@ -18157,7 +18157,7 @@
           <p:cNvPr id="18" name="c3-text-32">
             <a:extLst xmlns:a="http://schemas.openxmlformats.org/drawingml/2006/main">
               <a:ext uri="{FF2B5EF4-FFF2-40B4-BE49-F238E27FC236}">
-                <a16:creationId xmlns:a16="http://schemas.microsoft.com/office/drawing/2014/main" id="{CFFFD9F4-57F0-41B7-80C2-31F5EDEC12D4}"/>
+                <a16:creationId xmlns:a16="http://schemas.microsoft.com/office/drawing/2014/main" id="{4155FB22-3D60-468B-BFC7-E5DCED8987F7}"/>
               </a:ext>
             </a:extLst>
           </p:cNvPr>
@@ -18214,7 +18214,7 @@
           <p:cNvPr id="19" name="c3-shape-33">
             <a:extLst xmlns:a="http://schemas.openxmlformats.org/drawingml/2006/main">
               <a:ext uri="{FF2B5EF4-FFF2-40B4-BE49-F238E27FC236}">
-                <a16:creationId xmlns:a16="http://schemas.microsoft.com/office/drawing/2014/main" id="{FA7BD11E-6FD9-4454-9654-A6C86F95C4DF}"/>
+                <a16:creationId xmlns:a16="http://schemas.microsoft.com/office/drawing/2014/main" id="{AFACC0A4-0608-474E-8822-D67796824EBC}"/>
               </a:ext>
             </a:extLst>
           </p:cNvPr>
@@ -18252,7 +18252,7 @@
           <p:nvPr/>
         </p:nvPicPr>
         <p:blipFill>
-          <a:blip xmlns:r="http://schemas.openxmlformats.org/officeDocument/2006/relationships" xmlns:a="http://schemas.openxmlformats.org/drawingml/2006/main" r:embed="R2439d6f6e6c3464f"/>
+          <a:blip xmlns:r="http://schemas.openxmlformats.org/officeDocument/2006/relationships" xmlns:a="http://schemas.openxmlformats.org/drawingml/2006/main" r:embed="Rbe369619bc984502"/>
           <a:stretch xmlns:a="http://schemas.openxmlformats.org/drawingml/2006/main"/>
         </p:blipFill>
         <p:spPr>
@@ -18268,10 +18268,10 @@
       <p:sp>
         <p:nvSpPr>
           <p:cNvPr id="21" name="c3-text-34">
-            <a:hlinkClick xmlns:r="http://schemas.openxmlformats.org/officeDocument/2006/relationships" xmlns:a="http://schemas.openxmlformats.org/drawingml/2006/main" r:id="R33bdd40169f64304"/>
-            <a:extLst xmlns:a="http://schemas.openxmlformats.org/drawingml/2006/main">
-              <a:ext uri="{FF2B5EF4-FFF2-40B4-BE49-F238E27FC236}">
-                <a16:creationId xmlns:a16="http://schemas.microsoft.com/office/drawing/2014/main" id="{FFF8B2B9-9594-4E4B-A96A-D0036B38FD39}"/>
+            <a:hlinkClick xmlns:r="http://schemas.openxmlformats.org/officeDocument/2006/relationships" xmlns:a="http://schemas.openxmlformats.org/drawingml/2006/main" r:id="Re31b51cb3727450d"/>
+            <a:extLst xmlns:a="http://schemas.openxmlformats.org/drawingml/2006/main">
+              <a:ext uri="{FF2B5EF4-FFF2-40B4-BE49-F238E27FC236}">
+                <a16:creationId xmlns:a16="http://schemas.microsoft.com/office/drawing/2014/main" id="{6BEB82DB-057B-4D3A-8084-5E2E9BAF9AA7}"/>
               </a:ext>
             </a:extLst>
           </p:cNvPr>
@@ -18328,7 +18328,7 @@
           <p:cNvPr id="22" name="c3-text-35">
             <a:extLst xmlns:a="http://schemas.openxmlformats.org/drawingml/2006/main">
               <a:ext uri="{FF2B5EF4-FFF2-40B4-BE49-F238E27FC236}">
-                <a16:creationId xmlns:a16="http://schemas.microsoft.com/office/drawing/2014/main" id="{8EC99BC8-8100-47CF-A978-57AAF52C7C23}"/>
+                <a16:creationId xmlns:a16="http://schemas.microsoft.com/office/drawing/2014/main" id="{DC29A936-71ED-4F4D-96FC-28BA4F1AFE13}"/>
               </a:ext>
             </a:extLst>
           </p:cNvPr>
@@ -18385,7 +18385,7 @@
           <p:cNvPr id="23" name="c3-text-36">
             <a:extLst xmlns:a="http://schemas.openxmlformats.org/drawingml/2006/main">
               <a:ext uri="{FF2B5EF4-FFF2-40B4-BE49-F238E27FC236}">
-                <a16:creationId xmlns:a16="http://schemas.microsoft.com/office/drawing/2014/main" id="{917B55DF-45B5-4ED7-B915-096254F03ED1}"/>
+                <a16:creationId xmlns:a16="http://schemas.microsoft.com/office/drawing/2014/main" id="{F4B9FD4C-8DA2-43F9-A233-789899227C17}"/>
               </a:ext>
             </a:extLst>
           </p:cNvPr>
@@ -18442,7 +18442,7 @@
           <p:cNvPr id="24" name="c3-shape-37">
             <a:extLst xmlns:a="http://schemas.openxmlformats.org/drawingml/2006/main">
               <a:ext uri="{FF2B5EF4-FFF2-40B4-BE49-F238E27FC236}">
-                <a16:creationId xmlns:a16="http://schemas.microsoft.com/office/drawing/2014/main" id="{3FE556D2-ACE1-4CD7-A2B3-E22EB5CDF91A}"/>
+                <a16:creationId xmlns:a16="http://schemas.microsoft.com/office/drawing/2014/main" id="{474DE487-4E8E-4AD4-96E5-DA9C409C46C0}"/>
               </a:ext>
             </a:extLst>
           </p:cNvPr>
@@ -18476,7 +18476,7 @@
           <p:cNvPr id="25" name="c3-text-38">
             <a:extLst xmlns:a="http://schemas.openxmlformats.org/drawingml/2006/main">
               <a:ext uri="{FF2B5EF4-FFF2-40B4-BE49-F238E27FC236}">
-                <a16:creationId xmlns:a16="http://schemas.microsoft.com/office/drawing/2014/main" id="{8F631616-98D5-47F7-A602-EC67EBDBD73D}"/>
+                <a16:creationId xmlns:a16="http://schemas.microsoft.com/office/drawing/2014/main" id="{08ACDAA4-B142-4A8A-B56A-6E810861866D}"/>
               </a:ext>
             </a:extLst>
           </p:cNvPr>
@@ -18533,7 +18533,7 @@
           <p:cNvPr id="26" name="c3-text-380">
             <a:extLst xmlns:a="http://schemas.openxmlformats.org/drawingml/2006/main">
               <a:ext uri="{FF2B5EF4-FFF2-40B4-BE49-F238E27FC236}">
-                <a16:creationId xmlns:a16="http://schemas.microsoft.com/office/drawing/2014/main" id="{2F55D239-4BA3-4278-A490-54638D0DAA01}"/>
+                <a16:creationId xmlns:a16="http://schemas.microsoft.com/office/drawing/2014/main" id="{07B3C3C6-B5E5-4A28-8A0D-C7F1AC7F6E87}"/>
               </a:ext>
             </a:extLst>
           </p:cNvPr>
@@ -18588,7 +18588,7 @@
     </p:spTree>
     <p:extLst>
       <p:ext uri="{BB962C8B-B14F-4D97-AF65-F5344CB8AC3E}">
-        <p14:creationId xmlns:p14="http://schemas.microsoft.com/office/powerpoint/2010/main" val="551729441"/>
+        <p14:creationId xmlns:p14="http://schemas.microsoft.com/office/powerpoint/2010/main" val="1739114084"/>
       </p:ext>
     </p:extLst>
   </p:cSld>
@@ -18619,7 +18619,7 @@
           <p:cNvPr id="33" name="c3-text-39">
             <a:extLst xmlns:a="http://schemas.openxmlformats.org/drawingml/2006/main">
               <a:ext uri="{FF2B5EF4-FFF2-40B4-BE49-F238E27FC236}">
-                <a16:creationId xmlns:a16="http://schemas.microsoft.com/office/drawing/2014/main" id="{681119C9-688E-44A6-82CF-67EF3CE74CE1}"/>
+                <a16:creationId xmlns:a16="http://schemas.microsoft.com/office/drawing/2014/main" id="{68F1E450-F7B5-40F7-91B4-8E5B187CE471}"/>
               </a:ext>
             </a:extLst>
           </p:cNvPr>
@@ -18676,7 +18676,7 @@
           <p:cNvPr id="2" name="c3-text-40">
             <a:extLst xmlns:a="http://schemas.openxmlformats.org/drawingml/2006/main">
               <a:ext uri="{FF2B5EF4-FFF2-40B4-BE49-F238E27FC236}">
-                <a16:creationId xmlns:a16="http://schemas.microsoft.com/office/drawing/2014/main" id="{A462A6F8-0FD4-49D7-A121-1010F936A5DF}"/>
+                <a16:creationId xmlns:a16="http://schemas.microsoft.com/office/drawing/2014/main" id="{350F5EE7-BEBC-431D-AEB9-8DFF1B1674F4}"/>
               </a:ext>
             </a:extLst>
           </p:cNvPr>
@@ -18733,7 +18733,7 @@
           <p:cNvPr id="3" name="c3-text-41">
             <a:extLst xmlns:a="http://schemas.openxmlformats.org/drawingml/2006/main">
               <a:ext uri="{FF2B5EF4-FFF2-40B4-BE49-F238E27FC236}">
-                <a16:creationId xmlns:a16="http://schemas.microsoft.com/office/drawing/2014/main" id="{53914E8B-FDC9-443A-8BF0-6C9290CB6F91}"/>
+                <a16:creationId xmlns:a16="http://schemas.microsoft.com/office/drawing/2014/main" id="{A1BB81D0-9412-4F18-A882-EEE8B55C9B17}"/>
               </a:ext>
             </a:extLst>
           </p:cNvPr>
@@ -18790,7 +18790,7 @@
           <p:cNvPr id="4" name="c3-shape-42">
             <a:extLst xmlns:a="http://schemas.openxmlformats.org/drawingml/2006/main">
               <a:ext uri="{FF2B5EF4-FFF2-40B4-BE49-F238E27FC236}">
-                <a16:creationId xmlns:a16="http://schemas.microsoft.com/office/drawing/2014/main" id="{ED4D96DE-6366-4456-AC1A-A25CE17EDDD5}"/>
+                <a16:creationId xmlns:a16="http://schemas.microsoft.com/office/drawing/2014/main" id="{0D612607-72EA-48D8-91A6-51DDFDA64A92}"/>
               </a:ext>
             </a:extLst>
           </p:cNvPr>
@@ -18828,7 +18828,7 @@
           <p:nvPr/>
         </p:nvPicPr>
         <p:blipFill>
-          <a:blip xmlns:r="http://schemas.openxmlformats.org/officeDocument/2006/relationships" xmlns:a="http://schemas.openxmlformats.org/drawingml/2006/main" r:embed="R48d5606b45a04452"/>
+          <a:blip xmlns:r="http://schemas.openxmlformats.org/officeDocument/2006/relationships" xmlns:a="http://schemas.openxmlformats.org/drawingml/2006/main" r:embed="R88199afc257b41eb"/>
           <a:stretch xmlns:a="http://schemas.openxmlformats.org/drawingml/2006/main"/>
         </p:blipFill>
         <p:spPr>
@@ -18846,7 +18846,7 @@
           <p:cNvPr id="6" name="c3-shape-43">
             <a:extLst xmlns:a="http://schemas.openxmlformats.org/drawingml/2006/main">
               <a:ext uri="{FF2B5EF4-FFF2-40B4-BE49-F238E27FC236}">
-                <a16:creationId xmlns:a16="http://schemas.microsoft.com/office/drawing/2014/main" id="{3C1F3BF5-4B58-4E3B-A819-011E2DFF9436}"/>
+                <a16:creationId xmlns:a16="http://schemas.microsoft.com/office/drawing/2014/main" id="{60B72412-FA36-4EE6-8700-DB2332D65CDD}"/>
               </a:ext>
             </a:extLst>
           </p:cNvPr>
@@ -18880,7 +18880,7 @@
           <p:cNvPr id="7" name="c3-shape-44">
             <a:extLst xmlns:a="http://schemas.openxmlformats.org/drawingml/2006/main">
               <a:ext uri="{FF2B5EF4-FFF2-40B4-BE49-F238E27FC236}">
-                <a16:creationId xmlns:a16="http://schemas.microsoft.com/office/drawing/2014/main" id="{50F00815-510E-4D75-89BC-DF2D7681DE7D}"/>
+                <a16:creationId xmlns:a16="http://schemas.microsoft.com/office/drawing/2014/main" id="{F8E1BA6B-C7B0-40CE-BF8E-D78739DA5FBB}"/>
               </a:ext>
             </a:extLst>
           </p:cNvPr>
@@ -18912,7 +18912,7 @@
           <p:cNvPr id="8" name="c3-text-45">
             <a:extLst xmlns:a="http://schemas.openxmlformats.org/drawingml/2006/main">
               <a:ext uri="{FF2B5EF4-FFF2-40B4-BE49-F238E27FC236}">
-                <a16:creationId xmlns:a16="http://schemas.microsoft.com/office/drawing/2014/main" id="{8475C66D-A248-4BF4-8F35-235911E7A5AF}"/>
+                <a16:creationId xmlns:a16="http://schemas.microsoft.com/office/drawing/2014/main" id="{4C2D427C-7EF9-4417-88A0-12884A138A36}"/>
               </a:ext>
             </a:extLst>
           </p:cNvPr>
@@ -18969,7 +18969,7 @@
           <p:cNvPr id="9" name="c3-text-46">
             <a:extLst xmlns:a="http://schemas.openxmlformats.org/drawingml/2006/main">
               <a:ext uri="{FF2B5EF4-FFF2-40B4-BE49-F238E27FC236}">
-                <a16:creationId xmlns:a16="http://schemas.microsoft.com/office/drawing/2014/main" id="{6A04B6AF-FD30-4992-B66A-77A3DF8E768D}"/>
+                <a16:creationId xmlns:a16="http://schemas.microsoft.com/office/drawing/2014/main" id="{EC9976F9-3DAB-4D88-87C7-27102DCD760E}"/>
               </a:ext>
             </a:extLst>
           </p:cNvPr>
@@ -19026,7 +19026,7 @@
           <p:cNvPr id="10" name="c3-shape-47">
             <a:extLst xmlns:a="http://schemas.openxmlformats.org/drawingml/2006/main">
               <a:ext uri="{FF2B5EF4-FFF2-40B4-BE49-F238E27FC236}">
-                <a16:creationId xmlns:a16="http://schemas.microsoft.com/office/drawing/2014/main" id="{11C759EC-91BA-4843-95BE-D0195301553F}"/>
+                <a16:creationId xmlns:a16="http://schemas.microsoft.com/office/drawing/2014/main" id="{5F2948E6-B435-48B2-8C3E-D5E06DC5EBE9}"/>
               </a:ext>
             </a:extLst>
           </p:cNvPr>
@@ -19060,7 +19060,7 @@
           <p:cNvPr id="11" name="c3-shape-48">
             <a:extLst xmlns:a="http://schemas.openxmlformats.org/drawingml/2006/main">
               <a:ext uri="{FF2B5EF4-FFF2-40B4-BE49-F238E27FC236}">
-                <a16:creationId xmlns:a16="http://schemas.microsoft.com/office/drawing/2014/main" id="{22012E50-B9A2-4C3C-88DC-1CFBFCDC7533}"/>
+                <a16:creationId xmlns:a16="http://schemas.microsoft.com/office/drawing/2014/main" id="{D7428EDB-ED1E-47E6-BF26-59A2B550C098}"/>
               </a:ext>
             </a:extLst>
           </p:cNvPr>
@@ -19092,7 +19092,7 @@
           <p:cNvPr id="12" name="c3-text-49">
             <a:extLst xmlns:a="http://schemas.openxmlformats.org/drawingml/2006/main">
               <a:ext uri="{FF2B5EF4-FFF2-40B4-BE49-F238E27FC236}">
-                <a16:creationId xmlns:a16="http://schemas.microsoft.com/office/drawing/2014/main" id="{837282DA-FDAA-4D59-A2D7-486C86A3DA56}"/>
+                <a16:creationId xmlns:a16="http://schemas.microsoft.com/office/drawing/2014/main" id="{E781A93E-6693-4800-A97D-AB698DEA2691}"/>
               </a:ext>
             </a:extLst>
           </p:cNvPr>
@@ -19149,7 +19149,7 @@
           <p:cNvPr id="13" name="c3-text-50">
             <a:extLst xmlns:a="http://schemas.openxmlformats.org/drawingml/2006/main">
               <a:ext uri="{FF2B5EF4-FFF2-40B4-BE49-F238E27FC236}">
-                <a16:creationId xmlns:a16="http://schemas.microsoft.com/office/drawing/2014/main" id="{7338D023-548E-4AA9-8116-F2AB1E703451}"/>
+                <a16:creationId xmlns:a16="http://schemas.microsoft.com/office/drawing/2014/main" id="{76C58DC7-D182-4DE6-973E-2EC543893B64}"/>
               </a:ext>
             </a:extLst>
           </p:cNvPr>
@@ -19206,7 +19206,7 @@
           <p:cNvPr id="14" name="c3-shape-51">
             <a:extLst xmlns:a="http://schemas.openxmlformats.org/drawingml/2006/main">
               <a:ext uri="{FF2B5EF4-FFF2-40B4-BE49-F238E27FC236}">
-                <a16:creationId xmlns:a16="http://schemas.microsoft.com/office/drawing/2014/main" id="{6F1EFE5D-A79C-4508-A363-E6E7A3341F91}"/>
+                <a16:creationId xmlns:a16="http://schemas.microsoft.com/office/drawing/2014/main" id="{C1B9551D-11D8-42D4-86D8-A499B918F5A7}"/>
               </a:ext>
             </a:extLst>
           </p:cNvPr>
@@ -19240,7 +19240,7 @@
           <p:cNvPr id="15" name="c3-shape-52">
             <a:extLst xmlns:a="http://schemas.openxmlformats.org/drawingml/2006/main">
               <a:ext uri="{FF2B5EF4-FFF2-40B4-BE49-F238E27FC236}">
-                <a16:creationId xmlns:a16="http://schemas.microsoft.com/office/drawing/2014/main" id="{632CD959-0BEC-4CFC-BC76-8E5122CAA30E}"/>
+                <a16:creationId xmlns:a16="http://schemas.microsoft.com/office/drawing/2014/main" id="{E0A29FF1-2F1A-4DDE-85EB-0576C0CC0D23}"/>
               </a:ext>
             </a:extLst>
           </p:cNvPr>
@@ -19272,7 +19272,7 @@
           <p:cNvPr id="16" name="c3-text-53">
             <a:extLst xmlns:a="http://schemas.openxmlformats.org/drawingml/2006/main">
               <a:ext uri="{FF2B5EF4-FFF2-40B4-BE49-F238E27FC236}">
-                <a16:creationId xmlns:a16="http://schemas.microsoft.com/office/drawing/2014/main" id="{B1B405D2-496D-4974-8850-8C7E5D2A8941}"/>
+                <a16:creationId xmlns:a16="http://schemas.microsoft.com/office/drawing/2014/main" id="{BBD1E884-9052-41F5-AD4A-0BC005F85A30}"/>
               </a:ext>
             </a:extLst>
           </p:cNvPr>
@@ -19329,7 +19329,7 @@
           <p:cNvPr id="17" name="c3-text-54">
             <a:extLst xmlns:a="http://schemas.openxmlformats.org/drawingml/2006/main">
               <a:ext uri="{FF2B5EF4-FFF2-40B4-BE49-F238E27FC236}">
-                <a16:creationId xmlns:a16="http://schemas.microsoft.com/office/drawing/2014/main" id="{1BDE9FA0-BFDE-4A28-B4FE-210AE3DE4804}"/>
+                <a16:creationId xmlns:a16="http://schemas.microsoft.com/office/drawing/2014/main" id="{FE0793E0-E6FA-4D37-8E13-A073E7F14521}"/>
               </a:ext>
             </a:extLst>
           </p:cNvPr>
@@ -19386,7 +19386,7 @@
           <p:cNvPr id="18" name="c3-shape-55">
             <a:extLst xmlns:a="http://schemas.openxmlformats.org/drawingml/2006/main">
               <a:ext uri="{FF2B5EF4-FFF2-40B4-BE49-F238E27FC236}">
-                <a16:creationId xmlns:a16="http://schemas.microsoft.com/office/drawing/2014/main" id="{48089EE5-29A5-43A8-B9A0-FAF634B90603}"/>
+                <a16:creationId xmlns:a16="http://schemas.microsoft.com/office/drawing/2014/main" id="{91A16EEC-BA10-460D-B090-088ADD9D10BD}"/>
               </a:ext>
             </a:extLst>
           </p:cNvPr>
@@ -19420,7 +19420,7 @@
           <p:cNvPr id="19" name="c3-shape-56">
             <a:extLst xmlns:a="http://schemas.openxmlformats.org/drawingml/2006/main">
               <a:ext uri="{FF2B5EF4-FFF2-40B4-BE49-F238E27FC236}">
-                <a16:creationId xmlns:a16="http://schemas.microsoft.com/office/drawing/2014/main" id="{2D775F5F-8AA8-42D1-B411-112A5C0E3CC5}"/>
+                <a16:creationId xmlns:a16="http://schemas.microsoft.com/office/drawing/2014/main" id="{1703AD60-8606-4726-ADC1-85BE30AE0100}"/>
               </a:ext>
             </a:extLst>
           </p:cNvPr>
@@ -19452,7 +19452,7 @@
           <p:cNvPr id="20" name="c3-text-57">
             <a:extLst xmlns:a="http://schemas.openxmlformats.org/drawingml/2006/main">
               <a:ext uri="{FF2B5EF4-FFF2-40B4-BE49-F238E27FC236}">
-                <a16:creationId xmlns:a16="http://schemas.microsoft.com/office/drawing/2014/main" id="{73AC908B-3E5E-4056-9A99-DD04B6AF863F}"/>
+                <a16:creationId xmlns:a16="http://schemas.microsoft.com/office/drawing/2014/main" id="{5DA6064B-1C6E-4A9A-AFD8-DD166B55948F}"/>
               </a:ext>
             </a:extLst>
           </p:cNvPr>
@@ -19509,7 +19509,7 @@
           <p:cNvPr id="21" name="c3-text-58">
             <a:extLst xmlns:a="http://schemas.openxmlformats.org/drawingml/2006/main">
               <a:ext uri="{FF2B5EF4-FFF2-40B4-BE49-F238E27FC236}">
-                <a16:creationId xmlns:a16="http://schemas.microsoft.com/office/drawing/2014/main" id="{0C950099-E12B-4CB6-AB42-BE5462D300A1}"/>
+                <a16:creationId xmlns:a16="http://schemas.microsoft.com/office/drawing/2014/main" id="{ECC592B9-31A9-4E19-9FE6-0E9059B1B914}"/>
               </a:ext>
             </a:extLst>
           </p:cNvPr>
@@ -19566,7 +19566,7 @@
           <p:cNvPr id="22" name="c3-shape-59">
             <a:extLst xmlns:a="http://schemas.openxmlformats.org/drawingml/2006/main">
               <a:ext uri="{FF2B5EF4-FFF2-40B4-BE49-F238E27FC236}">
-                <a16:creationId xmlns:a16="http://schemas.microsoft.com/office/drawing/2014/main" id="{7753ABBE-D0C2-4179-A8B5-7DE1DB5CDD55}"/>
+                <a16:creationId xmlns:a16="http://schemas.microsoft.com/office/drawing/2014/main" id="{5045391C-CC55-4B87-A502-CC99050B2984}"/>
               </a:ext>
             </a:extLst>
           </p:cNvPr>
@@ -19600,7 +19600,7 @@
           <p:cNvPr id="23" name="c3-shape-60">
             <a:extLst xmlns:a="http://schemas.openxmlformats.org/drawingml/2006/main">
               <a:ext uri="{FF2B5EF4-FFF2-40B4-BE49-F238E27FC236}">
-                <a16:creationId xmlns:a16="http://schemas.microsoft.com/office/drawing/2014/main" id="{982D5A0A-6D69-4B20-A657-50524D26442C}"/>
+                <a16:creationId xmlns:a16="http://schemas.microsoft.com/office/drawing/2014/main" id="{3C4B8109-ED12-4ECA-80C4-C501DB7C0994}"/>
               </a:ext>
             </a:extLst>
           </p:cNvPr>
@@ -19632,7 +19632,7 @@
           <p:cNvPr id="24" name="c3-text-61">
             <a:extLst xmlns:a="http://schemas.openxmlformats.org/drawingml/2006/main">
               <a:ext uri="{FF2B5EF4-FFF2-40B4-BE49-F238E27FC236}">
-                <a16:creationId xmlns:a16="http://schemas.microsoft.com/office/drawing/2014/main" id="{4168D5D1-491D-4AD2-87F5-3509DBD571DD}"/>
+                <a16:creationId xmlns:a16="http://schemas.microsoft.com/office/drawing/2014/main" id="{F396B728-BFC6-4C69-B76F-2DFEC605C199}"/>
               </a:ext>
             </a:extLst>
           </p:cNvPr>
@@ -19689,7 +19689,7 @@
           <p:cNvPr id="25" name="c3-text-62">
             <a:extLst xmlns:a="http://schemas.openxmlformats.org/drawingml/2006/main">
               <a:ext uri="{FF2B5EF4-FFF2-40B4-BE49-F238E27FC236}">
-                <a16:creationId xmlns:a16="http://schemas.microsoft.com/office/drawing/2014/main" id="{F2B491F1-A23E-4BE1-9884-1BA211CEBBA3}"/>
+                <a16:creationId xmlns:a16="http://schemas.microsoft.com/office/drawing/2014/main" id="{41BEF885-FFDB-4A6D-A920-DB0D71B20F96}"/>
               </a:ext>
             </a:extLst>
           </p:cNvPr>
@@ -19746,7 +19746,7 @@
           <p:cNvPr id="26" name="c3-shape-63">
             <a:extLst xmlns:a="http://schemas.openxmlformats.org/drawingml/2006/main">
               <a:ext uri="{FF2B5EF4-FFF2-40B4-BE49-F238E27FC236}">
-                <a16:creationId xmlns:a16="http://schemas.microsoft.com/office/drawing/2014/main" id="{9449B3A9-216C-4888-B37D-DF3F4FD48C25}"/>
+                <a16:creationId xmlns:a16="http://schemas.microsoft.com/office/drawing/2014/main" id="{30B38882-0654-4019-958F-170DB62F1B18}"/>
               </a:ext>
             </a:extLst>
           </p:cNvPr>
@@ -19780,7 +19780,7 @@
           <p:cNvPr id="27" name="c3-shape-64">
             <a:extLst xmlns:a="http://schemas.openxmlformats.org/drawingml/2006/main">
               <a:ext uri="{FF2B5EF4-FFF2-40B4-BE49-F238E27FC236}">
-                <a16:creationId xmlns:a16="http://schemas.microsoft.com/office/drawing/2014/main" id="{B08EF84D-DC02-4C5F-AF25-A2A985532C68}"/>
+                <a16:creationId xmlns:a16="http://schemas.microsoft.com/office/drawing/2014/main" id="{ED8437F4-56BA-48B1-B962-6620BCB1BD02}"/>
               </a:ext>
             </a:extLst>
           </p:cNvPr>
@@ -19812,7 +19812,7 @@
           <p:cNvPr id="28" name="c3-text-65">
             <a:extLst xmlns:a="http://schemas.openxmlformats.org/drawingml/2006/main">
               <a:ext uri="{FF2B5EF4-FFF2-40B4-BE49-F238E27FC236}">
-                <a16:creationId xmlns:a16="http://schemas.microsoft.com/office/drawing/2014/main" id="{E39FE1D8-99D4-4982-AE3B-A47C6217F2CB}"/>
+                <a16:creationId xmlns:a16="http://schemas.microsoft.com/office/drawing/2014/main" id="{A4BA86D7-33C6-4407-917A-02D18C85BFF4}"/>
               </a:ext>
             </a:extLst>
           </p:cNvPr>
@@ -19869,7 +19869,7 @@
           <p:cNvPr id="29" name="c3-text-66">
             <a:extLst xmlns:a="http://schemas.openxmlformats.org/drawingml/2006/main">
               <a:ext uri="{FF2B5EF4-FFF2-40B4-BE49-F238E27FC236}">
-                <a16:creationId xmlns:a16="http://schemas.microsoft.com/office/drawing/2014/main" id="{45F2B47C-ED0B-4EBE-9085-D7957BCC88D1}"/>
+                <a16:creationId xmlns:a16="http://schemas.microsoft.com/office/drawing/2014/main" id="{606858A0-94B6-4261-AC83-E7EEF71DE5ED}"/>
               </a:ext>
             </a:extLst>
           </p:cNvPr>
@@ -19926,7 +19926,7 @@
           <p:cNvPr id="30" name="c3-shape-67">
             <a:extLst xmlns:a="http://schemas.openxmlformats.org/drawingml/2006/main">
               <a:ext uri="{FF2B5EF4-FFF2-40B4-BE49-F238E27FC236}">
-                <a16:creationId xmlns:a16="http://schemas.microsoft.com/office/drawing/2014/main" id="{E098D3A0-F021-4ED9-B9C5-991A26571C7D}"/>
+                <a16:creationId xmlns:a16="http://schemas.microsoft.com/office/drawing/2014/main" id="{35826316-6689-4348-A745-087FA70491FC}"/>
               </a:ext>
             </a:extLst>
           </p:cNvPr>
@@ -19960,7 +19960,7 @@
           <p:cNvPr id="31" name="c3-text-68">
             <a:extLst xmlns:a="http://schemas.openxmlformats.org/drawingml/2006/main">
               <a:ext uri="{FF2B5EF4-FFF2-40B4-BE49-F238E27FC236}">
-                <a16:creationId xmlns:a16="http://schemas.microsoft.com/office/drawing/2014/main" id="{FF4DA520-8AA0-48DC-A20D-793AE6F7A1E0}"/>
+                <a16:creationId xmlns:a16="http://schemas.microsoft.com/office/drawing/2014/main" id="{C711B9D2-04C3-4D1F-ADB0-EBBDC5E4A327}"/>
               </a:ext>
             </a:extLst>
           </p:cNvPr>
@@ -20017,7 +20017,7 @@
           <p:cNvPr id="32" name="c3-text-381">
             <a:extLst xmlns:a="http://schemas.openxmlformats.org/drawingml/2006/main">
               <a:ext uri="{FF2B5EF4-FFF2-40B4-BE49-F238E27FC236}">
-                <a16:creationId xmlns:a16="http://schemas.microsoft.com/office/drawing/2014/main" id="{FB776D3F-4C3C-4053-A8D3-330A9E0D47D0}"/>
+                <a16:creationId xmlns:a16="http://schemas.microsoft.com/office/drawing/2014/main" id="{AA531CE6-D264-44C9-BAC0-754903DA6B85}"/>
               </a:ext>
             </a:extLst>
           </p:cNvPr>
@@ -20072,7 +20072,7 @@
     </p:spTree>
     <p:extLst>
       <p:ext uri="{BB962C8B-B14F-4D97-AF65-F5344CB8AC3E}">
-        <p14:creationId xmlns:p14="http://schemas.microsoft.com/office/powerpoint/2010/main" val="1161732390"/>
+        <p14:creationId xmlns:p14="http://schemas.microsoft.com/office/powerpoint/2010/main" val="319118449"/>
       </p:ext>
     </p:extLst>
   </p:cSld>
@@ -20103,7 +20103,7 @@
           <p:cNvPr id="29" name="c3-text-69">
             <a:extLst xmlns:a="http://schemas.openxmlformats.org/drawingml/2006/main">
               <a:ext uri="{FF2B5EF4-FFF2-40B4-BE49-F238E27FC236}">
-                <a16:creationId xmlns:a16="http://schemas.microsoft.com/office/drawing/2014/main" id="{CE0594A4-7FCC-4231-925F-736B60B54A91}"/>
+                <a16:creationId xmlns:a16="http://schemas.microsoft.com/office/drawing/2014/main" id="{770C6BE2-88C6-461A-9DF1-3999F4FAC003}"/>
               </a:ext>
             </a:extLst>
           </p:cNvPr>
@@ -20160,7 +20160,7 @@
           <p:cNvPr id="2" name="c3-text-70">
             <a:extLst xmlns:a="http://schemas.openxmlformats.org/drawingml/2006/main">
               <a:ext uri="{FF2B5EF4-FFF2-40B4-BE49-F238E27FC236}">
-                <a16:creationId xmlns:a16="http://schemas.microsoft.com/office/drawing/2014/main" id="{7B4A60E4-F179-4EA6-8237-9A9E73E9FDEE}"/>
+                <a16:creationId xmlns:a16="http://schemas.microsoft.com/office/drawing/2014/main" id="{44044FB9-90F2-43A4-B451-FF1EB83548F2}"/>
               </a:ext>
             </a:extLst>
           </p:cNvPr>
@@ -20217,7 +20217,7 @@
           <p:cNvPr id="3" name="c3-text-71">
             <a:extLst xmlns:a="http://schemas.openxmlformats.org/drawingml/2006/main">
               <a:ext uri="{FF2B5EF4-FFF2-40B4-BE49-F238E27FC236}">
-                <a16:creationId xmlns:a16="http://schemas.microsoft.com/office/drawing/2014/main" id="{40E5B45D-E7AE-4762-A9DF-47320C1F1096}"/>
+                <a16:creationId xmlns:a16="http://schemas.microsoft.com/office/drawing/2014/main" id="{570D690D-DB4C-4F89-8FF4-A90DAFF29EDD}"/>
               </a:ext>
             </a:extLst>
           </p:cNvPr>
@@ -20274,7 +20274,7 @@
           <p:cNvPr id="4" name="c3-shape-72">
             <a:extLst xmlns:a="http://schemas.openxmlformats.org/drawingml/2006/main">
               <a:ext uri="{FF2B5EF4-FFF2-40B4-BE49-F238E27FC236}">
-                <a16:creationId xmlns:a16="http://schemas.microsoft.com/office/drawing/2014/main" id="{E71C0288-C46D-4230-AE35-E8302E34A641}"/>
+                <a16:creationId xmlns:a16="http://schemas.microsoft.com/office/drawing/2014/main" id="{25ED191E-DCB9-4050-B3EF-712263073518}"/>
               </a:ext>
             </a:extLst>
           </p:cNvPr>
@@ -20312,7 +20312,7 @@
           <p:nvPr/>
         </p:nvPicPr>
         <p:blipFill>
-          <a:blip xmlns:r="http://schemas.openxmlformats.org/officeDocument/2006/relationships" xmlns:a="http://schemas.openxmlformats.org/drawingml/2006/main" r:embed="Ra4a65b4eab214ae2"/>
+          <a:blip xmlns:r="http://schemas.openxmlformats.org/officeDocument/2006/relationships" xmlns:a="http://schemas.openxmlformats.org/drawingml/2006/main" r:embed="R331b2d84d5a84345"/>
           <a:stretch xmlns:a="http://schemas.openxmlformats.org/drawingml/2006/main"/>
         </p:blipFill>
         <p:spPr>
@@ -20330,7 +20330,7 @@
           <p:cNvPr id="6" name="c3-shape-73">
             <a:extLst xmlns:a="http://schemas.openxmlformats.org/drawingml/2006/main">
               <a:ext uri="{FF2B5EF4-FFF2-40B4-BE49-F238E27FC236}">
-                <a16:creationId xmlns:a16="http://schemas.microsoft.com/office/drawing/2014/main" id="{524FA593-22DF-4E0E-A2B8-D4FDCEE4B2AA}"/>
+                <a16:creationId xmlns:a16="http://schemas.microsoft.com/office/drawing/2014/main" id="{7BBB42FF-44FD-479A-AF40-9D49E8D738DE}"/>
               </a:ext>
             </a:extLst>
           </p:cNvPr>
@@ -20364,7 +20364,7 @@
           <p:cNvPr id="7" name="c3-shape-74">
             <a:extLst xmlns:a="http://schemas.openxmlformats.org/drawingml/2006/main">
               <a:ext uri="{FF2B5EF4-FFF2-40B4-BE49-F238E27FC236}">
-                <a16:creationId xmlns:a16="http://schemas.microsoft.com/office/drawing/2014/main" id="{63932AE3-00D0-4A10-953A-228504BC9632}"/>
+                <a16:creationId xmlns:a16="http://schemas.microsoft.com/office/drawing/2014/main" id="{77B78E59-9D90-42F8-89CC-2D83B443DD8F}"/>
               </a:ext>
             </a:extLst>
           </p:cNvPr>
@@ -20396,7 +20396,7 @@
           <p:cNvPr id="8" name="c3-text-75">
             <a:extLst xmlns:a="http://schemas.openxmlformats.org/drawingml/2006/main">
               <a:ext uri="{FF2B5EF4-FFF2-40B4-BE49-F238E27FC236}">
-                <a16:creationId xmlns:a16="http://schemas.microsoft.com/office/drawing/2014/main" id="{434C8CCC-29DC-4946-A557-A1109340A02A}"/>
+                <a16:creationId xmlns:a16="http://schemas.microsoft.com/office/drawing/2014/main" id="{C10F0E88-44EB-469F-AC9D-16038F3687A1}"/>
               </a:ext>
             </a:extLst>
           </p:cNvPr>
@@ -20453,7 +20453,7 @@
           <p:cNvPr id="9" name="c3-text-76">
             <a:extLst xmlns:a="http://schemas.openxmlformats.org/drawingml/2006/main">
               <a:ext uri="{FF2B5EF4-FFF2-40B4-BE49-F238E27FC236}">
-                <a16:creationId xmlns:a16="http://schemas.microsoft.com/office/drawing/2014/main" id="{91A87DE0-CEF1-4880-BD5D-0644FB1E4D1C}"/>
+                <a16:creationId xmlns:a16="http://schemas.microsoft.com/office/drawing/2014/main" id="{9E6F5DE0-1E7F-4BBC-8AFB-8E6ED879D666}"/>
               </a:ext>
             </a:extLst>
           </p:cNvPr>
@@ -20510,7 +20510,7 @@
           <p:cNvPr id="10" name="c3-shape-77">
             <a:extLst xmlns:a="http://schemas.openxmlformats.org/drawingml/2006/main">
               <a:ext uri="{FF2B5EF4-FFF2-40B4-BE49-F238E27FC236}">
-                <a16:creationId xmlns:a16="http://schemas.microsoft.com/office/drawing/2014/main" id="{9E3FD3D1-A7C4-45EF-A3A6-5A5F0A203E8F}"/>
+                <a16:creationId xmlns:a16="http://schemas.microsoft.com/office/drawing/2014/main" id="{021AEA2C-43D0-40D7-AF35-3EFC1FF37FFB}"/>
               </a:ext>
             </a:extLst>
           </p:cNvPr>
@@ -20544,7 +20544,7 @@
           <p:cNvPr id="11" name="c3-shape-78">
             <a:extLst xmlns:a="http://schemas.openxmlformats.org/drawingml/2006/main">
               <a:ext uri="{FF2B5EF4-FFF2-40B4-BE49-F238E27FC236}">
-                <a16:creationId xmlns:a16="http://schemas.microsoft.com/office/drawing/2014/main" id="{8F29F943-2372-4DF5-B349-4BB8AB8A4E29}"/>
+                <a16:creationId xmlns:a16="http://schemas.microsoft.com/office/drawing/2014/main" id="{CC1B8198-1F87-475B-B924-59D370E9C9D2}"/>
               </a:ext>
             </a:extLst>
           </p:cNvPr>
@@ -20576,7 +20576,7 @@
           <p:cNvPr id="12" name="c3-text-79">
             <a:extLst xmlns:a="http://schemas.openxmlformats.org/drawingml/2006/main">
               <a:ext uri="{FF2B5EF4-FFF2-40B4-BE49-F238E27FC236}">
-                <a16:creationId xmlns:a16="http://schemas.microsoft.com/office/drawing/2014/main" id="{D197196D-8E9E-487F-8AEF-37106B47CFD2}"/>
+                <a16:creationId xmlns:a16="http://schemas.microsoft.com/office/drawing/2014/main" id="{4D1E8FF5-2169-4DC1-B008-BD76C66F1C2E}"/>
               </a:ext>
             </a:extLst>
           </p:cNvPr>
@@ -20633,7 +20633,7 @@
           <p:cNvPr id="13" name="c3-text-80">
             <a:extLst xmlns:a="http://schemas.openxmlformats.org/drawingml/2006/main">
               <a:ext uri="{FF2B5EF4-FFF2-40B4-BE49-F238E27FC236}">
-                <a16:creationId xmlns:a16="http://schemas.microsoft.com/office/drawing/2014/main" id="{58181085-02BA-47EA-A3E0-2AF3FA3F6E96}"/>
+                <a16:creationId xmlns:a16="http://schemas.microsoft.com/office/drawing/2014/main" id="{9CABCEA7-7967-4EF7-B827-49F28B33AE51}"/>
               </a:ext>
             </a:extLst>
           </p:cNvPr>
@@ -20690,7 +20690,7 @@
           <p:cNvPr id="14" name="c3-shape-81">
             <a:extLst xmlns:a="http://schemas.openxmlformats.org/drawingml/2006/main">
               <a:ext uri="{FF2B5EF4-FFF2-40B4-BE49-F238E27FC236}">
-                <a16:creationId xmlns:a16="http://schemas.microsoft.com/office/drawing/2014/main" id="{B46A599A-85E4-42AC-9471-BB99EA2C33A9}"/>
+                <a16:creationId xmlns:a16="http://schemas.microsoft.com/office/drawing/2014/main" id="{FA08ACAF-5BDE-45C6-803F-89B68D845931}"/>
               </a:ext>
             </a:extLst>
           </p:cNvPr>
@@ -20724,7 +20724,7 @@
           <p:cNvPr id="15" name="c3-shape-82">
             <a:extLst xmlns:a="http://schemas.openxmlformats.org/drawingml/2006/main">
               <a:ext uri="{FF2B5EF4-FFF2-40B4-BE49-F238E27FC236}">
-                <a16:creationId xmlns:a16="http://schemas.microsoft.com/office/drawing/2014/main" id="{FE76B9D4-431C-43C5-9D2B-128DCCDE513B}"/>
+                <a16:creationId xmlns:a16="http://schemas.microsoft.com/office/drawing/2014/main" id="{D165871B-A226-45E2-A3F8-85A4FF36588D}"/>
               </a:ext>
             </a:extLst>
           </p:cNvPr>
@@ -20756,7 +20756,7 @@
           <p:cNvPr id="16" name="c3-text-83">
             <a:extLst xmlns:a="http://schemas.openxmlformats.org/drawingml/2006/main">
               <a:ext uri="{FF2B5EF4-FFF2-40B4-BE49-F238E27FC236}">
-                <a16:creationId xmlns:a16="http://schemas.microsoft.com/office/drawing/2014/main" id="{D2522D72-D289-436D-8D02-3CAFBB95551A}"/>
+                <a16:creationId xmlns:a16="http://schemas.microsoft.com/office/drawing/2014/main" id="{052CACE8-C95D-4F38-8EEB-F0DD8CAB0AA3}"/>
               </a:ext>
             </a:extLst>
           </p:cNvPr>
@@ -20813,7 +20813,7 @@
           <p:cNvPr id="17" name="c3-text-84">
             <a:extLst xmlns:a="http://schemas.openxmlformats.org/drawingml/2006/main">
               <a:ext uri="{FF2B5EF4-FFF2-40B4-BE49-F238E27FC236}">
-                <a16:creationId xmlns:a16="http://schemas.microsoft.com/office/drawing/2014/main" id="{8C403925-FCEA-4ACC-AAF7-CF51F04ED49D}"/>
+                <a16:creationId xmlns:a16="http://schemas.microsoft.com/office/drawing/2014/main" id="{2CE90C4A-9E4F-450C-83C1-0C1AB0F685DC}"/>
               </a:ext>
             </a:extLst>
           </p:cNvPr>
@@ -20870,7 +20870,7 @@
           <p:cNvPr id="18" name="c3-shape-85">
             <a:extLst xmlns:a="http://schemas.openxmlformats.org/drawingml/2006/main">
               <a:ext uri="{FF2B5EF4-FFF2-40B4-BE49-F238E27FC236}">
-                <a16:creationId xmlns:a16="http://schemas.microsoft.com/office/drawing/2014/main" id="{E62F7CF7-63A6-4BC0-BC2A-C9D1D58CD0CF}"/>
+                <a16:creationId xmlns:a16="http://schemas.microsoft.com/office/drawing/2014/main" id="{7D989323-54B1-4675-82A9-FFE261AE8F7C}"/>
               </a:ext>
             </a:extLst>
           </p:cNvPr>
@@ -20904,7 +20904,7 @@
           <p:cNvPr id="19" name="c3-shape-86">
             <a:extLst xmlns:a="http://schemas.openxmlformats.org/drawingml/2006/main">
               <a:ext uri="{FF2B5EF4-FFF2-40B4-BE49-F238E27FC236}">
-                <a16:creationId xmlns:a16="http://schemas.microsoft.com/office/drawing/2014/main" id="{1220FDDE-6A20-45DB-9CF2-F9A49995AD35}"/>
+                <a16:creationId xmlns:a16="http://schemas.microsoft.com/office/drawing/2014/main" id="{3DCCD584-7BE7-4B6F-BAEB-B32E70FE93E8}"/>
               </a:ext>
             </a:extLst>
           </p:cNvPr>
@@ -20936,7 +20936,7 @@
           <p:cNvPr id="20" name="c3-text-87">
             <a:extLst xmlns:a="http://schemas.openxmlformats.org/drawingml/2006/main">
               <a:ext uri="{FF2B5EF4-FFF2-40B4-BE49-F238E27FC236}">
-                <a16:creationId xmlns:a16="http://schemas.microsoft.com/office/drawing/2014/main" id="{77C611F0-2789-464E-AC42-54B1A7A40D70}"/>
+                <a16:creationId xmlns:a16="http://schemas.microsoft.com/office/drawing/2014/main" id="{7DFA8E20-1051-4BEB-9BBC-D667229C086C}"/>
               </a:ext>
             </a:extLst>
           </p:cNvPr>
@@ -20993,7 +20993,7 @@
           <p:cNvPr id="21" name="c3-text-88">
             <a:extLst xmlns:a="http://schemas.openxmlformats.org/drawingml/2006/main">
               <a:ext uri="{FF2B5EF4-FFF2-40B4-BE49-F238E27FC236}">
-                <a16:creationId xmlns:a16="http://schemas.microsoft.com/office/drawing/2014/main" id="{CF1CC72B-8221-4FB5-8974-07E5C865FDDD}"/>
+                <a16:creationId xmlns:a16="http://schemas.microsoft.com/office/drawing/2014/main" id="{BD98B735-C311-46A1-88A8-430757971C01}"/>
               </a:ext>
             </a:extLst>
           </p:cNvPr>
@@ -21050,7 +21050,7 @@
           <p:cNvPr id="22" name="c3-shape-89">
             <a:extLst xmlns:a="http://schemas.openxmlformats.org/drawingml/2006/main">
               <a:ext uri="{FF2B5EF4-FFF2-40B4-BE49-F238E27FC236}">
-                <a16:creationId xmlns:a16="http://schemas.microsoft.com/office/drawing/2014/main" id="{5903A4B4-5D1B-4B3B-B65F-7A67F9DBCA02}"/>
+                <a16:creationId xmlns:a16="http://schemas.microsoft.com/office/drawing/2014/main" id="{E85B034E-89F4-47C5-80D9-5F225FC8034E}"/>
               </a:ext>
             </a:extLst>
           </p:cNvPr>
@@ -21084,7 +21084,7 @@
           <p:cNvPr id="23" name="c3-shape-90">
             <a:extLst xmlns:a="http://schemas.openxmlformats.org/drawingml/2006/main">
               <a:ext uri="{FF2B5EF4-FFF2-40B4-BE49-F238E27FC236}">
-                <a16:creationId xmlns:a16="http://schemas.microsoft.com/office/drawing/2014/main" id="{038AEF63-5121-4166-A727-DA688E09E8D0}"/>
+                <a16:creationId xmlns:a16="http://schemas.microsoft.com/office/drawing/2014/main" id="{5E28D163-19D6-4249-AC24-E4ABF7E11B6D}"/>
               </a:ext>
             </a:extLst>
           </p:cNvPr>
@@ -21116,7 +21116,7 @@
           <p:cNvPr id="24" name="c3-text-91">
             <a:extLst xmlns:a="http://schemas.openxmlformats.org/drawingml/2006/main">
               <a:ext uri="{FF2B5EF4-FFF2-40B4-BE49-F238E27FC236}">
-                <a16:creationId xmlns:a16="http://schemas.microsoft.com/office/drawing/2014/main" id="{C8EDED7B-99C9-4CBA-BAC8-792D434B994E}"/>
+                <a16:creationId xmlns:a16="http://schemas.microsoft.com/office/drawing/2014/main" id="{43D1F3EC-A731-4AC0-A59C-253624F5F4B8}"/>
               </a:ext>
             </a:extLst>
           </p:cNvPr>
@@ -21173,7 +21173,7 @@
           <p:cNvPr id="25" name="c3-text-92">
             <a:extLst xmlns:a="http://schemas.openxmlformats.org/drawingml/2006/main">
               <a:ext uri="{FF2B5EF4-FFF2-40B4-BE49-F238E27FC236}">
-                <a16:creationId xmlns:a16="http://schemas.microsoft.com/office/drawing/2014/main" id="{ADE7CDA6-DD7A-4C52-96E9-4C184F372A6A}"/>
+                <a16:creationId xmlns:a16="http://schemas.microsoft.com/office/drawing/2014/main" id="{DF609B05-8955-452F-9EC9-13D0397332FE}"/>
               </a:ext>
             </a:extLst>
           </p:cNvPr>
@@ -21230,7 +21230,7 @@
           <p:cNvPr id="26" name="c3-shape-93">
             <a:extLst xmlns:a="http://schemas.openxmlformats.org/drawingml/2006/main">
               <a:ext uri="{FF2B5EF4-FFF2-40B4-BE49-F238E27FC236}">
-                <a16:creationId xmlns:a16="http://schemas.microsoft.com/office/drawing/2014/main" id="{81C0B004-0C36-49D3-B392-2EDA67795297}"/>
+                <a16:creationId xmlns:a16="http://schemas.microsoft.com/office/drawing/2014/main" id="{BA025E01-EEE1-452F-8A5F-D04D7C1DDA0C}"/>
               </a:ext>
             </a:extLst>
           </p:cNvPr>
@@ -21264,7 +21264,7 @@
           <p:cNvPr id="27" name="c3-text-94">
             <a:extLst xmlns:a="http://schemas.openxmlformats.org/drawingml/2006/main">
               <a:ext uri="{FF2B5EF4-FFF2-40B4-BE49-F238E27FC236}">
-                <a16:creationId xmlns:a16="http://schemas.microsoft.com/office/drawing/2014/main" id="{53520BFC-25DF-415C-B5CA-255AF5157ED0}"/>
+                <a16:creationId xmlns:a16="http://schemas.microsoft.com/office/drawing/2014/main" id="{03D4D258-91AA-4772-BA23-03E4716D8CCF}"/>
               </a:ext>
             </a:extLst>
           </p:cNvPr>
@@ -21321,7 +21321,7 @@
           <p:cNvPr id="28" name="c3-text-382">
             <a:extLst xmlns:a="http://schemas.openxmlformats.org/drawingml/2006/main">
               <a:ext uri="{FF2B5EF4-FFF2-40B4-BE49-F238E27FC236}">
-                <a16:creationId xmlns:a16="http://schemas.microsoft.com/office/drawing/2014/main" id="{DF2E54EF-E9BC-4BA4-BADF-A43F1420DA58}"/>
+                <a16:creationId xmlns:a16="http://schemas.microsoft.com/office/drawing/2014/main" id="{F4F3281E-645F-4E41-8C03-A74BB3B90492}"/>
               </a:ext>
             </a:extLst>
           </p:cNvPr>
@@ -21376,7 +21376,7 @@
     </p:spTree>
     <p:extLst>
       <p:ext uri="{BB962C8B-B14F-4D97-AF65-F5344CB8AC3E}">
-        <p14:creationId xmlns:p14="http://schemas.microsoft.com/office/powerpoint/2010/main" val="970766007"/>
+        <p14:creationId xmlns:p14="http://schemas.microsoft.com/office/powerpoint/2010/main" val="1655485483"/>
       </p:ext>
     </p:extLst>
   </p:cSld>
@@ -21407,7 +21407,7 @@
           <p:cNvPr id="15" name="c3-text-95">
             <a:extLst xmlns:a="http://schemas.openxmlformats.org/drawingml/2006/main">
               <a:ext uri="{FF2B5EF4-FFF2-40B4-BE49-F238E27FC236}">
-                <a16:creationId xmlns:a16="http://schemas.microsoft.com/office/drawing/2014/main" id="{AD96A0BB-E939-43C8-BB94-DEFEA082B3B1}"/>
+                <a16:creationId xmlns:a16="http://schemas.microsoft.com/office/drawing/2014/main" id="{E690CFA1-8EAE-4D98-AFD4-87E3366C94AF}"/>
               </a:ext>
             </a:extLst>
           </p:cNvPr>
@@ -21464,7 +21464,7 @@
           <p:cNvPr id="2" name="c3-text-96">
             <a:extLst xmlns:a="http://schemas.openxmlformats.org/drawingml/2006/main">
               <a:ext uri="{FF2B5EF4-FFF2-40B4-BE49-F238E27FC236}">
-                <a16:creationId xmlns:a16="http://schemas.microsoft.com/office/drawing/2014/main" id="{5ACA9B79-6E4E-4755-A982-D610C493BE50}"/>
+                <a16:creationId xmlns:a16="http://schemas.microsoft.com/office/drawing/2014/main" id="{CE4C0259-418F-44A2-9F80-A0F62ECC9199}"/>
               </a:ext>
             </a:extLst>
           </p:cNvPr>
@@ -21521,7 +21521,7 @@
           <p:cNvPr id="3" name="c3-text-97">
             <a:extLst xmlns:a="http://schemas.openxmlformats.org/drawingml/2006/main">
               <a:ext uri="{FF2B5EF4-FFF2-40B4-BE49-F238E27FC236}">
-                <a16:creationId xmlns:a16="http://schemas.microsoft.com/office/drawing/2014/main" id="{119890A7-DA13-4340-B32E-422906BA5062}"/>
+                <a16:creationId xmlns:a16="http://schemas.microsoft.com/office/drawing/2014/main" id="{2BEE9FF4-64FE-47EE-90DD-542C39A9C349}"/>
               </a:ext>
             </a:extLst>
           </p:cNvPr>
@@ -21578,7 +21578,7 @@
           <p:cNvPr id="4" name="c3-shape-98">
             <a:extLst xmlns:a="http://schemas.openxmlformats.org/drawingml/2006/main">
               <a:ext uri="{FF2B5EF4-FFF2-40B4-BE49-F238E27FC236}">
-                <a16:creationId xmlns:a16="http://schemas.microsoft.com/office/drawing/2014/main" id="{34F03AE5-F870-4D4B-B820-B0949C6DC10A}"/>
+                <a16:creationId xmlns:a16="http://schemas.microsoft.com/office/drawing/2014/main" id="{87748A52-DAAC-46A0-A559-FD3FB8A8E5B2}"/>
               </a:ext>
             </a:extLst>
           </p:cNvPr>
@@ -21612,7 +21612,7 @@
           <p:cNvPr id="5" name="c3-shape-99">
             <a:extLst xmlns:a="http://schemas.openxmlformats.org/drawingml/2006/main">
               <a:ext uri="{FF2B5EF4-FFF2-40B4-BE49-F238E27FC236}">
-                <a16:creationId xmlns:a16="http://schemas.microsoft.com/office/drawing/2014/main" id="{6EEC8A0C-5861-4F66-91C5-B64D644A5A53}"/>
+                <a16:creationId xmlns:a16="http://schemas.microsoft.com/office/drawing/2014/main" id="{399D13B6-48EE-42A4-9577-9741479C06DA}"/>
               </a:ext>
             </a:extLst>
           </p:cNvPr>
@@ -21644,7 +21644,7 @@
           <p:cNvPr id="6" name="c3-text-100">
             <a:extLst xmlns:a="http://schemas.openxmlformats.org/drawingml/2006/main">
               <a:ext uri="{FF2B5EF4-FFF2-40B4-BE49-F238E27FC236}">
-                <a16:creationId xmlns:a16="http://schemas.microsoft.com/office/drawing/2014/main" id="{F081970A-0013-40A7-8F67-25C0F064329E}"/>
+                <a16:creationId xmlns:a16="http://schemas.microsoft.com/office/drawing/2014/main" id="{D890A32F-7C34-4C62-A920-59C81C7EA814}"/>
               </a:ext>
             </a:extLst>
           </p:cNvPr>
@@ -21701,7 +21701,7 @@
           <p:cNvPr id="7" name="c3-text-101">
             <a:extLst xmlns:a="http://schemas.openxmlformats.org/drawingml/2006/main">
               <a:ext uri="{FF2B5EF4-FFF2-40B4-BE49-F238E27FC236}">
-                <a16:creationId xmlns:a16="http://schemas.microsoft.com/office/drawing/2014/main" id="{B7259C5A-0B51-4FE0-B0F7-1519020E8337}"/>
+                <a16:creationId xmlns:a16="http://schemas.microsoft.com/office/drawing/2014/main" id="{B73EFF2C-56F2-4CEE-8E5F-404E816EB634}"/>
               </a:ext>
             </a:extLst>
           </p:cNvPr>
@@ -21827,7 +21827,7 @@
           <p:cNvPr id="8" name="c3-shape-102">
             <a:extLst xmlns:a="http://schemas.openxmlformats.org/drawingml/2006/main">
               <a:ext uri="{FF2B5EF4-FFF2-40B4-BE49-F238E27FC236}">
-                <a16:creationId xmlns:a16="http://schemas.microsoft.com/office/drawing/2014/main" id="{8C3B55FC-2D4C-4642-9313-31561D5111AC}"/>
+                <a16:creationId xmlns:a16="http://schemas.microsoft.com/office/drawing/2014/main" id="{C9B32F97-2CEF-46E3-A5C5-2840CC491EB2}"/>
               </a:ext>
             </a:extLst>
           </p:cNvPr>
@@ -21861,7 +21861,7 @@
           <p:cNvPr id="9" name="c3-shape-103">
             <a:extLst xmlns:a="http://schemas.openxmlformats.org/drawingml/2006/main">
               <a:ext uri="{FF2B5EF4-FFF2-40B4-BE49-F238E27FC236}">
-                <a16:creationId xmlns:a16="http://schemas.microsoft.com/office/drawing/2014/main" id="{9C7323AD-CD66-40A4-890E-12686987A034}"/>
+                <a16:creationId xmlns:a16="http://schemas.microsoft.com/office/drawing/2014/main" id="{1BE39DD2-EBAD-4B29-848E-B548F3A11517}"/>
               </a:ext>
             </a:extLst>
           </p:cNvPr>
@@ -21893,7 +21893,7 @@
           <p:cNvPr id="10" name="c3-text-104">
             <a:extLst xmlns:a="http://schemas.openxmlformats.org/drawingml/2006/main">
               <a:ext uri="{FF2B5EF4-FFF2-40B4-BE49-F238E27FC236}">
-                <a16:creationId xmlns:a16="http://schemas.microsoft.com/office/drawing/2014/main" id="{4028273F-2F06-4A71-BF70-9846DEB18425}"/>
+                <a16:creationId xmlns:a16="http://schemas.microsoft.com/office/drawing/2014/main" id="{79869CB3-6774-490A-874B-68852F5D0F1E}"/>
               </a:ext>
             </a:extLst>
           </p:cNvPr>
@@ -21950,7 +21950,7 @@
           <p:cNvPr id="11" name="c3-text-105">
             <a:extLst xmlns:a="http://schemas.openxmlformats.org/drawingml/2006/main">
               <a:ext uri="{FF2B5EF4-FFF2-40B4-BE49-F238E27FC236}">
-                <a16:creationId xmlns:a16="http://schemas.microsoft.com/office/drawing/2014/main" id="{160C7237-BB1E-4428-ADBE-3054B113580E}"/>
+                <a16:creationId xmlns:a16="http://schemas.microsoft.com/office/drawing/2014/main" id="{D45BE634-8AD5-47C5-9AA4-B74D4E2992C8}"/>
               </a:ext>
             </a:extLst>
           </p:cNvPr>
@@ -22053,7 +22053,7 @@
           <p:cNvPr id="12" name="c3-shape-106">
             <a:extLst xmlns:a="http://schemas.openxmlformats.org/drawingml/2006/main">
               <a:ext uri="{FF2B5EF4-FFF2-40B4-BE49-F238E27FC236}">
-                <a16:creationId xmlns:a16="http://schemas.microsoft.com/office/drawing/2014/main" id="{83EA9614-6F66-4A0B-9301-F9A3F3C9FC1F}"/>
+                <a16:creationId xmlns:a16="http://schemas.microsoft.com/office/drawing/2014/main" id="{7A3B2150-5E2C-48E7-AA88-F18257AC5BF5}"/>
               </a:ext>
             </a:extLst>
           </p:cNvPr>
@@ -22087,7 +22087,7 @@
           <p:cNvPr id="13" name="c3-text-107">
             <a:extLst xmlns:a="http://schemas.openxmlformats.org/drawingml/2006/main">
               <a:ext uri="{FF2B5EF4-FFF2-40B4-BE49-F238E27FC236}">
-                <a16:creationId xmlns:a16="http://schemas.microsoft.com/office/drawing/2014/main" id="{9DC23B6F-F206-4906-99C3-26DF2C671E44}"/>
+                <a16:creationId xmlns:a16="http://schemas.microsoft.com/office/drawing/2014/main" id="{F1B9F47E-EE4A-4981-8BD5-9B177E3691FC}"/>
               </a:ext>
             </a:extLst>
           </p:cNvPr>
@@ -22144,7 +22144,7 @@
           <p:cNvPr id="14" name="c3-text-383">
             <a:extLst xmlns:a="http://schemas.openxmlformats.org/drawingml/2006/main">
               <a:ext uri="{FF2B5EF4-FFF2-40B4-BE49-F238E27FC236}">
-                <a16:creationId xmlns:a16="http://schemas.microsoft.com/office/drawing/2014/main" id="{0CC3ECCB-A9AB-4C9D-B18A-21DBBF113C37}"/>
+                <a16:creationId xmlns:a16="http://schemas.microsoft.com/office/drawing/2014/main" id="{8EDB8A94-BE83-4FE2-959D-A91F67303B60}"/>
               </a:ext>
             </a:extLst>
           </p:cNvPr>
@@ -22199,7 +22199,7 @@
     </p:spTree>
     <p:extLst>
       <p:ext uri="{BB962C8B-B14F-4D97-AF65-F5344CB8AC3E}">
-        <p14:creationId xmlns:p14="http://schemas.microsoft.com/office/powerpoint/2010/main" val="718711468"/>
+        <p14:creationId xmlns:p14="http://schemas.microsoft.com/office/powerpoint/2010/main" val="1337289851"/>
       </p:ext>
     </p:extLst>
   </p:cSld>
@@ -22230,7 +22230,7 @@
           <p:cNvPr id="15" name="c3-text-108">
             <a:extLst xmlns:a="http://schemas.openxmlformats.org/drawingml/2006/main">
               <a:ext uri="{FF2B5EF4-FFF2-40B4-BE49-F238E27FC236}">
-                <a16:creationId xmlns:a16="http://schemas.microsoft.com/office/drawing/2014/main" id="{E13358C6-0221-4362-941F-AD8E79B6D052}"/>
+                <a16:creationId xmlns:a16="http://schemas.microsoft.com/office/drawing/2014/main" id="{D4F915EC-D44A-4FEF-9A28-A3A4D54C62C0}"/>
               </a:ext>
             </a:extLst>
           </p:cNvPr>
@@ -22287,7 +22287,7 @@
           <p:cNvPr id="2" name="c3-text-109">
             <a:extLst xmlns:a="http://schemas.openxmlformats.org/drawingml/2006/main">
               <a:ext uri="{FF2B5EF4-FFF2-40B4-BE49-F238E27FC236}">
-                <a16:creationId xmlns:a16="http://schemas.microsoft.com/office/drawing/2014/main" id="{4108A812-1E39-43DC-9252-A095618F4997}"/>
+                <a16:creationId xmlns:a16="http://schemas.microsoft.com/office/drawing/2014/main" id="{D418E8F3-D2E0-4CFF-A001-6E1580F6E53C}"/>
               </a:ext>
             </a:extLst>
           </p:cNvPr>
@@ -22344,7 +22344,7 @@
           <p:cNvPr id="3" name="c3-text-110">
             <a:extLst xmlns:a="http://schemas.openxmlformats.org/drawingml/2006/main">
               <a:ext uri="{FF2B5EF4-FFF2-40B4-BE49-F238E27FC236}">
-                <a16:creationId xmlns:a16="http://schemas.microsoft.com/office/drawing/2014/main" id="{7C159B40-38C1-4F27-8B7A-70A8FAB0CD7D}"/>
+                <a16:creationId xmlns:a16="http://schemas.microsoft.com/office/drawing/2014/main" id="{4FFF4C5A-146C-447B-9316-3C0B48A5F58E}"/>
               </a:ext>
             </a:extLst>
           </p:cNvPr>
@@ -22401,7 +22401,7 @@
           <p:cNvPr id="4" name="c3-shape-111">
             <a:extLst xmlns:a="http://schemas.openxmlformats.org/drawingml/2006/main">
               <a:ext uri="{FF2B5EF4-FFF2-40B4-BE49-F238E27FC236}">
-                <a16:creationId xmlns:a16="http://schemas.microsoft.com/office/drawing/2014/main" id="{92D5BCAC-5A7B-41A1-9530-B56E8AF9BD7C}"/>
+                <a16:creationId xmlns:a16="http://schemas.microsoft.com/office/drawing/2014/main" id="{2D1227BC-F6AF-4DEC-8E0F-0517E61D29EB}"/>
               </a:ext>
             </a:extLst>
           </p:cNvPr>
@@ -22435,7 +22435,7 @@
           <p:cNvPr id="5" name="c3-shape-112">
             <a:extLst xmlns:a="http://schemas.openxmlformats.org/drawingml/2006/main">
               <a:ext uri="{FF2B5EF4-FFF2-40B4-BE49-F238E27FC236}">
-                <a16:creationId xmlns:a16="http://schemas.microsoft.com/office/drawing/2014/main" id="{513A7FB8-83FC-435C-BEB4-BF995C90CF14}"/>
+                <a16:creationId xmlns:a16="http://schemas.microsoft.com/office/drawing/2014/main" id="{4281BDB5-8507-4DC2-9072-CAA0B48C01C6}"/>
               </a:ext>
             </a:extLst>
           </p:cNvPr>
@@ -22467,7 +22467,7 @@
           <p:cNvPr id="6" name="c3-text-113">
             <a:extLst xmlns:a="http://schemas.openxmlformats.org/drawingml/2006/main">
               <a:ext uri="{FF2B5EF4-FFF2-40B4-BE49-F238E27FC236}">
-                <a16:creationId xmlns:a16="http://schemas.microsoft.com/office/drawing/2014/main" id="{207C724F-ABE7-4926-9D54-C18855805DE6}"/>
+                <a16:creationId xmlns:a16="http://schemas.microsoft.com/office/drawing/2014/main" id="{7A2F991A-038E-4ADF-83F9-BEF192BFC09D}"/>
               </a:ext>
             </a:extLst>
           </p:cNvPr>
@@ -22524,7 +22524,7 @@
           <p:cNvPr id="7" name="c3-text-114">
             <a:extLst xmlns:a="http://schemas.openxmlformats.org/drawingml/2006/main">
               <a:ext uri="{FF2B5EF4-FFF2-40B4-BE49-F238E27FC236}">
-                <a16:creationId xmlns:a16="http://schemas.microsoft.com/office/drawing/2014/main" id="{3C1F6DB6-6699-419D-8186-75FB25D6FC07}"/>
+                <a16:creationId xmlns:a16="http://schemas.microsoft.com/office/drawing/2014/main" id="{AED96D3A-CC5B-4254-8652-098D005166EE}"/>
               </a:ext>
             </a:extLst>
           </p:cNvPr>
@@ -22604,7 +22604,7 @@
           <p:cNvPr id="8" name="c3-shape-115">
             <a:extLst xmlns:a="http://schemas.openxmlformats.org/drawingml/2006/main">
               <a:ext uri="{FF2B5EF4-FFF2-40B4-BE49-F238E27FC236}">
-                <a16:creationId xmlns:a16="http://schemas.microsoft.com/office/drawing/2014/main" id="{E0C984F2-5101-4C21-A8AE-967068F2E9CB}"/>
+                <a16:creationId xmlns:a16="http://schemas.microsoft.com/office/drawing/2014/main" id="{D19FEF36-EEF6-470E-B884-36EF81BAB861}"/>
               </a:ext>
             </a:extLst>
           </p:cNvPr>
@@ -22638,7 +22638,7 @@
           <p:cNvPr id="9" name="c3-shape-116">
             <a:extLst xmlns:a="http://schemas.openxmlformats.org/drawingml/2006/main">
               <a:ext uri="{FF2B5EF4-FFF2-40B4-BE49-F238E27FC236}">
-                <a16:creationId xmlns:a16="http://schemas.microsoft.com/office/drawing/2014/main" id="{658397F1-BBC3-42A2-8ADF-B33D6ABB7AB7}"/>
+                <a16:creationId xmlns:a16="http://schemas.microsoft.com/office/drawing/2014/main" id="{2067D872-5ACE-47D3-B7E5-8474E15A2DE4}"/>
               </a:ext>
             </a:extLst>
           </p:cNvPr>
@@ -22670,7 +22670,7 @@
           <p:cNvPr id="10" name="c3-text-117">
             <a:extLst xmlns:a="http://schemas.openxmlformats.org/drawingml/2006/main">
               <a:ext uri="{FF2B5EF4-FFF2-40B4-BE49-F238E27FC236}">
-                <a16:creationId xmlns:a16="http://schemas.microsoft.com/office/drawing/2014/main" id="{BEF9F875-BC12-44E6-AD86-C8F451E239CF}"/>
+                <a16:creationId xmlns:a16="http://schemas.microsoft.com/office/drawing/2014/main" id="{6DE2A618-422C-4901-A81A-4960093F503F}"/>
               </a:ext>
             </a:extLst>
           </p:cNvPr>
@@ -22727,7 +22727,7 @@
           <p:cNvPr id="11" name="c3-text-118">
             <a:extLst xmlns:a="http://schemas.openxmlformats.org/drawingml/2006/main">
               <a:ext uri="{FF2B5EF4-FFF2-40B4-BE49-F238E27FC236}">
-                <a16:creationId xmlns:a16="http://schemas.microsoft.com/office/drawing/2014/main" id="{E70B1065-FA50-46F5-91D3-FC2DB3644360}"/>
+                <a16:creationId xmlns:a16="http://schemas.microsoft.com/office/drawing/2014/main" id="{144DF518-5E20-4A5A-8FE3-14377ACEBF60}"/>
               </a:ext>
             </a:extLst>
           </p:cNvPr>
@@ -22807,7 +22807,7 @@
           <p:cNvPr id="12" name="c3-shape-119">
             <a:extLst xmlns:a="http://schemas.openxmlformats.org/drawingml/2006/main">
               <a:ext uri="{FF2B5EF4-FFF2-40B4-BE49-F238E27FC236}">
-                <a16:creationId xmlns:a16="http://schemas.microsoft.com/office/drawing/2014/main" id="{774F9A3D-D2C4-4634-8367-79249BB353C4}"/>
+                <a16:creationId xmlns:a16="http://schemas.microsoft.com/office/drawing/2014/main" id="{6FE04B03-C454-48EA-AF72-3F9897F9BE6A}"/>
               </a:ext>
             </a:extLst>
           </p:cNvPr>
@@ -22841,7 +22841,7 @@
           <p:cNvPr id="13" name="c3-text-120">
             <a:extLst xmlns:a="http://schemas.openxmlformats.org/drawingml/2006/main">
               <a:ext uri="{FF2B5EF4-FFF2-40B4-BE49-F238E27FC236}">
-                <a16:creationId xmlns:a16="http://schemas.microsoft.com/office/drawing/2014/main" id="{3B300DFE-421C-4687-8B55-696F80499869}"/>
+                <a16:creationId xmlns:a16="http://schemas.microsoft.com/office/drawing/2014/main" id="{C7DC0BD3-45C5-4C71-8BC0-9C181D88818D}"/>
               </a:ext>
             </a:extLst>
           </p:cNvPr>
@@ -22898,7 +22898,7 @@
           <p:cNvPr id="14" name="c3-text-384">
             <a:extLst xmlns:a="http://schemas.openxmlformats.org/drawingml/2006/main">
               <a:ext uri="{FF2B5EF4-FFF2-40B4-BE49-F238E27FC236}">
-                <a16:creationId xmlns:a16="http://schemas.microsoft.com/office/drawing/2014/main" id="{24448BE5-EC95-475A-9757-8FC22B707CD5}"/>
+                <a16:creationId xmlns:a16="http://schemas.microsoft.com/office/drawing/2014/main" id="{DA8B19B9-FCF6-4D0B-A90D-0790BDF971BF}"/>
               </a:ext>
             </a:extLst>
           </p:cNvPr>
@@ -22953,7 +22953,7 @@
     </p:spTree>
     <p:extLst>
       <p:ext uri="{BB962C8B-B14F-4D97-AF65-F5344CB8AC3E}">
-        <p14:creationId xmlns:p14="http://schemas.microsoft.com/office/powerpoint/2010/main" val="140228918"/>
+        <p14:creationId xmlns:p14="http://schemas.microsoft.com/office/powerpoint/2010/main" val="674297866"/>
       </p:ext>
     </p:extLst>
   </p:cSld>
@@ -22984,7 +22984,7 @@
           <p:cNvPr id="15" name="c3-text-121">
             <a:extLst xmlns:a="http://schemas.openxmlformats.org/drawingml/2006/main">
               <a:ext uri="{FF2B5EF4-FFF2-40B4-BE49-F238E27FC236}">
-                <a16:creationId xmlns:a16="http://schemas.microsoft.com/office/drawing/2014/main" id="{DCA3ED41-91D0-49AA-9782-60A47602AAED}"/>
+                <a16:creationId xmlns:a16="http://schemas.microsoft.com/office/drawing/2014/main" id="{6B592062-5D48-4B81-AD57-D72B06B82B33}"/>
               </a:ext>
             </a:extLst>
           </p:cNvPr>
@@ -23041,7 +23041,7 @@
           <p:cNvPr id="2" name="c3-text-122">
             <a:extLst xmlns:a="http://schemas.openxmlformats.org/drawingml/2006/main">
               <a:ext uri="{FF2B5EF4-FFF2-40B4-BE49-F238E27FC236}">
-                <a16:creationId xmlns:a16="http://schemas.microsoft.com/office/drawing/2014/main" id="{67F09A6D-A86F-4B3E-B925-3E667C6D523A}"/>
+                <a16:creationId xmlns:a16="http://schemas.microsoft.com/office/drawing/2014/main" id="{59CF0736-8ECC-4C3F-97AF-6740D302A276}"/>
               </a:ext>
             </a:extLst>
           </p:cNvPr>
@@ -23098,7 +23098,7 @@
           <p:cNvPr id="3" name="c3-text-123">
             <a:extLst xmlns:a="http://schemas.openxmlformats.org/drawingml/2006/main">
               <a:ext uri="{FF2B5EF4-FFF2-40B4-BE49-F238E27FC236}">
-                <a16:creationId xmlns:a16="http://schemas.microsoft.com/office/drawing/2014/main" id="{EEE3AB30-5305-49EB-93F7-8DD6DE346AC2}"/>
+                <a16:creationId xmlns:a16="http://schemas.microsoft.com/office/drawing/2014/main" id="{C5B12CBB-D435-457B-9329-B48F614F4F5D}"/>
               </a:ext>
             </a:extLst>
           </p:cNvPr>
@@ -23155,7 +23155,7 @@
           <p:cNvPr id="4" name="c3-shape-124">
             <a:extLst xmlns:a="http://schemas.openxmlformats.org/drawingml/2006/main">
               <a:ext uri="{FF2B5EF4-FFF2-40B4-BE49-F238E27FC236}">
-                <a16:creationId xmlns:a16="http://schemas.microsoft.com/office/drawing/2014/main" id="{0A1026CB-6F04-4DE8-B190-FB917058D2FF}"/>
+                <a16:creationId xmlns:a16="http://schemas.microsoft.com/office/drawing/2014/main" id="{A1789C9E-CD9B-419C-A0CA-16A043C117C4}"/>
               </a:ext>
             </a:extLst>
           </p:cNvPr>
@@ -23189,7 +23189,7 @@
           <p:cNvPr id="5" name="c3-shape-125">
             <a:extLst xmlns:a="http://schemas.openxmlformats.org/drawingml/2006/main">
               <a:ext uri="{FF2B5EF4-FFF2-40B4-BE49-F238E27FC236}">
-                <a16:creationId xmlns:a16="http://schemas.microsoft.com/office/drawing/2014/main" id="{B03BE896-B7DE-4D33-928F-4E91F13C807B}"/>
+                <a16:creationId xmlns:a16="http://schemas.microsoft.com/office/drawing/2014/main" id="{8C457D88-F967-489B-A32D-77F3DE24BCE6}"/>
               </a:ext>
             </a:extLst>
           </p:cNvPr>
@@ -23221,7 +23221,7 @@
           <p:cNvPr id="6" name="c3-text-126">
             <a:extLst xmlns:a="http://schemas.openxmlformats.org/drawingml/2006/main">
               <a:ext uri="{FF2B5EF4-FFF2-40B4-BE49-F238E27FC236}">
-                <a16:creationId xmlns:a16="http://schemas.microsoft.com/office/drawing/2014/main" id="{8654C0FF-592F-407F-A86E-65DCB97BFEEB}"/>
+                <a16:creationId xmlns:a16="http://schemas.microsoft.com/office/drawing/2014/main" id="{8C9DA5CE-0E25-4183-838C-1C5524A884D2}"/>
               </a:ext>
             </a:extLst>
           </p:cNvPr>
@@ -23278,7 +23278,7 @@
           <p:cNvPr id="7" name="c3-text-127">
             <a:extLst xmlns:a="http://schemas.openxmlformats.org/drawingml/2006/main">
               <a:ext uri="{FF2B5EF4-FFF2-40B4-BE49-F238E27FC236}">
-                <a16:creationId xmlns:a16="http://schemas.microsoft.com/office/drawing/2014/main" id="{C55FDBE3-0DAE-4D27-9E8C-565271542722}"/>
+                <a16:creationId xmlns:a16="http://schemas.microsoft.com/office/drawing/2014/main" id="{5B006A09-4A36-468C-BCFA-C165C8438121}"/>
               </a:ext>
             </a:extLst>
           </p:cNvPr>
@@ -23335,7 +23335,7 @@
           <p:cNvPr id="8" name="c3-shape-128">
             <a:extLst xmlns:a="http://schemas.openxmlformats.org/drawingml/2006/main">
               <a:ext uri="{FF2B5EF4-FFF2-40B4-BE49-F238E27FC236}">
-                <a16:creationId xmlns:a16="http://schemas.microsoft.com/office/drawing/2014/main" id="{23B8FB0F-21BB-4509-8E10-C7D2CEB13E6B}"/>
+                <a16:creationId xmlns:a16="http://schemas.microsoft.com/office/drawing/2014/main" id="{E53072B9-3AAA-409D-BB54-47C741AAFE52}"/>
               </a:ext>
             </a:extLst>
           </p:cNvPr>
@@ -23369,7 +23369,7 @@
           <p:cNvPr id="9" name="c3-shape-129">
             <a:extLst xmlns:a="http://schemas.openxmlformats.org/drawingml/2006/main">
               <a:ext uri="{FF2B5EF4-FFF2-40B4-BE49-F238E27FC236}">
-                <a16:creationId xmlns:a16="http://schemas.microsoft.com/office/drawing/2014/main" id="{DDB9E3BB-42BF-4DA6-8D25-41142E5B1F4F}"/>
+                <a16:creationId xmlns:a16="http://schemas.microsoft.com/office/drawing/2014/main" id="{B0269EF1-426B-4E53-ACE6-CB737DEA975B}"/>
               </a:ext>
             </a:extLst>
           </p:cNvPr>
@@ -23401,7 +23401,7 @@
           <p:cNvPr id="10" name="c3-text-130">
             <a:extLst xmlns:a="http://schemas.openxmlformats.org/drawingml/2006/main">
               <a:ext uri="{FF2B5EF4-FFF2-40B4-BE49-F238E27FC236}">
-                <a16:creationId xmlns:a16="http://schemas.microsoft.com/office/drawing/2014/main" id="{7DEF14BE-7E0B-4E6E-8662-165B85D6CC15}"/>
+                <a16:creationId xmlns:a16="http://schemas.microsoft.com/office/drawing/2014/main" id="{EF9AE5C6-68B9-4347-A7EF-8F5C7B11B5C8}"/>
               </a:ext>
             </a:extLst>
           </p:cNvPr>
@@ -23458,7 +23458,7 @@
           <p:cNvPr id="11" name="c3-text-131">
             <a:extLst xmlns:a="http://schemas.openxmlformats.org/drawingml/2006/main">
               <a:ext uri="{FF2B5EF4-FFF2-40B4-BE49-F238E27FC236}">
-                <a16:creationId xmlns:a16="http://schemas.microsoft.com/office/drawing/2014/main" id="{7FD6C869-CD95-459A-B1E3-735FC14C2AB8}"/>
+                <a16:creationId xmlns:a16="http://schemas.microsoft.com/office/drawing/2014/main" id="{2D7C5E32-F383-483A-92D3-A0FBAFED03CF}"/>
               </a:ext>
             </a:extLst>
           </p:cNvPr>
@@ -23515,7 +23515,7 @@
           <p:cNvPr id="12" name="c3-shape-132">
             <a:extLst xmlns:a="http://schemas.openxmlformats.org/drawingml/2006/main">
               <a:ext uri="{FF2B5EF4-FFF2-40B4-BE49-F238E27FC236}">
-                <a16:creationId xmlns:a16="http://schemas.microsoft.com/office/drawing/2014/main" id="{CFF0C320-46F4-431C-8F1C-9E97291AA68E}"/>
+                <a16:creationId xmlns:a16="http://schemas.microsoft.com/office/drawing/2014/main" id="{759FA36E-B093-4C20-88CD-D45BBA7B44C9}"/>
               </a:ext>
             </a:extLst>
           </p:cNvPr>
@@ -23549,7 +23549,7 @@
           <p:cNvPr id="13" name="c3-text-133">
             <a:extLst xmlns:a="http://schemas.openxmlformats.org/drawingml/2006/main">
               <a:ext uri="{FF2B5EF4-FFF2-40B4-BE49-F238E27FC236}">
-                <a16:creationId xmlns:a16="http://schemas.microsoft.com/office/drawing/2014/main" id="{57744532-15D9-4221-9F76-E7B7D7B5036D}"/>
+                <a16:creationId xmlns:a16="http://schemas.microsoft.com/office/drawing/2014/main" id="{F1A5C1D7-F0BB-49C1-B0AE-A89F29D141D3}"/>
               </a:ext>
             </a:extLst>
           </p:cNvPr>
@@ -23606,7 +23606,7 @@
           <p:cNvPr id="14" name="c3-text-385">
             <a:extLst xmlns:a="http://schemas.openxmlformats.org/drawingml/2006/main">
               <a:ext uri="{FF2B5EF4-FFF2-40B4-BE49-F238E27FC236}">
-                <a16:creationId xmlns:a16="http://schemas.microsoft.com/office/drawing/2014/main" id="{AA0477D5-EDBE-4870-B1C7-B61C7FF37FD8}"/>
+                <a16:creationId xmlns:a16="http://schemas.microsoft.com/office/drawing/2014/main" id="{6468E335-B3B5-4D4A-9252-FEE45A629E36}"/>
               </a:ext>
             </a:extLst>
           </p:cNvPr>
@@ -23661,7 +23661,7 @@
     </p:spTree>
     <p:extLst>
       <p:ext uri="{BB962C8B-B14F-4D97-AF65-F5344CB8AC3E}">
-        <p14:creationId xmlns:p14="http://schemas.microsoft.com/office/powerpoint/2010/main" val="1709829517"/>
+        <p14:creationId xmlns:p14="http://schemas.microsoft.com/office/powerpoint/2010/main" val="2056633657"/>
       </p:ext>
     </p:extLst>
   </p:cSld>
@@ -23692,7 +23692,7 @@
           <p:cNvPr id="23" name="c3-text-134">
             <a:extLst xmlns:a="http://schemas.openxmlformats.org/drawingml/2006/main">
               <a:ext uri="{FF2B5EF4-FFF2-40B4-BE49-F238E27FC236}">
-                <a16:creationId xmlns:a16="http://schemas.microsoft.com/office/drawing/2014/main" id="{8823284D-D890-453B-B268-5D5E33695ED6}"/>
+                <a16:creationId xmlns:a16="http://schemas.microsoft.com/office/drawing/2014/main" id="{99C28683-7E2A-49C8-9841-2E9B80D612A0}"/>
               </a:ext>
             </a:extLst>
           </p:cNvPr>
@@ -23749,7 +23749,7 @@
           <p:cNvPr id="2" name="c3-text-135">
             <a:extLst xmlns:a="http://schemas.openxmlformats.org/drawingml/2006/main">
               <a:ext uri="{FF2B5EF4-FFF2-40B4-BE49-F238E27FC236}">
-                <a16:creationId xmlns:a16="http://schemas.microsoft.com/office/drawing/2014/main" id="{26DBD917-7B06-4B5A-ACCC-D6583D49B331}"/>
+                <a16:creationId xmlns:a16="http://schemas.microsoft.com/office/drawing/2014/main" id="{59E98DE6-4676-4EC3-BA24-908D0FC0F96B}"/>
               </a:ext>
             </a:extLst>
           </p:cNvPr>
@@ -23806,7 +23806,7 @@
           <p:cNvPr id="3" name="c3-text-136">
             <a:extLst xmlns:a="http://schemas.openxmlformats.org/drawingml/2006/main">
               <a:ext uri="{FF2B5EF4-FFF2-40B4-BE49-F238E27FC236}">
-                <a16:creationId xmlns:a16="http://schemas.microsoft.com/office/drawing/2014/main" id="{A6681DFD-91F7-4585-BAB1-F360BEB73D8E}"/>
+                <a16:creationId xmlns:a16="http://schemas.microsoft.com/office/drawing/2014/main" id="{6DFB716B-6CF8-4B7B-BAF1-86E7B1DCF166}"/>
               </a:ext>
             </a:extLst>
           </p:cNvPr>
@@ -23863,7 +23863,7 @@
           <p:cNvPr id="4" name="c3-shape-137">
             <a:extLst xmlns:a="http://schemas.openxmlformats.org/drawingml/2006/main">
               <a:ext uri="{FF2B5EF4-FFF2-40B4-BE49-F238E27FC236}">
-                <a16:creationId xmlns:a16="http://schemas.microsoft.com/office/drawing/2014/main" id="{3952DF56-AC2C-4790-828B-09CD782AB644}"/>
+                <a16:creationId xmlns:a16="http://schemas.microsoft.com/office/drawing/2014/main" id="{9A05F890-993F-44F8-8D86-FB5571E98117}"/>
               </a:ext>
             </a:extLst>
           </p:cNvPr>
@@ -23897,7 +23897,7 @@
           <p:cNvPr id="5" name="c3-text-138">
             <a:extLst xmlns:a="http://schemas.openxmlformats.org/drawingml/2006/main">
               <a:ext uri="{FF2B5EF4-FFF2-40B4-BE49-F238E27FC236}">
-                <a16:creationId xmlns:a16="http://schemas.microsoft.com/office/drawing/2014/main" id="{2C5C83A2-F5AD-4F68-BF13-346D67B092B8}"/>
+                <a16:creationId xmlns:a16="http://schemas.microsoft.com/office/drawing/2014/main" id="{4795C030-29CA-4532-A6A4-AF85D4F66DDB}"/>
               </a:ext>
             </a:extLst>
           </p:cNvPr>
@@ -23954,7 +23954,7 @@
           <p:cNvPr id="6" name="c3-shape-139">
             <a:extLst xmlns:a="http://schemas.openxmlformats.org/drawingml/2006/main">
               <a:ext uri="{FF2B5EF4-FFF2-40B4-BE49-F238E27FC236}">
-                <a16:creationId xmlns:a16="http://schemas.microsoft.com/office/drawing/2014/main" id="{DF54794D-5807-4699-8DE5-9DA610490E6E}"/>
+                <a16:creationId xmlns:a16="http://schemas.microsoft.com/office/drawing/2014/main" id="{8480244E-B863-45E5-8132-44D669B1BE65}"/>
               </a:ext>
             </a:extLst>
           </p:cNvPr>
@@ -23986,7 +23986,7 @@
           <p:cNvPr id="7" name="c3-shape-140">
             <a:extLst xmlns:a="http://schemas.openxmlformats.org/drawingml/2006/main">
               <a:ext uri="{FF2B5EF4-FFF2-40B4-BE49-F238E27FC236}">
-                <a16:creationId xmlns:a16="http://schemas.microsoft.com/office/drawing/2014/main" id="{141DE22A-96BC-43BB-96A2-E91DEE65CDEE}"/>
+                <a16:creationId xmlns:a16="http://schemas.microsoft.com/office/drawing/2014/main" id="{2A5FD251-A314-4E44-95EE-1D1A230AB6B7}"/>
               </a:ext>
             </a:extLst>
           </p:cNvPr>
@@ -24020,7 +24020,7 @@
           <p:cNvPr id="8" name="c3-text-141">
             <a:extLst xmlns:a="http://schemas.openxmlformats.org/drawingml/2006/main">
               <a:ext uri="{FF2B5EF4-FFF2-40B4-BE49-F238E27FC236}">
-                <a16:creationId xmlns:a16="http://schemas.microsoft.com/office/drawing/2014/main" id="{CC4965E9-7A20-4C67-9A3A-652D723C2018}"/>
+                <a16:creationId xmlns:a16="http://schemas.microsoft.com/office/drawing/2014/main" id="{99CC2847-E3F6-4541-9063-4CFB7578082F}"/>
               </a:ext>
             </a:extLst>
           </p:cNvPr>
@@ -24077,7 +24077,7 @@
           <p:cNvPr id="9" name="c3-text-142">
             <a:extLst xmlns:a="http://schemas.openxmlformats.org/drawingml/2006/main">
               <a:ext uri="{FF2B5EF4-FFF2-40B4-BE49-F238E27FC236}">
-                <a16:creationId xmlns:a16="http://schemas.microsoft.com/office/drawing/2014/main" id="{AC9E8E4C-9668-4F4C-9BE2-C95B183EB028}"/>
+                <a16:creationId xmlns:a16="http://schemas.microsoft.com/office/drawing/2014/main" id="{C6D6CB9A-371C-467B-AC9D-395A5A1452EF}"/>
               </a:ext>
             </a:extLst>
           </p:cNvPr>
@@ -24134,7 +24134,7 @@
           <p:cNvPr id="10" name="c3-shape-143">
             <a:extLst xmlns:a="http://schemas.openxmlformats.org/drawingml/2006/main">
               <a:ext uri="{FF2B5EF4-FFF2-40B4-BE49-F238E27FC236}">
-                <a16:creationId xmlns:a16="http://schemas.microsoft.com/office/drawing/2014/main" id="{A1BB7F0B-DEFD-458E-8FB7-829F2B005183}"/>
+                <a16:creationId xmlns:a16="http://schemas.microsoft.com/office/drawing/2014/main" id="{31289857-244F-474D-B628-2403952716BF}"/>
               </a:ext>
             </a:extLst>
           </p:cNvPr>
@@ -24168,7 +24168,7 @@
           <p:cNvPr id="11" name="c3-shape-144">
             <a:extLst xmlns:a="http://schemas.openxmlformats.org/drawingml/2006/main">
               <a:ext uri="{FF2B5EF4-FFF2-40B4-BE49-F238E27FC236}">
-                <a16:creationId xmlns:a16="http://schemas.microsoft.com/office/drawing/2014/main" id="{16240B47-7F8C-4FC5-916F-30E92AA67AE9}"/>
+                <a16:creationId xmlns:a16="http://schemas.microsoft.com/office/drawing/2014/main" id="{CDA5FC10-7DB5-44C9-9E1D-801AA7F47B3F}"/>
               </a:ext>
             </a:extLst>
           </p:cNvPr>
@@ -24200,7 +24200,7 @@
           <p:cNvPr id="12" name="c3-text-145">
             <a:extLst xmlns:a="http://schemas.openxmlformats.org/drawingml/2006/main">
               <a:ext uri="{FF2B5EF4-FFF2-40B4-BE49-F238E27FC236}">
-                <a16:creationId xmlns:a16="http://schemas.microsoft.com/office/drawing/2014/main" id="{260BE95A-369C-4F4B-8BC7-150DA7ABB65C}"/>
+                <a16:creationId xmlns:a16="http://schemas.microsoft.com/office/drawing/2014/main" id="{5BAEADE1-B830-4298-882E-3DB5557C8E13}"/>
               </a:ext>
             </a:extLst>
           </p:cNvPr>
@@ -24257,7 +24257,7 @@
           <p:cNvPr id="13" name="c3-text-146">
             <a:extLst xmlns:a="http://schemas.openxmlformats.org/drawingml/2006/main">
               <a:ext uri="{FF2B5EF4-FFF2-40B4-BE49-F238E27FC236}">
-                <a16:creationId xmlns:a16="http://schemas.microsoft.com/office/drawing/2014/main" id="{A8B9C10A-1915-4A21-9BD7-06B26A40A102}"/>
+                <a16:creationId xmlns:a16="http://schemas.microsoft.com/office/drawing/2014/main" id="{724C5262-2C19-42A8-BBE2-632A5C7B3B34}"/>
               </a:ext>
             </a:extLst>
           </p:cNvPr>
@@ -24314,7 +24314,7 @@
           <p:cNvPr id="14" name="c3-shape-147">
             <a:extLst xmlns:a="http://schemas.openxmlformats.org/drawingml/2006/main">
               <a:ext uri="{FF2B5EF4-FFF2-40B4-BE49-F238E27FC236}">
-                <a16:creationId xmlns:a16="http://schemas.microsoft.com/office/drawing/2014/main" id="{D6641B93-2587-48DD-BCBB-5D0115B87712}"/>
+                <a16:creationId xmlns:a16="http://schemas.microsoft.com/office/drawing/2014/main" id="{850C3A5A-248A-4C22-8B07-9EA478964FDE}"/>
               </a:ext>
             </a:extLst>
           </p:cNvPr>
@@ -24348,7 +24348,7 @@
           <p:cNvPr id="15" name="c3-shape-148">
             <a:extLst xmlns:a="http://schemas.openxmlformats.org/drawingml/2006/main">
               <a:ext uri="{FF2B5EF4-FFF2-40B4-BE49-F238E27FC236}">
-                <a16:creationId xmlns:a16="http://schemas.microsoft.com/office/drawing/2014/main" id="{9D4ED62B-8DA9-4B39-9E60-F93BC36CE9A0}"/>
+                <a16:creationId xmlns:a16="http://schemas.microsoft.com/office/drawing/2014/main" id="{9C37A3A4-1A50-40FA-B5A2-E0595F724BDD}"/>
               </a:ext>
             </a:extLst>
           </p:cNvPr>
@@ -24380,7 +24380,7 @@
           <p:cNvPr id="16" name="c3-text-149">
             <a:extLst xmlns:a="http://schemas.openxmlformats.org/drawingml/2006/main">
               <a:ext uri="{FF2B5EF4-FFF2-40B4-BE49-F238E27FC236}">
-                <a16:creationId xmlns:a16="http://schemas.microsoft.com/office/drawing/2014/main" id="{7EFE2FBB-0E4A-4862-BF77-D5A1F942DE9E}"/>
+                <a16:creationId xmlns:a16="http://schemas.microsoft.com/office/drawing/2014/main" id="{1C133EA9-7388-486A-B0E5-2E91C00CEB5C}"/>
               </a:ext>
             </a:extLst>
           </p:cNvPr>
@@ -24437,7 +24437,7 @@
           <p:cNvPr id="17" name="c3-text-150">
             <a:extLst xmlns:a="http://schemas.openxmlformats.org/drawingml/2006/main">
               <a:ext uri="{FF2B5EF4-FFF2-40B4-BE49-F238E27FC236}">
-                <a16:creationId xmlns:a16="http://schemas.microsoft.com/office/drawing/2014/main" id="{CD4EA852-3A5E-43A5-AE67-ECA30C45FA2F}"/>
+                <a16:creationId xmlns:a16="http://schemas.microsoft.com/office/drawing/2014/main" id="{5C459926-8E79-4DF2-974B-F52093FEC745}"/>
               </a:ext>
             </a:extLst>
           </p:cNvPr>
@@ -24494,7 +24494,7 @@
           <p:cNvPr id="18" name="c3-shape-151">
             <a:extLst xmlns:a="http://schemas.openxmlformats.org/drawingml/2006/main">
               <a:ext uri="{FF2B5EF4-FFF2-40B4-BE49-F238E27FC236}">
-                <a16:creationId xmlns:a16="http://schemas.microsoft.com/office/drawing/2014/main" id="{CF4EC6CA-73E7-4267-840A-65A76C3BA55B}"/>
+                <a16:creationId xmlns:a16="http://schemas.microsoft.com/office/drawing/2014/main" id="{54805A26-BEC7-4A86-8F65-63ED81593910}"/>
               </a:ext>
             </a:extLst>
           </p:cNvPr>
@@ -24528,7 +24528,7 @@
           <p:cNvPr id="19" name="c3-shape-152">
             <a:extLst xmlns:a="http://schemas.openxmlformats.org/drawingml/2006/main">
               <a:ext uri="{FF2B5EF4-FFF2-40B4-BE49-F238E27FC236}">
-                <a16:creationId xmlns:a16="http://schemas.microsoft.com/office/drawing/2014/main" id="{E518ECE2-5A33-4E79-BC0F-52256B8ED351}"/>
+                <a16:creationId xmlns:a16="http://schemas.microsoft.com/office/drawing/2014/main" id="{1C01D5F5-2E78-4657-9510-A75182D18B88}"/>
               </a:ext>
             </a:extLst>
           </p:cNvPr>
@@ -24560,7 +24560,7 @@
           <p:cNvPr id="20" name="c3-text-153">
             <a:extLst xmlns:a="http://schemas.openxmlformats.org/drawingml/2006/main">
               <a:ext uri="{FF2B5EF4-FFF2-40B4-BE49-F238E27FC236}">
-                <a16:creationId xmlns:a16="http://schemas.microsoft.com/office/drawing/2014/main" id="{89C0D43A-5F0D-4220-BC5A-E743D16A2D77}"/>
+                <a16:creationId xmlns:a16="http://schemas.microsoft.com/office/drawing/2014/main" id="{72322A83-CF77-4E82-8375-7F9407640363}"/>
               </a:ext>
             </a:extLst>
           </p:cNvPr>
@@ -24617,7 +24617,7 @@
           <p:cNvPr id="21" name="c3-text-154">
             <a:extLst xmlns:a="http://schemas.openxmlformats.org/drawingml/2006/main">
               <a:ext uri="{FF2B5EF4-FFF2-40B4-BE49-F238E27FC236}">
-                <a16:creationId xmlns:a16="http://schemas.microsoft.com/office/drawing/2014/main" id="{FCE3A882-4CE1-41AC-A0F7-D44AC79006B1}"/>
+                <a16:creationId xmlns:a16="http://schemas.microsoft.com/office/drawing/2014/main" id="{68F790DB-0A9B-49F3-B227-9555DE8D5519}"/>
               </a:ext>
             </a:extLst>
           </p:cNvPr>
@@ -24674,7 +24674,7 @@
           <p:cNvPr id="22" name="c3-text-386">
             <a:extLst xmlns:a="http://schemas.openxmlformats.org/drawingml/2006/main">
               <a:ext uri="{FF2B5EF4-FFF2-40B4-BE49-F238E27FC236}">
-                <a16:creationId xmlns:a16="http://schemas.microsoft.com/office/drawing/2014/main" id="{AFC4D721-6DC4-4F13-83BD-9DBE99758BD3}"/>
+                <a16:creationId xmlns:a16="http://schemas.microsoft.com/office/drawing/2014/main" id="{C142E133-03E0-4051-AE8E-0DBABB32BB6D}"/>
               </a:ext>
             </a:extLst>
           </p:cNvPr>
@@ -24729,7 +24729,7 @@
     </p:spTree>
     <p:extLst>
       <p:ext uri="{BB962C8B-B14F-4D97-AF65-F5344CB8AC3E}">
-        <p14:creationId xmlns:p14="http://schemas.microsoft.com/office/powerpoint/2010/main" val="1938162235"/>
+        <p14:creationId xmlns:p14="http://schemas.microsoft.com/office/powerpoint/2010/main" val="334309506"/>
       </p:ext>
     </p:extLst>
   </p:cSld>

</xml_diff>